<commit_message>
docs: update PPT cover and remove numbered titles
</commit_message>
<xml_diff>
--- a/output/SKT_OTDR_선로품질관리시스템_고도화_개발계획서_최종.pptx
+++ b/output/SKT_OTDR_선로품질관리시스템_고도화_개발계획서_최종.pptx
@@ -3194,14 +3194,210 @@
       </p:sp>
       <p:sp>
         <p:nvSpPr>
-          <p:cNvPr id="4" name="TextBox 3"/>
+          <p:cNvPr id="4" name="Rectangle 3"/>
+          <p:cNvSpPr/>
+          <p:nvPr/>
+        </p:nvSpPr>
+        <p:spPr>
+          <a:xfrm>
+            <a:off x="0" y="502920"/>
+            <a:ext cx="12191695" cy="6062472"/>
+          </a:xfrm>
+          <a:prstGeom prst="rect">
+            <a:avLst/>
+          </a:prstGeom>
+          <a:solidFill>
+            <a:srgbClr val="FFFFFF"/>
+          </a:solidFill>
+          <a:ln>
+            <a:noFill/>
+          </a:ln>
+        </p:spPr>
+        <p:style>
+          <a:lnRef idx="1">
+            <a:schemeClr val="accent1"/>
+          </a:lnRef>
+          <a:fillRef idx="3">
+            <a:schemeClr val="accent1"/>
+          </a:fillRef>
+          <a:effectRef idx="2">
+            <a:schemeClr val="accent1"/>
+          </a:effectRef>
+          <a:fontRef idx="minor">
+            <a:schemeClr val="lt1"/>
+          </a:fontRef>
+        </p:style>
+        <p:txBody>
+          <a:bodyPr rtlCol="0" anchor="ctr"/>
+          <a:lstStyle/>
+          <a:p>
+            <a:pPr algn="ctr"/>
+          </a:p>
+        </p:txBody>
+      </p:sp>
+      <p:sp>
+        <p:nvSpPr>
+          <p:cNvPr id="5" name="Rectangle 4"/>
+          <p:cNvSpPr/>
+          <p:nvPr/>
+        </p:nvSpPr>
+        <p:spPr>
+          <a:xfrm>
+            <a:off x="0" y="502920"/>
+            <a:ext cx="3840480" cy="6062472"/>
+          </a:xfrm>
+          <a:prstGeom prst="rect">
+            <a:avLst/>
+          </a:prstGeom>
+          <a:solidFill>
+            <a:srgbClr val="F6F6F8"/>
+          </a:solidFill>
+          <a:ln>
+            <a:noFill/>
+          </a:ln>
+        </p:spPr>
+        <p:style>
+          <a:lnRef idx="1">
+            <a:schemeClr val="accent1"/>
+          </a:lnRef>
+          <a:fillRef idx="3">
+            <a:schemeClr val="accent1"/>
+          </a:fillRef>
+          <a:effectRef idx="2">
+            <a:schemeClr val="accent1"/>
+          </a:effectRef>
+          <a:fontRef idx="minor">
+            <a:schemeClr val="lt1"/>
+          </a:fontRef>
+        </p:style>
+        <p:txBody>
+          <a:bodyPr rtlCol="0" anchor="ctr"/>
+          <a:lstStyle/>
+          <a:p>
+            <a:pPr algn="ctr"/>
+          </a:p>
+        </p:txBody>
+      </p:sp>
+      <p:sp>
+        <p:nvSpPr>
+          <p:cNvPr id="6" name="Chevron 5"/>
+          <p:cNvSpPr/>
+          <p:nvPr/>
+        </p:nvSpPr>
+        <p:spPr>
+          <a:xfrm>
+            <a:off x="8138160" y="868680"/>
+            <a:ext cx="3108960" cy="914400"/>
+          </a:xfrm>
+          <a:prstGeom prst="chevron">
+            <a:avLst/>
+          </a:prstGeom>
+          <a:solidFill>
+            <a:srgbClr val="D63F36"/>
+          </a:solidFill>
+          <a:ln>
+            <a:noFill/>
+          </a:ln>
+        </p:spPr>
+        <p:style>
+          <a:lnRef idx="1">
+            <a:schemeClr val="accent1"/>
+          </a:lnRef>
+          <a:fillRef idx="3">
+            <a:schemeClr val="accent1"/>
+          </a:fillRef>
+          <a:effectRef idx="2">
+            <a:schemeClr val="accent1"/>
+          </a:effectRef>
+          <a:fontRef idx="minor">
+            <a:schemeClr val="lt1"/>
+          </a:fontRef>
+        </p:style>
+        <p:txBody>
+          <a:bodyPr rtlCol="0" anchor="ctr"/>
+          <a:lstStyle/>
+          <a:p>
+            <a:pPr algn="ctr"/>
+          </a:p>
+        </p:txBody>
+      </p:sp>
+      <p:sp>
+        <p:nvSpPr>
+          <p:cNvPr id="7" name="Chevron 6"/>
+          <p:cNvSpPr/>
+          <p:nvPr/>
+        </p:nvSpPr>
+        <p:spPr>
+          <a:xfrm>
+            <a:off x="8869680" y="1417320"/>
+            <a:ext cx="2286000" cy="731520"/>
+          </a:xfrm>
+          <a:prstGeom prst="chevron">
+            <a:avLst/>
+          </a:prstGeom>
+          <a:solidFill>
+            <a:srgbClr val="F4A142"/>
+          </a:solidFill>
+          <a:ln>
+            <a:noFill/>
+          </a:ln>
+        </p:spPr>
+        <p:style>
+          <a:lnRef idx="1">
+            <a:schemeClr val="accent1"/>
+          </a:lnRef>
+          <a:fillRef idx="3">
+            <a:schemeClr val="accent1"/>
+          </a:fillRef>
+          <a:effectRef idx="2">
+            <a:schemeClr val="accent1"/>
+          </a:effectRef>
+          <a:fontRef idx="minor">
+            <a:schemeClr val="lt1"/>
+          </a:fontRef>
+        </p:style>
+        <p:txBody>
+          <a:bodyPr rtlCol="0" anchor="ctr"/>
+          <a:lstStyle/>
+          <a:p>
+            <a:pPr algn="ctr"/>
+          </a:p>
+        </p:txBody>
+      </p:sp>
+      <p:pic>
+        <p:nvPicPr>
+          <p:cNvPr id="8" name="Picture 7" descr="skt_logo.png"/>
+          <p:cNvPicPr>
+            <a:picLocks noChangeAspect="1"/>
+          </p:cNvPicPr>
+          <p:nvPr/>
+        </p:nvPicPr>
+        <p:blipFill>
+          <a:blip r:embed="rId2"/>
+          <a:stretch>
+            <a:fillRect/>
+          </a:stretch>
+        </p:blipFill>
+        <p:spPr>
+          <a:xfrm>
+            <a:off x="640080" y="868680"/>
+            <a:ext cx="2377440" cy="792480"/>
+          </a:xfrm>
+          <a:prstGeom prst="rect">
+            <a:avLst/>
+          </a:prstGeom>
+        </p:spPr>
+      </p:pic>
+      <p:sp>
+        <p:nvSpPr>
+          <p:cNvPr id="9" name="TextBox 8"/>
           <p:cNvSpPr txBox="1"/>
           <p:nvPr/>
         </p:nvSpPr>
         <p:spPr>
           <a:xfrm>
-            <a:off x="731520" y="960120"/>
-            <a:ext cx="6858000" cy="1463040"/>
+            <a:off x="685800" y="1920240"/>
+            <a:ext cx="6766560" cy="2286000"/>
           </a:xfrm>
           <a:prstGeom prst="rect">
             <a:avLst/>
@@ -3220,9 +3416,8 @@
                   <a:srgbClr val="112743"/>
                 </a:solidFill>
               </a:rPr>
-              <a:t>SKT OTDR
-선로품질관리시스템 고도화
-개발 계획서</a:t>
+              <a:t>OTDR 선로품질관리시스템
+고도화 개발 계획서</a:t>
             </a:r>
           </a:p>
           <a:p>
@@ -3234,12 +3429,12 @@
               </a:defRPr>
             </a:pPr>
             <a:r>
-              <a:t>배경: 기간망 OTDR 운영 자동화 및 EMS 연동 고도화</a:t>
+              <a:t>SKT 기간망 선로 품질관리 고도화 및 EMS 연동 확대</a:t>
             </a:r>
           </a:p>
           <a:p>
             <a:pPr>
-              <a:defRPr sz="1400">
+              <a:defRPr sz="1300">
                 <a:solidFill>
                   <a:srgbClr val="292929"/>
                 </a:solidFill>
@@ -3251,7 +3446,7 @@
           </a:p>
           <a:p>
             <a:pPr>
-              <a:defRPr sz="1400">
+              <a:defRPr sz="1300">
                 <a:solidFill>
                   <a:srgbClr val="292929"/>
                 </a:solidFill>
@@ -3265,120 +3460,130 @@
       </p:sp>
       <p:sp>
         <p:nvSpPr>
-          <p:cNvPr id="5" name="Rounded Rectangle 4"/>
-          <p:cNvSpPr/>
-          <p:nvPr/>
-        </p:nvSpPr>
-        <p:spPr>
-          <a:xfrm>
-            <a:off x="8001000" y="1005840"/>
-            <a:ext cx="3291840" cy="4389120"/>
+          <p:cNvPr id="10" name="Rounded Rectangle 9"/>
+          <p:cNvSpPr/>
+          <p:nvPr/>
+        </p:nvSpPr>
+        <p:spPr>
+          <a:xfrm>
+            <a:off x="7818120" y="2743200"/>
+            <a:ext cx="2971800" cy="502920"/>
           </a:xfrm>
           <a:prstGeom prst="roundRect">
             <a:avLst/>
           </a:prstGeom>
           <a:solidFill>
-            <a:srgbClr val="FFFFFF"/>
-          </a:solidFill>
-          <a:ln>
-            <a:solidFill>
-              <a:srgbClr val="D2DBE6"/>
-            </a:solidFill>
-          </a:ln>
-        </p:spPr>
-        <p:style>
-          <a:lnRef idx="1">
-            <a:schemeClr val="accent1"/>
-          </a:lnRef>
-          <a:fillRef idx="3">
-            <a:schemeClr val="accent1"/>
-          </a:fillRef>
-          <a:effectRef idx="2">
-            <a:schemeClr val="accent1"/>
-          </a:effectRef>
-          <a:fontRef idx="minor">
-            <a:schemeClr val="lt1"/>
-          </a:fontRef>
-        </p:style>
-        <p:txBody>
-          <a:bodyPr rtlCol="0" anchor="ctr"/>
-          <a:lstStyle/>
-          <a:p>
-            <a:pPr algn="ctr"/>
-          </a:p>
-        </p:txBody>
-      </p:sp>
-      <p:sp>
-        <p:nvSpPr>
-          <p:cNvPr id="6" name="Rounded Rectangle 5"/>
-          <p:cNvSpPr/>
-          <p:nvPr/>
-        </p:nvSpPr>
-        <p:spPr>
-          <a:xfrm>
-            <a:off x="8321040" y="1325880"/>
-            <a:ext cx="2651760" cy="1051560"/>
+            <a:srgbClr val="245CA5"/>
+          </a:solidFill>
+          <a:ln>
+            <a:solidFill>
+              <a:srgbClr val="245CA5"/>
+            </a:solidFill>
+          </a:ln>
+        </p:spPr>
+        <p:style>
+          <a:lnRef idx="1">
+            <a:schemeClr val="accent1"/>
+          </a:lnRef>
+          <a:fillRef idx="3">
+            <a:schemeClr val="accent1"/>
+          </a:fillRef>
+          <a:effectRef idx="2">
+            <a:schemeClr val="accent1"/>
+          </a:effectRef>
+          <a:fontRef idx="minor">
+            <a:schemeClr val="lt1"/>
+          </a:fontRef>
+        </p:style>
+        <p:txBody>
+          <a:bodyPr rtlCol="0" anchor="ctr"/>
+          <a:lstStyle/>
+          <a:p>
+            <a:pPr algn="ctr"/>
+            <a:r>
+              <a:rPr sz="1200" b="1">
+                <a:solidFill>
+                  <a:srgbClr val="FFFFFF"/>
+                </a:solidFill>
+              </a:rPr>
+              <a:t>HUAWEI/NOKIA EMS 연동</a:t>
+            </a:r>
+          </a:p>
+        </p:txBody>
+      </p:sp>
+      <p:sp>
+        <p:nvSpPr>
+          <p:cNvPr id="11" name="Rounded Rectangle 10"/>
+          <p:cNvSpPr/>
+          <p:nvPr/>
+        </p:nvSpPr>
+        <p:spPr>
+          <a:xfrm>
+            <a:off x="7818120" y="3493008"/>
+            <a:ext cx="2971800" cy="502920"/>
           </a:xfrm>
           <a:prstGeom prst="roundRect">
             <a:avLst/>
           </a:prstGeom>
           <a:solidFill>
-            <a:srgbClr val="D63F36"/>
-          </a:solidFill>
-          <a:ln>
-            <a:noFill/>
-          </a:ln>
-        </p:spPr>
-        <p:style>
-          <a:lnRef idx="1">
-            <a:schemeClr val="accent1"/>
-          </a:lnRef>
-          <a:fillRef idx="3">
-            <a:schemeClr val="accent1"/>
-          </a:fillRef>
-          <a:effectRef idx="2">
-            <a:schemeClr val="accent1"/>
-          </a:effectRef>
-          <a:fontRef idx="minor">
-            <a:schemeClr val="lt1"/>
-          </a:fontRef>
-        </p:style>
-        <p:txBody>
-          <a:bodyPr rtlCol="0" anchor="ctr"/>
-          <a:lstStyle/>
-          <a:p>
-            <a:pPr algn="ctr"/>
-            <a:r>
-              <a:rPr sz="2800" b="1">
+            <a:srgbClr val="359961"/>
+          </a:solidFill>
+          <a:ln>
+            <a:solidFill>
+              <a:srgbClr val="359961"/>
+            </a:solidFill>
+          </a:ln>
+        </p:spPr>
+        <p:style>
+          <a:lnRef idx="1">
+            <a:schemeClr val="accent1"/>
+          </a:lnRef>
+          <a:fillRef idx="3">
+            <a:schemeClr val="accent1"/>
+          </a:fillRef>
+          <a:effectRef idx="2">
+            <a:schemeClr val="accent1"/>
+          </a:effectRef>
+          <a:fontRef idx="minor">
+            <a:schemeClr val="lt1"/>
+          </a:fontRef>
+        </p:style>
+        <p:txBody>
+          <a:bodyPr rtlCol="0" anchor="ctr"/>
+          <a:lstStyle/>
+          <a:p>
+            <a:pPr algn="ctr"/>
+            <a:r>
+              <a:rPr sz="1200" b="1">
                 <a:solidFill>
                   <a:srgbClr val="FFFFFF"/>
                 </a:solidFill>
               </a:rPr>
-              <a:t>SKT</a:t>
-            </a:r>
-          </a:p>
-        </p:txBody>
-      </p:sp>
-      <p:sp>
-        <p:nvSpPr>
-          <p:cNvPr id="7" name="Rounded Rectangle 6"/>
-          <p:cNvSpPr/>
-          <p:nvPr/>
-        </p:nvSpPr>
-        <p:spPr>
-          <a:xfrm>
-            <a:off x="8412480" y="2743200"/>
-            <a:ext cx="2468880" cy="457200"/>
+              <a:t>OTDR 측정 자동화</a:t>
+            </a:r>
+          </a:p>
+        </p:txBody>
+      </p:sp>
+      <p:sp>
+        <p:nvSpPr>
+          <p:cNvPr id="12" name="Rounded Rectangle 11"/>
+          <p:cNvSpPr/>
+          <p:nvPr/>
+        </p:nvSpPr>
+        <p:spPr>
+          <a:xfrm>
+            <a:off x="7818120" y="4242816"/>
+            <a:ext cx="2971800" cy="502920"/>
           </a:xfrm>
           <a:prstGeom prst="roundRect">
             <a:avLst/>
           </a:prstGeom>
           <a:solidFill>
-            <a:srgbClr val="245CA5"/>
-          </a:solidFill>
-          <a:ln>
-            <a:solidFill>
-              <a:srgbClr val="245CA5"/>
+            <a:srgbClr val="7159C1"/>
+          </a:solidFill>
+          <a:ln>
+            <a:solidFill>
+              <a:srgbClr val="7159C1"/>
             </a:solidFill>
           </a:ln>
         </p:spPr>
@@ -3407,113 +3612,7 @@
                   <a:srgbClr val="FFFFFF"/>
                 </a:solidFill>
               </a:rPr>
-              <a:t>기간망 EMS 연동</a:t>
-            </a:r>
-          </a:p>
-        </p:txBody>
-      </p:sp>
-      <p:sp>
-        <p:nvSpPr>
-          <p:cNvPr id="8" name="Rounded Rectangle 7"/>
-          <p:cNvSpPr/>
-          <p:nvPr/>
-        </p:nvSpPr>
-        <p:spPr>
-          <a:xfrm>
-            <a:off x="8412480" y="3401568"/>
-            <a:ext cx="2468880" cy="457200"/>
-          </a:xfrm>
-          <a:prstGeom prst="roundRect">
-            <a:avLst/>
-          </a:prstGeom>
-          <a:solidFill>
-            <a:srgbClr val="359961"/>
-          </a:solidFill>
-          <a:ln>
-            <a:solidFill>
-              <a:srgbClr val="359961"/>
-            </a:solidFill>
-          </a:ln>
-        </p:spPr>
-        <p:style>
-          <a:lnRef idx="1">
-            <a:schemeClr val="accent1"/>
-          </a:lnRef>
-          <a:fillRef idx="3">
-            <a:schemeClr val="accent1"/>
-          </a:fillRef>
-          <a:effectRef idx="2">
-            <a:schemeClr val="accent1"/>
-          </a:effectRef>
-          <a:fontRef idx="minor">
-            <a:schemeClr val="lt1"/>
-          </a:fontRef>
-        </p:style>
-        <p:txBody>
-          <a:bodyPr rtlCol="0" anchor="ctr"/>
-          <a:lstStyle/>
-          <a:p>
-            <a:pPr algn="ctr"/>
-            <a:r>
-              <a:rPr sz="1200" b="1">
-                <a:solidFill>
-                  <a:srgbClr val="FFFFFF"/>
-                </a:solidFill>
-              </a:rPr>
-              <a:t>OTDR 운영 자동화</a:t>
-            </a:r>
-          </a:p>
-        </p:txBody>
-      </p:sp>
-      <p:sp>
-        <p:nvSpPr>
-          <p:cNvPr id="9" name="Rounded Rectangle 8"/>
-          <p:cNvSpPr/>
-          <p:nvPr/>
-        </p:nvSpPr>
-        <p:spPr>
-          <a:xfrm>
-            <a:off x="8412480" y="4059935"/>
-            <a:ext cx="2468880" cy="457200"/>
-          </a:xfrm>
-          <a:prstGeom prst="roundRect">
-            <a:avLst/>
-          </a:prstGeom>
-          <a:solidFill>
-            <a:srgbClr val="7159C1"/>
-          </a:solidFill>
-          <a:ln>
-            <a:solidFill>
-              <a:srgbClr val="7159C1"/>
-            </a:solidFill>
-          </a:ln>
-        </p:spPr>
-        <p:style>
-          <a:lnRef idx="1">
-            <a:schemeClr val="accent1"/>
-          </a:lnRef>
-          <a:fillRef idx="3">
-            <a:schemeClr val="accent1"/>
-          </a:fillRef>
-          <a:effectRef idx="2">
-            <a:schemeClr val="accent1"/>
-          </a:effectRef>
-          <a:fontRef idx="minor">
-            <a:schemeClr val="lt1"/>
-          </a:fontRef>
-        </p:style>
-        <p:txBody>
-          <a:bodyPr rtlCol="0" anchor="ctr"/>
-          <a:lstStyle/>
-          <a:p>
-            <a:pPr algn="ctr"/>
-            <a:r>
-              <a:rPr sz="1200" b="1">
-                <a:solidFill>
-                  <a:srgbClr val="FFFFFF"/>
-                </a:solidFill>
-              </a:rPr>
-              <a:t>품질관리 고도화</a:t>
+              <a:t>결과 분석/보고서 고도화</a:t>
             </a:r>
           </a:p>
         </p:txBody>
@@ -3658,7 +3757,7 @@
                   <a:srgbClr val="112743"/>
                 </a:solidFill>
               </a:rPr>
-              <a:t>10. OTDR 측정 결과 보고서 기능</a:t>
+              <a:t>OTDR 측정 결과 보고서 기능</a:t>
             </a:r>
           </a:p>
           <a:p>
@@ -4776,7 +4875,7 @@
                   <a:srgbClr val="112743"/>
                 </a:solidFill>
               </a:rPr>
-              <a:t>11. 개발 일정</a:t>
+              <a:t>개발 일정</a:t>
             </a:r>
           </a:p>
           <a:p>
@@ -4788,7 +4887,7 @@
               </a:defRPr>
             </a:pPr>
             <a:r>
-              <a:t>기능별 M ~ M+5 진행 일정을 색상으로 표현</a:t>
+              <a:t>doc 폴더의 개발계획서 xlsx 기준 기능별 진행 일정(M ~ M+5)</a:t>
             </a:r>
           </a:p>
         </p:txBody>
@@ -5349,14 +5448,6 @@
           <a:lstStyle/>
           <a:p>
             <a:pPr algn="ctr"/>
-            <a:r>
-              <a:rPr sz="1200" b="1">
-                <a:solidFill>
-                  <a:srgbClr val="FFFFFF"/>
-                </a:solidFill>
-              </a:rPr>
-              <a:t>■</a:t>
-            </a:r>
           </a:p>
         </p:txBody>
       </p:sp>
@@ -5402,14 +5493,6 @@
           <a:lstStyle/>
           <a:p>
             <a:pPr algn="ctr"/>
-            <a:r>
-              <a:rPr sz="1200" b="1">
-                <a:solidFill>
-                  <a:srgbClr val="FFFFFF"/>
-                </a:solidFill>
-              </a:rPr>
-              <a:t>■</a:t>
-            </a:r>
           </a:p>
         </p:txBody>
       </p:sp>
@@ -5455,14 +5538,6 @@
           <a:lstStyle/>
           <a:p>
             <a:pPr algn="ctr"/>
-            <a:r>
-              <a:rPr sz="1200" b="1">
-                <a:solidFill>
-                  <a:srgbClr val="FFFFFF"/>
-                </a:solidFill>
-              </a:rPr>
-              <a:t>■</a:t>
-            </a:r>
           </a:p>
         </p:txBody>
       </p:sp>
@@ -5508,14 +5583,6 @@
           <a:lstStyle/>
           <a:p>
             <a:pPr algn="ctr"/>
-            <a:r>
-              <a:rPr sz="1200" b="1">
-                <a:solidFill>
-                  <a:srgbClr val="FFFFFF"/>
-                </a:solidFill>
-              </a:rPr>
-              <a:t>■</a:t>
-            </a:r>
           </a:p>
         </p:txBody>
       </p:sp>
@@ -5561,14 +5628,6 @@
           <a:lstStyle/>
           <a:p>
             <a:pPr algn="ctr"/>
-            <a:r>
-              <a:rPr sz="1200" b="1">
-                <a:solidFill>
-                  <a:srgbClr val="FFFFFF"/>
-                </a:solidFill>
-              </a:rPr>
-              <a:t>■</a:t>
-            </a:r>
           </a:p>
         </p:txBody>
       </p:sp>
@@ -5614,14 +5673,6 @@
           <a:lstStyle/>
           <a:p>
             <a:pPr algn="ctr"/>
-            <a:r>
-              <a:rPr sz="1200" b="1">
-                <a:solidFill>
-                  <a:srgbClr val="FFFFFF"/>
-                </a:solidFill>
-              </a:rPr>
-              <a:t>■</a:t>
-            </a:r>
           </a:p>
         </p:txBody>
       </p:sp>
@@ -5773,14 +5824,6 @@
           <a:lstStyle/>
           <a:p>
             <a:pPr algn="ctr"/>
-            <a:r>
-              <a:rPr sz="1200" b="1">
-                <a:solidFill>
-                  <a:srgbClr val="FFFFFF"/>
-                </a:solidFill>
-              </a:rPr>
-              <a:t>■</a:t>
-            </a:r>
           </a:p>
         </p:txBody>
       </p:sp>
@@ -5826,14 +5869,6 @@
           <a:lstStyle/>
           <a:p>
             <a:pPr algn="ctr"/>
-            <a:r>
-              <a:rPr sz="1200" b="1">
-                <a:solidFill>
-                  <a:srgbClr val="FFFFFF"/>
-                </a:solidFill>
-              </a:rPr>
-              <a:t>■</a:t>
-            </a:r>
           </a:p>
         </p:txBody>
       </p:sp>
@@ -5879,14 +5914,6 @@
           <a:lstStyle/>
           <a:p>
             <a:pPr algn="ctr"/>
-            <a:r>
-              <a:rPr sz="1200" b="1">
-                <a:solidFill>
-                  <a:srgbClr val="FFFFFF"/>
-                </a:solidFill>
-              </a:rPr>
-              <a:t>■</a:t>
-            </a:r>
           </a:p>
         </p:txBody>
       </p:sp>
@@ -5932,14 +5959,6 @@
           <a:lstStyle/>
           <a:p>
             <a:pPr algn="ctr"/>
-            <a:r>
-              <a:rPr sz="1200" b="1">
-                <a:solidFill>
-                  <a:srgbClr val="FFFFFF"/>
-                </a:solidFill>
-              </a:rPr>
-              <a:t>■</a:t>
-            </a:r>
           </a:p>
         </p:txBody>
       </p:sp>
@@ -5985,14 +6004,6 @@
           <a:lstStyle/>
           <a:p>
             <a:pPr algn="ctr"/>
-            <a:r>
-              <a:rPr sz="1200" b="1">
-                <a:solidFill>
-                  <a:srgbClr val="FFFFFF"/>
-                </a:solidFill>
-              </a:rPr>
-              <a:t>■</a:t>
-            </a:r>
           </a:p>
         </p:txBody>
       </p:sp>
@@ -6038,14 +6049,6 @@
           <a:lstStyle/>
           <a:p>
             <a:pPr algn="ctr"/>
-            <a:r>
-              <a:rPr sz="1200" b="1">
-                <a:solidFill>
-                  <a:srgbClr val="FFFFFF"/>
-                </a:solidFill>
-              </a:rPr>
-              <a:t>■</a:t>
-            </a:r>
           </a:p>
         </p:txBody>
       </p:sp>
@@ -6197,14 +6200,6 @@
           <a:lstStyle/>
           <a:p>
             <a:pPr algn="ctr"/>
-            <a:r>
-              <a:rPr sz="1200" b="1">
-                <a:solidFill>
-                  <a:srgbClr val="FFFFFF"/>
-                </a:solidFill>
-              </a:rPr>
-              <a:t>■</a:t>
-            </a:r>
           </a:p>
         </p:txBody>
       </p:sp>
@@ -6250,14 +6245,6 @@
           <a:lstStyle/>
           <a:p>
             <a:pPr algn="ctr"/>
-            <a:r>
-              <a:rPr sz="1200" b="1">
-                <a:solidFill>
-                  <a:srgbClr val="FFFFFF"/>
-                </a:solidFill>
-              </a:rPr>
-              <a:t>■</a:t>
-            </a:r>
           </a:p>
         </p:txBody>
       </p:sp>
@@ -6303,14 +6290,6 @@
           <a:lstStyle/>
           <a:p>
             <a:pPr algn="ctr"/>
-            <a:r>
-              <a:rPr sz="1200" b="1">
-                <a:solidFill>
-                  <a:srgbClr val="FFFFFF"/>
-                </a:solidFill>
-              </a:rPr>
-              <a:t>■</a:t>
-            </a:r>
           </a:p>
         </p:txBody>
       </p:sp>
@@ -6356,14 +6335,6 @@
           <a:lstStyle/>
           <a:p>
             <a:pPr algn="ctr"/>
-            <a:r>
-              <a:rPr sz="1200" b="1">
-                <a:solidFill>
-                  <a:srgbClr val="FFFFFF"/>
-                </a:solidFill>
-              </a:rPr>
-              <a:t>■</a:t>
-            </a:r>
           </a:p>
         </p:txBody>
       </p:sp>
@@ -6409,14 +6380,6 @@
           <a:lstStyle/>
           <a:p>
             <a:pPr algn="ctr"/>
-            <a:r>
-              <a:rPr sz="1200" b="1">
-                <a:solidFill>
-                  <a:srgbClr val="FFFFFF"/>
-                </a:solidFill>
-              </a:rPr>
-              <a:t>■</a:t>
-            </a:r>
           </a:p>
         </p:txBody>
       </p:sp>
@@ -6462,14 +6425,6 @@
           <a:lstStyle/>
           <a:p>
             <a:pPr algn="ctr"/>
-            <a:r>
-              <a:rPr sz="1200" b="1">
-                <a:solidFill>
-                  <a:srgbClr val="FFFFFF"/>
-                </a:solidFill>
-              </a:rPr>
-              <a:t>■</a:t>
-            </a:r>
           </a:p>
         </p:txBody>
       </p:sp>
@@ -6621,14 +6576,6 @@
           <a:lstStyle/>
           <a:p>
             <a:pPr algn="ctr"/>
-            <a:r>
-              <a:rPr sz="1200" b="1">
-                <a:solidFill>
-                  <a:srgbClr val="FFFFFF"/>
-                </a:solidFill>
-              </a:rPr>
-              <a:t>■</a:t>
-            </a:r>
           </a:p>
         </p:txBody>
       </p:sp>
@@ -6674,14 +6621,6 @@
           <a:lstStyle/>
           <a:p>
             <a:pPr algn="ctr"/>
-            <a:r>
-              <a:rPr sz="1200" b="1">
-                <a:solidFill>
-                  <a:srgbClr val="FFFFFF"/>
-                </a:solidFill>
-              </a:rPr>
-              <a:t>■</a:t>
-            </a:r>
           </a:p>
         </p:txBody>
       </p:sp>
@@ -6727,14 +6666,6 @@
           <a:lstStyle/>
           <a:p>
             <a:pPr algn="ctr"/>
-            <a:r>
-              <a:rPr sz="1200" b="1">
-                <a:solidFill>
-                  <a:srgbClr val="FFFFFF"/>
-                </a:solidFill>
-              </a:rPr>
-              <a:t>■</a:t>
-            </a:r>
           </a:p>
         </p:txBody>
       </p:sp>
@@ -6780,14 +6711,6 @@
           <a:lstStyle/>
           <a:p>
             <a:pPr algn="ctr"/>
-            <a:r>
-              <a:rPr sz="1200" b="1">
-                <a:solidFill>
-                  <a:srgbClr val="FFFFFF"/>
-                </a:solidFill>
-              </a:rPr>
-              <a:t>■</a:t>
-            </a:r>
           </a:p>
         </p:txBody>
       </p:sp>
@@ -6833,14 +6756,6 @@
           <a:lstStyle/>
           <a:p>
             <a:pPr algn="ctr"/>
-            <a:r>
-              <a:rPr sz="1200" b="1">
-                <a:solidFill>
-                  <a:srgbClr val="FFFFFF"/>
-                </a:solidFill>
-              </a:rPr>
-              <a:t>■</a:t>
-            </a:r>
           </a:p>
         </p:txBody>
       </p:sp>
@@ -6886,14 +6801,6 @@
           <a:lstStyle/>
           <a:p>
             <a:pPr algn="ctr"/>
-            <a:r>
-              <a:rPr sz="1200" b="1">
-                <a:solidFill>
-                  <a:srgbClr val="FFFFFF"/>
-                </a:solidFill>
-              </a:rPr>
-              <a:t>■</a:t>
-            </a:r>
           </a:p>
         </p:txBody>
       </p:sp>
@@ -7045,14 +6952,6 @@
           <a:lstStyle/>
           <a:p>
             <a:pPr algn="ctr"/>
-            <a:r>
-              <a:rPr sz="1200" b="1">
-                <a:solidFill>
-                  <a:srgbClr val="FFFFFF"/>
-                </a:solidFill>
-              </a:rPr>
-              <a:t>■</a:t>
-            </a:r>
           </a:p>
         </p:txBody>
       </p:sp>
@@ -7098,14 +6997,6 @@
           <a:lstStyle/>
           <a:p>
             <a:pPr algn="ctr"/>
-            <a:r>
-              <a:rPr sz="1200" b="1">
-                <a:solidFill>
-                  <a:srgbClr val="FFFFFF"/>
-                </a:solidFill>
-              </a:rPr>
-              <a:t>■</a:t>
-            </a:r>
           </a:p>
         </p:txBody>
       </p:sp>
@@ -7151,14 +7042,6 @@
           <a:lstStyle/>
           <a:p>
             <a:pPr algn="ctr"/>
-            <a:r>
-              <a:rPr sz="1200" b="1">
-                <a:solidFill>
-                  <a:srgbClr val="FFFFFF"/>
-                </a:solidFill>
-              </a:rPr>
-              <a:t>■</a:t>
-            </a:r>
           </a:p>
         </p:txBody>
       </p:sp>
@@ -7204,14 +7087,6 @@
           <a:lstStyle/>
           <a:p>
             <a:pPr algn="ctr"/>
-            <a:r>
-              <a:rPr sz="1200" b="1">
-                <a:solidFill>
-                  <a:srgbClr val="FFFFFF"/>
-                </a:solidFill>
-              </a:rPr>
-              <a:t>■</a:t>
-            </a:r>
           </a:p>
         </p:txBody>
       </p:sp>
@@ -7257,14 +7132,6 @@
           <a:lstStyle/>
           <a:p>
             <a:pPr algn="ctr"/>
-            <a:r>
-              <a:rPr sz="1200" b="1">
-                <a:solidFill>
-                  <a:srgbClr val="FFFFFF"/>
-                </a:solidFill>
-              </a:rPr>
-              <a:t>■</a:t>
-            </a:r>
           </a:p>
         </p:txBody>
       </p:sp>
@@ -7310,14 +7177,6 @@
           <a:lstStyle/>
           <a:p>
             <a:pPr algn="ctr"/>
-            <a:r>
-              <a:rPr sz="1200" b="1">
-                <a:solidFill>
-                  <a:srgbClr val="FFFFFF"/>
-                </a:solidFill>
-              </a:rPr>
-              <a:t>■</a:t>
-            </a:r>
           </a:p>
         </p:txBody>
       </p:sp>
@@ -7469,14 +7328,6 @@
           <a:lstStyle/>
           <a:p>
             <a:pPr algn="ctr"/>
-            <a:r>
-              <a:rPr sz="1200" b="1">
-                <a:solidFill>
-                  <a:srgbClr val="FFFFFF"/>
-                </a:solidFill>
-              </a:rPr>
-              <a:t>■</a:t>
-            </a:r>
           </a:p>
         </p:txBody>
       </p:sp>
@@ -7522,14 +7373,6 @@
           <a:lstStyle/>
           <a:p>
             <a:pPr algn="ctr"/>
-            <a:r>
-              <a:rPr sz="1200" b="1">
-                <a:solidFill>
-                  <a:srgbClr val="FFFFFF"/>
-                </a:solidFill>
-              </a:rPr>
-              <a:t>■</a:t>
-            </a:r>
           </a:p>
         </p:txBody>
       </p:sp>
@@ -7575,14 +7418,6 @@
           <a:lstStyle/>
           <a:p>
             <a:pPr algn="ctr"/>
-            <a:r>
-              <a:rPr sz="1200" b="1">
-                <a:solidFill>
-                  <a:srgbClr val="FFFFFF"/>
-                </a:solidFill>
-              </a:rPr>
-              <a:t>■</a:t>
-            </a:r>
           </a:p>
         </p:txBody>
       </p:sp>
@@ -7628,14 +7463,6 @@
           <a:lstStyle/>
           <a:p>
             <a:pPr algn="ctr"/>
-            <a:r>
-              <a:rPr sz="1200" b="1">
-                <a:solidFill>
-                  <a:srgbClr val="FFFFFF"/>
-                </a:solidFill>
-              </a:rPr>
-              <a:t>■</a:t>
-            </a:r>
           </a:p>
         </p:txBody>
       </p:sp>
@@ -7681,14 +7508,6 @@
           <a:lstStyle/>
           <a:p>
             <a:pPr algn="ctr"/>
-            <a:r>
-              <a:rPr sz="1200" b="1">
-                <a:solidFill>
-                  <a:srgbClr val="FFFFFF"/>
-                </a:solidFill>
-              </a:rPr>
-              <a:t>■</a:t>
-            </a:r>
           </a:p>
         </p:txBody>
       </p:sp>
@@ -7734,10 +7553,55 @@
           <a:lstStyle/>
           <a:p>
             <a:pPr algn="ctr"/>
-            <a:r>
-              <a:rPr sz="1200" b="1">
-                <a:solidFill>
-                  <a:srgbClr val="FFFFFF"/>
+          </a:p>
+        </p:txBody>
+      </p:sp>
+      <p:sp>
+        <p:nvSpPr>
+          <p:cNvPr id="61" name="Rounded Rectangle 60"/>
+          <p:cNvSpPr/>
+          <p:nvPr/>
+        </p:nvSpPr>
+        <p:spPr>
+          <a:xfrm>
+            <a:off x="411480" y="4087368"/>
+            <a:ext cx="1298448" cy="347472"/>
+          </a:xfrm>
+          <a:prstGeom prst="roundRect">
+            <a:avLst/>
+          </a:prstGeom>
+          <a:solidFill>
+            <a:srgbClr val="E6EEF8"/>
+          </a:solidFill>
+          <a:ln>
+            <a:solidFill>
+              <a:srgbClr val="D2DBE6"/>
+            </a:solidFill>
+          </a:ln>
+        </p:spPr>
+        <p:style>
+          <a:lnRef idx="1">
+            <a:schemeClr val="accent1"/>
+          </a:lnRef>
+          <a:fillRef idx="3">
+            <a:schemeClr val="accent1"/>
+          </a:fillRef>
+          <a:effectRef idx="2">
+            <a:schemeClr val="accent1"/>
+          </a:effectRef>
+          <a:fontRef idx="minor">
+            <a:schemeClr val="lt1"/>
+          </a:fontRef>
+        </p:style>
+        <p:txBody>
+          <a:bodyPr rtlCol="0" anchor="ctr"/>
+          <a:lstStyle/>
+          <a:p>
+            <a:pPr algn="ctr"/>
+            <a:r>
+              <a:rPr sz="950" b="0">
+                <a:solidFill>
+                  <a:srgbClr val="292929"/>
                 </a:solidFill>
               </a:rPr>
               <a:t/>
@@ -7747,13 +7611,712 @@
       </p:sp>
       <p:sp>
         <p:nvSpPr>
-          <p:cNvPr id="61" name="Rounded Rectangle 60"/>
-          <p:cNvSpPr/>
-          <p:nvPr/>
-        </p:nvSpPr>
-        <p:spPr>
-          <a:xfrm>
-            <a:off x="411480" y="4087368"/>
+          <p:cNvPr id="62" name="Rounded Rectangle 61"/>
+          <p:cNvSpPr/>
+          <p:nvPr/>
+        </p:nvSpPr>
+        <p:spPr>
+          <a:xfrm>
+            <a:off x="1737360" y="4087368"/>
+            <a:ext cx="3721607" cy="347472"/>
+          </a:xfrm>
+          <a:prstGeom prst="roundRect">
+            <a:avLst/>
+          </a:prstGeom>
+          <a:solidFill>
+            <a:srgbClr val="FFFFFF"/>
+          </a:solidFill>
+          <a:ln>
+            <a:solidFill>
+              <a:srgbClr val="D2DBE6"/>
+            </a:solidFill>
+          </a:ln>
+        </p:spPr>
+        <p:style>
+          <a:lnRef idx="1">
+            <a:schemeClr val="accent1"/>
+          </a:lnRef>
+          <a:fillRef idx="3">
+            <a:schemeClr val="accent1"/>
+          </a:fillRef>
+          <a:effectRef idx="2">
+            <a:schemeClr val="accent1"/>
+          </a:effectRef>
+          <a:fontRef idx="minor">
+            <a:schemeClr val="lt1"/>
+          </a:fontRef>
+        </p:style>
+        <p:txBody>
+          <a:bodyPr rtlCol="0" anchor="ctr"/>
+          <a:lstStyle/>
+          <a:p>
+            <a:pPr algn="l"/>
+            <a:r>
+              <a:rPr sz="950" b="0">
+                <a:solidFill>
+                  <a:srgbClr val="292929"/>
+                </a:solidFill>
+              </a:rPr>
+              <a:t>GIS 선번 정보 연동 기능</a:t>
+            </a:r>
+          </a:p>
+        </p:txBody>
+      </p:sp>
+      <p:sp>
+        <p:nvSpPr>
+          <p:cNvPr id="63" name="Rounded Rectangle 62"/>
+          <p:cNvSpPr/>
+          <p:nvPr/>
+        </p:nvSpPr>
+        <p:spPr>
+          <a:xfrm>
+            <a:off x="5486400" y="4087368"/>
+            <a:ext cx="841247" cy="347472"/>
+          </a:xfrm>
+          <a:prstGeom prst="roundRect">
+            <a:avLst/>
+          </a:prstGeom>
+          <a:solidFill>
+            <a:srgbClr val="245CA5"/>
+          </a:solidFill>
+          <a:ln>
+            <a:solidFill>
+              <a:srgbClr val="D2DBE6"/>
+            </a:solidFill>
+          </a:ln>
+        </p:spPr>
+        <p:style>
+          <a:lnRef idx="1">
+            <a:schemeClr val="accent1"/>
+          </a:lnRef>
+          <a:fillRef idx="3">
+            <a:schemeClr val="accent1"/>
+          </a:fillRef>
+          <a:effectRef idx="2">
+            <a:schemeClr val="accent1"/>
+          </a:effectRef>
+          <a:fontRef idx="minor">
+            <a:schemeClr val="lt1"/>
+          </a:fontRef>
+        </p:style>
+        <p:txBody>
+          <a:bodyPr rtlCol="0" anchor="ctr"/>
+          <a:lstStyle/>
+          <a:p>
+            <a:pPr algn="ctr"/>
+          </a:p>
+        </p:txBody>
+      </p:sp>
+      <p:sp>
+        <p:nvSpPr>
+          <p:cNvPr id="64" name="Rounded Rectangle 63"/>
+          <p:cNvSpPr/>
+          <p:nvPr/>
+        </p:nvSpPr>
+        <p:spPr>
+          <a:xfrm>
+            <a:off x="6355080" y="4087368"/>
+            <a:ext cx="841247" cy="347472"/>
+          </a:xfrm>
+          <a:prstGeom prst="roundRect">
+            <a:avLst/>
+          </a:prstGeom>
+          <a:solidFill>
+            <a:srgbClr val="4FA4E3"/>
+          </a:solidFill>
+          <a:ln>
+            <a:solidFill>
+              <a:srgbClr val="D2DBE6"/>
+            </a:solidFill>
+          </a:ln>
+        </p:spPr>
+        <p:style>
+          <a:lnRef idx="1">
+            <a:schemeClr val="accent1"/>
+          </a:lnRef>
+          <a:fillRef idx="3">
+            <a:schemeClr val="accent1"/>
+          </a:fillRef>
+          <a:effectRef idx="2">
+            <a:schemeClr val="accent1"/>
+          </a:effectRef>
+          <a:fontRef idx="minor">
+            <a:schemeClr val="lt1"/>
+          </a:fontRef>
+        </p:style>
+        <p:txBody>
+          <a:bodyPr rtlCol="0" anchor="ctr"/>
+          <a:lstStyle/>
+          <a:p>
+            <a:pPr algn="ctr"/>
+          </a:p>
+        </p:txBody>
+      </p:sp>
+      <p:sp>
+        <p:nvSpPr>
+          <p:cNvPr id="65" name="Rounded Rectangle 64"/>
+          <p:cNvSpPr/>
+          <p:nvPr/>
+        </p:nvSpPr>
+        <p:spPr>
+          <a:xfrm>
+            <a:off x="7223760" y="4087368"/>
+            <a:ext cx="841247" cy="347472"/>
+          </a:xfrm>
+          <a:prstGeom prst="roundRect">
+            <a:avLst/>
+          </a:prstGeom>
+          <a:solidFill>
+            <a:srgbClr val="359961"/>
+          </a:solidFill>
+          <a:ln>
+            <a:solidFill>
+              <a:srgbClr val="D2DBE6"/>
+            </a:solidFill>
+          </a:ln>
+        </p:spPr>
+        <p:style>
+          <a:lnRef idx="1">
+            <a:schemeClr val="accent1"/>
+          </a:lnRef>
+          <a:fillRef idx="3">
+            <a:schemeClr val="accent1"/>
+          </a:fillRef>
+          <a:effectRef idx="2">
+            <a:schemeClr val="accent1"/>
+          </a:effectRef>
+          <a:fontRef idx="minor">
+            <a:schemeClr val="lt1"/>
+          </a:fontRef>
+        </p:style>
+        <p:txBody>
+          <a:bodyPr rtlCol="0" anchor="ctr"/>
+          <a:lstStyle/>
+          <a:p>
+            <a:pPr algn="ctr"/>
+          </a:p>
+        </p:txBody>
+      </p:sp>
+      <p:sp>
+        <p:nvSpPr>
+          <p:cNvPr id="66" name="Rounded Rectangle 65"/>
+          <p:cNvSpPr/>
+          <p:nvPr/>
+        </p:nvSpPr>
+        <p:spPr>
+          <a:xfrm>
+            <a:off x="8092440" y="4087368"/>
+            <a:ext cx="841247" cy="347472"/>
+          </a:xfrm>
+          <a:prstGeom prst="roundRect">
+            <a:avLst/>
+          </a:prstGeom>
+          <a:solidFill>
+            <a:srgbClr val="7159C1"/>
+          </a:solidFill>
+          <a:ln>
+            <a:solidFill>
+              <a:srgbClr val="D2DBE6"/>
+            </a:solidFill>
+          </a:ln>
+        </p:spPr>
+        <p:style>
+          <a:lnRef idx="1">
+            <a:schemeClr val="accent1"/>
+          </a:lnRef>
+          <a:fillRef idx="3">
+            <a:schemeClr val="accent1"/>
+          </a:fillRef>
+          <a:effectRef idx="2">
+            <a:schemeClr val="accent1"/>
+          </a:effectRef>
+          <a:fontRef idx="minor">
+            <a:schemeClr val="lt1"/>
+          </a:fontRef>
+        </p:style>
+        <p:txBody>
+          <a:bodyPr rtlCol="0" anchor="ctr"/>
+          <a:lstStyle/>
+          <a:p>
+            <a:pPr algn="ctr"/>
+          </a:p>
+        </p:txBody>
+      </p:sp>
+      <p:sp>
+        <p:nvSpPr>
+          <p:cNvPr id="67" name="Rounded Rectangle 66"/>
+          <p:cNvSpPr/>
+          <p:nvPr/>
+        </p:nvSpPr>
+        <p:spPr>
+          <a:xfrm>
+            <a:off x="8961119" y="4087368"/>
+            <a:ext cx="841247" cy="347472"/>
+          </a:xfrm>
+          <a:prstGeom prst="roundRect">
+            <a:avLst/>
+          </a:prstGeom>
+          <a:solidFill>
+            <a:srgbClr val="F4A142"/>
+          </a:solidFill>
+          <a:ln>
+            <a:solidFill>
+              <a:srgbClr val="D2DBE6"/>
+            </a:solidFill>
+          </a:ln>
+        </p:spPr>
+        <p:style>
+          <a:lnRef idx="1">
+            <a:schemeClr val="accent1"/>
+          </a:lnRef>
+          <a:fillRef idx="3">
+            <a:schemeClr val="accent1"/>
+          </a:fillRef>
+          <a:effectRef idx="2">
+            <a:schemeClr val="accent1"/>
+          </a:effectRef>
+          <a:fontRef idx="minor">
+            <a:schemeClr val="lt1"/>
+          </a:fontRef>
+        </p:style>
+        <p:txBody>
+          <a:bodyPr rtlCol="0" anchor="ctr"/>
+          <a:lstStyle/>
+          <a:p>
+            <a:pPr algn="ctr"/>
+          </a:p>
+        </p:txBody>
+      </p:sp>
+      <p:sp>
+        <p:nvSpPr>
+          <p:cNvPr id="68" name="Rounded Rectangle 67"/>
+          <p:cNvSpPr/>
+          <p:nvPr/>
+        </p:nvSpPr>
+        <p:spPr>
+          <a:xfrm>
+            <a:off x="9829799" y="4087368"/>
+            <a:ext cx="841247" cy="347472"/>
+          </a:xfrm>
+          <a:prstGeom prst="roundRect">
+            <a:avLst/>
+          </a:prstGeom>
+          <a:solidFill>
+            <a:srgbClr val="D63F36"/>
+          </a:solidFill>
+          <a:ln>
+            <a:solidFill>
+              <a:srgbClr val="D2DBE6"/>
+            </a:solidFill>
+          </a:ln>
+        </p:spPr>
+        <p:style>
+          <a:lnRef idx="1">
+            <a:schemeClr val="accent1"/>
+          </a:lnRef>
+          <a:fillRef idx="3">
+            <a:schemeClr val="accent1"/>
+          </a:fillRef>
+          <a:effectRef idx="2">
+            <a:schemeClr val="accent1"/>
+          </a:effectRef>
+          <a:fontRef idx="minor">
+            <a:schemeClr val="lt1"/>
+          </a:fontRef>
+        </p:style>
+        <p:txBody>
+          <a:bodyPr rtlCol="0" anchor="ctr"/>
+          <a:lstStyle/>
+          <a:p>
+            <a:pPr algn="ctr"/>
+          </a:p>
+        </p:txBody>
+      </p:sp>
+      <p:sp>
+        <p:nvSpPr>
+          <p:cNvPr id="69" name="Rounded Rectangle 68"/>
+          <p:cNvSpPr/>
+          <p:nvPr/>
+        </p:nvSpPr>
+        <p:spPr>
+          <a:xfrm>
+            <a:off x="411480" y="4471416"/>
+            <a:ext cx="1298448" cy="347472"/>
+          </a:xfrm>
+          <a:prstGeom prst="roundRect">
+            <a:avLst/>
+          </a:prstGeom>
+          <a:solidFill>
+            <a:srgbClr val="E6EEF8"/>
+          </a:solidFill>
+          <a:ln>
+            <a:solidFill>
+              <a:srgbClr val="D2DBE6"/>
+            </a:solidFill>
+          </a:ln>
+        </p:spPr>
+        <p:style>
+          <a:lnRef idx="1">
+            <a:schemeClr val="accent1"/>
+          </a:lnRef>
+          <a:fillRef idx="3">
+            <a:schemeClr val="accent1"/>
+          </a:fillRef>
+          <a:effectRef idx="2">
+            <a:schemeClr val="accent1"/>
+          </a:effectRef>
+          <a:fontRef idx="minor">
+            <a:schemeClr val="lt1"/>
+          </a:fontRef>
+        </p:style>
+        <p:txBody>
+          <a:bodyPr rtlCol="0" anchor="ctr"/>
+          <a:lstStyle/>
+          <a:p>
+            <a:pPr algn="ctr"/>
+            <a:r>
+              <a:rPr sz="950" b="1">
+                <a:solidFill>
+                  <a:srgbClr val="292929"/>
+                </a:solidFill>
+              </a:rPr>
+              <a:t>NOKIA 자동점검</a:t>
+            </a:r>
+          </a:p>
+        </p:txBody>
+      </p:sp>
+      <p:sp>
+        <p:nvSpPr>
+          <p:cNvPr id="70" name="Rounded Rectangle 69"/>
+          <p:cNvSpPr/>
+          <p:nvPr/>
+        </p:nvSpPr>
+        <p:spPr>
+          <a:xfrm>
+            <a:off x="1737360" y="4471416"/>
+            <a:ext cx="3721607" cy="347472"/>
+          </a:xfrm>
+          <a:prstGeom prst="roundRect">
+            <a:avLst/>
+          </a:prstGeom>
+          <a:solidFill>
+            <a:srgbClr val="FFFFFF"/>
+          </a:solidFill>
+          <a:ln>
+            <a:solidFill>
+              <a:srgbClr val="D2DBE6"/>
+            </a:solidFill>
+          </a:ln>
+        </p:spPr>
+        <p:style>
+          <a:lnRef idx="1">
+            <a:schemeClr val="accent1"/>
+          </a:lnRef>
+          <a:fillRef idx="3">
+            <a:schemeClr val="accent1"/>
+          </a:fillRef>
+          <a:effectRef idx="2">
+            <a:schemeClr val="accent1"/>
+          </a:effectRef>
+          <a:fontRef idx="minor">
+            <a:schemeClr val="lt1"/>
+          </a:fontRef>
+        </p:style>
+        <p:txBody>
+          <a:bodyPr rtlCol="0" anchor="ctr"/>
+          <a:lstStyle/>
+          <a:p>
+            <a:pPr algn="l"/>
+            <a:r>
+              <a:rPr sz="950" b="0">
+                <a:solidFill>
+                  <a:srgbClr val="292929"/>
+                </a:solidFill>
+              </a:rPr>
+              <a:t>NOKIA OTDR Event 연동 기능</a:t>
+            </a:r>
+          </a:p>
+        </p:txBody>
+      </p:sp>
+      <p:sp>
+        <p:nvSpPr>
+          <p:cNvPr id="71" name="Rounded Rectangle 70"/>
+          <p:cNvSpPr/>
+          <p:nvPr/>
+        </p:nvSpPr>
+        <p:spPr>
+          <a:xfrm>
+            <a:off x="5486400" y="4471416"/>
+            <a:ext cx="841247" cy="347472"/>
+          </a:xfrm>
+          <a:prstGeom prst="roundRect">
+            <a:avLst/>
+          </a:prstGeom>
+          <a:solidFill>
+            <a:srgbClr val="245CA5"/>
+          </a:solidFill>
+          <a:ln>
+            <a:solidFill>
+              <a:srgbClr val="D2DBE6"/>
+            </a:solidFill>
+          </a:ln>
+        </p:spPr>
+        <p:style>
+          <a:lnRef idx="1">
+            <a:schemeClr val="accent1"/>
+          </a:lnRef>
+          <a:fillRef idx="3">
+            <a:schemeClr val="accent1"/>
+          </a:fillRef>
+          <a:effectRef idx="2">
+            <a:schemeClr val="accent1"/>
+          </a:effectRef>
+          <a:fontRef idx="minor">
+            <a:schemeClr val="lt1"/>
+          </a:fontRef>
+        </p:style>
+        <p:txBody>
+          <a:bodyPr rtlCol="0" anchor="ctr"/>
+          <a:lstStyle/>
+          <a:p>
+            <a:pPr algn="ctr"/>
+          </a:p>
+        </p:txBody>
+      </p:sp>
+      <p:sp>
+        <p:nvSpPr>
+          <p:cNvPr id="72" name="Rounded Rectangle 71"/>
+          <p:cNvSpPr/>
+          <p:nvPr/>
+        </p:nvSpPr>
+        <p:spPr>
+          <a:xfrm>
+            <a:off x="6355080" y="4471416"/>
+            <a:ext cx="841247" cy="347472"/>
+          </a:xfrm>
+          <a:prstGeom prst="roundRect">
+            <a:avLst/>
+          </a:prstGeom>
+          <a:solidFill>
+            <a:srgbClr val="4FA4E3"/>
+          </a:solidFill>
+          <a:ln>
+            <a:solidFill>
+              <a:srgbClr val="D2DBE6"/>
+            </a:solidFill>
+          </a:ln>
+        </p:spPr>
+        <p:style>
+          <a:lnRef idx="1">
+            <a:schemeClr val="accent1"/>
+          </a:lnRef>
+          <a:fillRef idx="3">
+            <a:schemeClr val="accent1"/>
+          </a:fillRef>
+          <a:effectRef idx="2">
+            <a:schemeClr val="accent1"/>
+          </a:effectRef>
+          <a:fontRef idx="minor">
+            <a:schemeClr val="lt1"/>
+          </a:fontRef>
+        </p:style>
+        <p:txBody>
+          <a:bodyPr rtlCol="0" anchor="ctr"/>
+          <a:lstStyle/>
+          <a:p>
+            <a:pPr algn="ctr"/>
+          </a:p>
+        </p:txBody>
+      </p:sp>
+      <p:sp>
+        <p:nvSpPr>
+          <p:cNvPr id="73" name="Rounded Rectangle 72"/>
+          <p:cNvSpPr/>
+          <p:nvPr/>
+        </p:nvSpPr>
+        <p:spPr>
+          <a:xfrm>
+            <a:off x="7223760" y="4471416"/>
+            <a:ext cx="841247" cy="347472"/>
+          </a:xfrm>
+          <a:prstGeom prst="roundRect">
+            <a:avLst/>
+          </a:prstGeom>
+          <a:solidFill>
+            <a:srgbClr val="359961"/>
+          </a:solidFill>
+          <a:ln>
+            <a:solidFill>
+              <a:srgbClr val="D2DBE6"/>
+            </a:solidFill>
+          </a:ln>
+        </p:spPr>
+        <p:style>
+          <a:lnRef idx="1">
+            <a:schemeClr val="accent1"/>
+          </a:lnRef>
+          <a:fillRef idx="3">
+            <a:schemeClr val="accent1"/>
+          </a:fillRef>
+          <a:effectRef idx="2">
+            <a:schemeClr val="accent1"/>
+          </a:effectRef>
+          <a:fontRef idx="minor">
+            <a:schemeClr val="lt1"/>
+          </a:fontRef>
+        </p:style>
+        <p:txBody>
+          <a:bodyPr rtlCol="0" anchor="ctr"/>
+          <a:lstStyle/>
+          <a:p>
+            <a:pPr algn="ctr"/>
+          </a:p>
+        </p:txBody>
+      </p:sp>
+      <p:sp>
+        <p:nvSpPr>
+          <p:cNvPr id="74" name="Rounded Rectangle 73"/>
+          <p:cNvSpPr/>
+          <p:nvPr/>
+        </p:nvSpPr>
+        <p:spPr>
+          <a:xfrm>
+            <a:off x="8092440" y="4471416"/>
+            <a:ext cx="841247" cy="347472"/>
+          </a:xfrm>
+          <a:prstGeom prst="roundRect">
+            <a:avLst/>
+          </a:prstGeom>
+          <a:solidFill>
+            <a:srgbClr val="7159C1"/>
+          </a:solidFill>
+          <a:ln>
+            <a:solidFill>
+              <a:srgbClr val="D2DBE6"/>
+            </a:solidFill>
+          </a:ln>
+        </p:spPr>
+        <p:style>
+          <a:lnRef idx="1">
+            <a:schemeClr val="accent1"/>
+          </a:lnRef>
+          <a:fillRef idx="3">
+            <a:schemeClr val="accent1"/>
+          </a:fillRef>
+          <a:effectRef idx="2">
+            <a:schemeClr val="accent1"/>
+          </a:effectRef>
+          <a:fontRef idx="minor">
+            <a:schemeClr val="lt1"/>
+          </a:fontRef>
+        </p:style>
+        <p:txBody>
+          <a:bodyPr rtlCol="0" anchor="ctr"/>
+          <a:lstStyle/>
+          <a:p>
+            <a:pPr algn="ctr"/>
+          </a:p>
+        </p:txBody>
+      </p:sp>
+      <p:sp>
+        <p:nvSpPr>
+          <p:cNvPr id="75" name="Rounded Rectangle 74"/>
+          <p:cNvSpPr/>
+          <p:nvPr/>
+        </p:nvSpPr>
+        <p:spPr>
+          <a:xfrm>
+            <a:off x="8961119" y="4471416"/>
+            <a:ext cx="841247" cy="347472"/>
+          </a:xfrm>
+          <a:prstGeom prst="roundRect">
+            <a:avLst/>
+          </a:prstGeom>
+          <a:solidFill>
+            <a:srgbClr val="F4A142"/>
+          </a:solidFill>
+          <a:ln>
+            <a:solidFill>
+              <a:srgbClr val="D2DBE6"/>
+            </a:solidFill>
+          </a:ln>
+        </p:spPr>
+        <p:style>
+          <a:lnRef idx="1">
+            <a:schemeClr val="accent1"/>
+          </a:lnRef>
+          <a:fillRef idx="3">
+            <a:schemeClr val="accent1"/>
+          </a:fillRef>
+          <a:effectRef idx="2">
+            <a:schemeClr val="accent1"/>
+          </a:effectRef>
+          <a:fontRef idx="minor">
+            <a:schemeClr val="lt1"/>
+          </a:fontRef>
+        </p:style>
+        <p:txBody>
+          <a:bodyPr rtlCol="0" anchor="ctr"/>
+          <a:lstStyle/>
+          <a:p>
+            <a:pPr algn="ctr"/>
+          </a:p>
+        </p:txBody>
+      </p:sp>
+      <p:sp>
+        <p:nvSpPr>
+          <p:cNvPr id="76" name="Rounded Rectangle 75"/>
+          <p:cNvSpPr/>
+          <p:nvPr/>
+        </p:nvSpPr>
+        <p:spPr>
+          <a:xfrm>
+            <a:off x="9829799" y="4471416"/>
+            <a:ext cx="841247" cy="347472"/>
+          </a:xfrm>
+          <a:prstGeom prst="roundRect">
+            <a:avLst/>
+          </a:prstGeom>
+          <a:solidFill>
+            <a:srgbClr val="D63F36"/>
+          </a:solidFill>
+          <a:ln>
+            <a:solidFill>
+              <a:srgbClr val="D2DBE6"/>
+            </a:solidFill>
+          </a:ln>
+        </p:spPr>
+        <p:style>
+          <a:lnRef idx="1">
+            <a:schemeClr val="accent1"/>
+          </a:lnRef>
+          <a:fillRef idx="3">
+            <a:schemeClr val="accent1"/>
+          </a:fillRef>
+          <a:effectRef idx="2">
+            <a:schemeClr val="accent1"/>
+          </a:effectRef>
+          <a:fontRef idx="minor">
+            <a:schemeClr val="lt1"/>
+          </a:fontRef>
+        </p:style>
+        <p:txBody>
+          <a:bodyPr rtlCol="0" anchor="ctr"/>
+          <a:lstStyle/>
+          <a:p>
+            <a:pPr algn="ctr"/>
+          </a:p>
+        </p:txBody>
+      </p:sp>
+      <p:sp>
+        <p:nvSpPr>
+          <p:cNvPr id="77" name="Rounded Rectangle 76"/>
+          <p:cNvSpPr/>
+          <p:nvPr/>
+        </p:nvSpPr>
+        <p:spPr>
+          <a:xfrm>
+            <a:off x="411480" y="4855464"/>
             <a:ext cx="1298448" cy="347472"/>
           </a:xfrm>
           <a:prstGeom prst="roundRect">
@@ -7800,854 +8363,6 @@
       </p:sp>
       <p:sp>
         <p:nvSpPr>
-          <p:cNvPr id="62" name="Rounded Rectangle 61"/>
-          <p:cNvSpPr/>
-          <p:nvPr/>
-        </p:nvSpPr>
-        <p:spPr>
-          <a:xfrm>
-            <a:off x="1737360" y="4087368"/>
-            <a:ext cx="3721607" cy="347472"/>
-          </a:xfrm>
-          <a:prstGeom prst="roundRect">
-            <a:avLst/>
-          </a:prstGeom>
-          <a:solidFill>
-            <a:srgbClr val="FFFFFF"/>
-          </a:solidFill>
-          <a:ln>
-            <a:solidFill>
-              <a:srgbClr val="D2DBE6"/>
-            </a:solidFill>
-          </a:ln>
-        </p:spPr>
-        <p:style>
-          <a:lnRef idx="1">
-            <a:schemeClr val="accent1"/>
-          </a:lnRef>
-          <a:fillRef idx="3">
-            <a:schemeClr val="accent1"/>
-          </a:fillRef>
-          <a:effectRef idx="2">
-            <a:schemeClr val="accent1"/>
-          </a:effectRef>
-          <a:fontRef idx="minor">
-            <a:schemeClr val="lt1"/>
-          </a:fontRef>
-        </p:style>
-        <p:txBody>
-          <a:bodyPr rtlCol="0" anchor="ctr"/>
-          <a:lstStyle/>
-          <a:p>
-            <a:pPr algn="l"/>
-            <a:r>
-              <a:rPr sz="950" b="0">
-                <a:solidFill>
-                  <a:srgbClr val="292929"/>
-                </a:solidFill>
-              </a:rPr>
-              <a:t>GIS 선번 정보 연동 기능</a:t>
-            </a:r>
-          </a:p>
-        </p:txBody>
-      </p:sp>
-      <p:sp>
-        <p:nvSpPr>
-          <p:cNvPr id="63" name="Rounded Rectangle 62"/>
-          <p:cNvSpPr/>
-          <p:nvPr/>
-        </p:nvSpPr>
-        <p:spPr>
-          <a:xfrm>
-            <a:off x="5486400" y="4087368"/>
-            <a:ext cx="841247" cy="347472"/>
-          </a:xfrm>
-          <a:prstGeom prst="roundRect">
-            <a:avLst/>
-          </a:prstGeom>
-          <a:solidFill>
-            <a:srgbClr val="245CA5"/>
-          </a:solidFill>
-          <a:ln>
-            <a:solidFill>
-              <a:srgbClr val="D2DBE6"/>
-            </a:solidFill>
-          </a:ln>
-        </p:spPr>
-        <p:style>
-          <a:lnRef idx="1">
-            <a:schemeClr val="accent1"/>
-          </a:lnRef>
-          <a:fillRef idx="3">
-            <a:schemeClr val="accent1"/>
-          </a:fillRef>
-          <a:effectRef idx="2">
-            <a:schemeClr val="accent1"/>
-          </a:effectRef>
-          <a:fontRef idx="minor">
-            <a:schemeClr val="lt1"/>
-          </a:fontRef>
-        </p:style>
-        <p:txBody>
-          <a:bodyPr rtlCol="0" anchor="ctr"/>
-          <a:lstStyle/>
-          <a:p>
-            <a:pPr algn="ctr"/>
-            <a:r>
-              <a:rPr sz="1200" b="1">
-                <a:solidFill>
-                  <a:srgbClr val="FFFFFF"/>
-                </a:solidFill>
-              </a:rPr>
-              <a:t>■</a:t>
-            </a:r>
-          </a:p>
-        </p:txBody>
-      </p:sp>
-      <p:sp>
-        <p:nvSpPr>
-          <p:cNvPr id="64" name="Rounded Rectangle 63"/>
-          <p:cNvSpPr/>
-          <p:nvPr/>
-        </p:nvSpPr>
-        <p:spPr>
-          <a:xfrm>
-            <a:off x="6355080" y="4087368"/>
-            <a:ext cx="841247" cy="347472"/>
-          </a:xfrm>
-          <a:prstGeom prst="roundRect">
-            <a:avLst/>
-          </a:prstGeom>
-          <a:solidFill>
-            <a:srgbClr val="4FA4E3"/>
-          </a:solidFill>
-          <a:ln>
-            <a:solidFill>
-              <a:srgbClr val="D2DBE6"/>
-            </a:solidFill>
-          </a:ln>
-        </p:spPr>
-        <p:style>
-          <a:lnRef idx="1">
-            <a:schemeClr val="accent1"/>
-          </a:lnRef>
-          <a:fillRef idx="3">
-            <a:schemeClr val="accent1"/>
-          </a:fillRef>
-          <a:effectRef idx="2">
-            <a:schemeClr val="accent1"/>
-          </a:effectRef>
-          <a:fontRef idx="minor">
-            <a:schemeClr val="lt1"/>
-          </a:fontRef>
-        </p:style>
-        <p:txBody>
-          <a:bodyPr rtlCol="0" anchor="ctr"/>
-          <a:lstStyle/>
-          <a:p>
-            <a:pPr algn="ctr"/>
-            <a:r>
-              <a:rPr sz="1200" b="1">
-                <a:solidFill>
-                  <a:srgbClr val="FFFFFF"/>
-                </a:solidFill>
-              </a:rPr>
-              <a:t>■</a:t>
-            </a:r>
-          </a:p>
-        </p:txBody>
-      </p:sp>
-      <p:sp>
-        <p:nvSpPr>
-          <p:cNvPr id="65" name="Rounded Rectangle 64"/>
-          <p:cNvSpPr/>
-          <p:nvPr/>
-        </p:nvSpPr>
-        <p:spPr>
-          <a:xfrm>
-            <a:off x="7223760" y="4087368"/>
-            <a:ext cx="841247" cy="347472"/>
-          </a:xfrm>
-          <a:prstGeom prst="roundRect">
-            <a:avLst/>
-          </a:prstGeom>
-          <a:solidFill>
-            <a:srgbClr val="359961"/>
-          </a:solidFill>
-          <a:ln>
-            <a:solidFill>
-              <a:srgbClr val="D2DBE6"/>
-            </a:solidFill>
-          </a:ln>
-        </p:spPr>
-        <p:style>
-          <a:lnRef idx="1">
-            <a:schemeClr val="accent1"/>
-          </a:lnRef>
-          <a:fillRef idx="3">
-            <a:schemeClr val="accent1"/>
-          </a:fillRef>
-          <a:effectRef idx="2">
-            <a:schemeClr val="accent1"/>
-          </a:effectRef>
-          <a:fontRef idx="minor">
-            <a:schemeClr val="lt1"/>
-          </a:fontRef>
-        </p:style>
-        <p:txBody>
-          <a:bodyPr rtlCol="0" anchor="ctr"/>
-          <a:lstStyle/>
-          <a:p>
-            <a:pPr algn="ctr"/>
-            <a:r>
-              <a:rPr sz="1200" b="1">
-                <a:solidFill>
-                  <a:srgbClr val="FFFFFF"/>
-                </a:solidFill>
-              </a:rPr>
-              <a:t>■</a:t>
-            </a:r>
-          </a:p>
-        </p:txBody>
-      </p:sp>
-      <p:sp>
-        <p:nvSpPr>
-          <p:cNvPr id="66" name="Rounded Rectangle 65"/>
-          <p:cNvSpPr/>
-          <p:nvPr/>
-        </p:nvSpPr>
-        <p:spPr>
-          <a:xfrm>
-            <a:off x="8092440" y="4087368"/>
-            <a:ext cx="841247" cy="347472"/>
-          </a:xfrm>
-          <a:prstGeom prst="roundRect">
-            <a:avLst/>
-          </a:prstGeom>
-          <a:solidFill>
-            <a:srgbClr val="7159C1"/>
-          </a:solidFill>
-          <a:ln>
-            <a:solidFill>
-              <a:srgbClr val="D2DBE6"/>
-            </a:solidFill>
-          </a:ln>
-        </p:spPr>
-        <p:style>
-          <a:lnRef idx="1">
-            <a:schemeClr val="accent1"/>
-          </a:lnRef>
-          <a:fillRef idx="3">
-            <a:schemeClr val="accent1"/>
-          </a:fillRef>
-          <a:effectRef idx="2">
-            <a:schemeClr val="accent1"/>
-          </a:effectRef>
-          <a:fontRef idx="minor">
-            <a:schemeClr val="lt1"/>
-          </a:fontRef>
-        </p:style>
-        <p:txBody>
-          <a:bodyPr rtlCol="0" anchor="ctr"/>
-          <a:lstStyle/>
-          <a:p>
-            <a:pPr algn="ctr"/>
-            <a:r>
-              <a:rPr sz="1200" b="1">
-                <a:solidFill>
-                  <a:srgbClr val="FFFFFF"/>
-                </a:solidFill>
-              </a:rPr>
-              <a:t>■</a:t>
-            </a:r>
-          </a:p>
-        </p:txBody>
-      </p:sp>
-      <p:sp>
-        <p:nvSpPr>
-          <p:cNvPr id="67" name="Rounded Rectangle 66"/>
-          <p:cNvSpPr/>
-          <p:nvPr/>
-        </p:nvSpPr>
-        <p:spPr>
-          <a:xfrm>
-            <a:off x="8961119" y="4087368"/>
-            <a:ext cx="841247" cy="347472"/>
-          </a:xfrm>
-          <a:prstGeom prst="roundRect">
-            <a:avLst/>
-          </a:prstGeom>
-          <a:solidFill>
-            <a:srgbClr val="F4A142"/>
-          </a:solidFill>
-          <a:ln>
-            <a:solidFill>
-              <a:srgbClr val="D2DBE6"/>
-            </a:solidFill>
-          </a:ln>
-        </p:spPr>
-        <p:style>
-          <a:lnRef idx="1">
-            <a:schemeClr val="accent1"/>
-          </a:lnRef>
-          <a:fillRef idx="3">
-            <a:schemeClr val="accent1"/>
-          </a:fillRef>
-          <a:effectRef idx="2">
-            <a:schemeClr val="accent1"/>
-          </a:effectRef>
-          <a:fontRef idx="minor">
-            <a:schemeClr val="lt1"/>
-          </a:fontRef>
-        </p:style>
-        <p:txBody>
-          <a:bodyPr rtlCol="0" anchor="ctr"/>
-          <a:lstStyle/>
-          <a:p>
-            <a:pPr algn="ctr"/>
-            <a:r>
-              <a:rPr sz="1200" b="1">
-                <a:solidFill>
-                  <a:srgbClr val="FFFFFF"/>
-                </a:solidFill>
-              </a:rPr>
-              <a:t>■</a:t>
-            </a:r>
-          </a:p>
-        </p:txBody>
-      </p:sp>
-      <p:sp>
-        <p:nvSpPr>
-          <p:cNvPr id="68" name="Rounded Rectangle 67"/>
-          <p:cNvSpPr/>
-          <p:nvPr/>
-        </p:nvSpPr>
-        <p:spPr>
-          <a:xfrm>
-            <a:off x="9829799" y="4087368"/>
-            <a:ext cx="841247" cy="347472"/>
-          </a:xfrm>
-          <a:prstGeom prst="roundRect">
-            <a:avLst/>
-          </a:prstGeom>
-          <a:solidFill>
-            <a:srgbClr val="D63F36"/>
-          </a:solidFill>
-          <a:ln>
-            <a:solidFill>
-              <a:srgbClr val="D2DBE6"/>
-            </a:solidFill>
-          </a:ln>
-        </p:spPr>
-        <p:style>
-          <a:lnRef idx="1">
-            <a:schemeClr val="accent1"/>
-          </a:lnRef>
-          <a:fillRef idx="3">
-            <a:schemeClr val="accent1"/>
-          </a:fillRef>
-          <a:effectRef idx="2">
-            <a:schemeClr val="accent1"/>
-          </a:effectRef>
-          <a:fontRef idx="minor">
-            <a:schemeClr val="lt1"/>
-          </a:fontRef>
-        </p:style>
-        <p:txBody>
-          <a:bodyPr rtlCol="0" anchor="ctr"/>
-          <a:lstStyle/>
-          <a:p>
-            <a:pPr algn="ctr"/>
-            <a:r>
-              <a:rPr sz="1200" b="1">
-                <a:solidFill>
-                  <a:srgbClr val="FFFFFF"/>
-                </a:solidFill>
-              </a:rPr>
-              <a:t>■</a:t>
-            </a:r>
-          </a:p>
-        </p:txBody>
-      </p:sp>
-      <p:sp>
-        <p:nvSpPr>
-          <p:cNvPr id="69" name="Rounded Rectangle 68"/>
-          <p:cNvSpPr/>
-          <p:nvPr/>
-        </p:nvSpPr>
-        <p:spPr>
-          <a:xfrm>
-            <a:off x="411480" y="4471416"/>
-            <a:ext cx="1298448" cy="347472"/>
-          </a:xfrm>
-          <a:prstGeom prst="roundRect">
-            <a:avLst/>
-          </a:prstGeom>
-          <a:solidFill>
-            <a:srgbClr val="E6EEF8"/>
-          </a:solidFill>
-          <a:ln>
-            <a:solidFill>
-              <a:srgbClr val="D2DBE6"/>
-            </a:solidFill>
-          </a:ln>
-        </p:spPr>
-        <p:style>
-          <a:lnRef idx="1">
-            <a:schemeClr val="accent1"/>
-          </a:lnRef>
-          <a:fillRef idx="3">
-            <a:schemeClr val="accent1"/>
-          </a:fillRef>
-          <a:effectRef idx="2">
-            <a:schemeClr val="accent1"/>
-          </a:effectRef>
-          <a:fontRef idx="minor">
-            <a:schemeClr val="lt1"/>
-          </a:fontRef>
-        </p:style>
-        <p:txBody>
-          <a:bodyPr rtlCol="0" anchor="ctr"/>
-          <a:lstStyle/>
-          <a:p>
-            <a:pPr algn="ctr"/>
-            <a:r>
-              <a:rPr sz="950" b="1">
-                <a:solidFill>
-                  <a:srgbClr val="292929"/>
-                </a:solidFill>
-              </a:rPr>
-              <a:t>NOKIA 자동점검</a:t>
-            </a:r>
-          </a:p>
-        </p:txBody>
-      </p:sp>
-      <p:sp>
-        <p:nvSpPr>
-          <p:cNvPr id="70" name="Rounded Rectangle 69"/>
-          <p:cNvSpPr/>
-          <p:nvPr/>
-        </p:nvSpPr>
-        <p:spPr>
-          <a:xfrm>
-            <a:off x="1737360" y="4471416"/>
-            <a:ext cx="3721607" cy="347472"/>
-          </a:xfrm>
-          <a:prstGeom prst="roundRect">
-            <a:avLst/>
-          </a:prstGeom>
-          <a:solidFill>
-            <a:srgbClr val="FFFFFF"/>
-          </a:solidFill>
-          <a:ln>
-            <a:solidFill>
-              <a:srgbClr val="D2DBE6"/>
-            </a:solidFill>
-          </a:ln>
-        </p:spPr>
-        <p:style>
-          <a:lnRef idx="1">
-            <a:schemeClr val="accent1"/>
-          </a:lnRef>
-          <a:fillRef idx="3">
-            <a:schemeClr val="accent1"/>
-          </a:fillRef>
-          <a:effectRef idx="2">
-            <a:schemeClr val="accent1"/>
-          </a:effectRef>
-          <a:fontRef idx="minor">
-            <a:schemeClr val="lt1"/>
-          </a:fontRef>
-        </p:style>
-        <p:txBody>
-          <a:bodyPr rtlCol="0" anchor="ctr"/>
-          <a:lstStyle/>
-          <a:p>
-            <a:pPr algn="l"/>
-            <a:r>
-              <a:rPr sz="950" b="0">
-                <a:solidFill>
-                  <a:srgbClr val="292929"/>
-                </a:solidFill>
-              </a:rPr>
-              <a:t>NOKIA OTDR Event 연동 기능</a:t>
-            </a:r>
-          </a:p>
-        </p:txBody>
-      </p:sp>
-      <p:sp>
-        <p:nvSpPr>
-          <p:cNvPr id="71" name="Rounded Rectangle 70"/>
-          <p:cNvSpPr/>
-          <p:nvPr/>
-        </p:nvSpPr>
-        <p:spPr>
-          <a:xfrm>
-            <a:off x="5486400" y="4471416"/>
-            <a:ext cx="841247" cy="347472"/>
-          </a:xfrm>
-          <a:prstGeom prst="roundRect">
-            <a:avLst/>
-          </a:prstGeom>
-          <a:solidFill>
-            <a:srgbClr val="245CA5"/>
-          </a:solidFill>
-          <a:ln>
-            <a:solidFill>
-              <a:srgbClr val="D2DBE6"/>
-            </a:solidFill>
-          </a:ln>
-        </p:spPr>
-        <p:style>
-          <a:lnRef idx="1">
-            <a:schemeClr val="accent1"/>
-          </a:lnRef>
-          <a:fillRef idx="3">
-            <a:schemeClr val="accent1"/>
-          </a:fillRef>
-          <a:effectRef idx="2">
-            <a:schemeClr val="accent1"/>
-          </a:effectRef>
-          <a:fontRef idx="minor">
-            <a:schemeClr val="lt1"/>
-          </a:fontRef>
-        </p:style>
-        <p:txBody>
-          <a:bodyPr rtlCol="0" anchor="ctr"/>
-          <a:lstStyle/>
-          <a:p>
-            <a:pPr algn="ctr"/>
-            <a:r>
-              <a:rPr sz="1200" b="1">
-                <a:solidFill>
-                  <a:srgbClr val="FFFFFF"/>
-                </a:solidFill>
-              </a:rPr>
-              <a:t>■</a:t>
-            </a:r>
-          </a:p>
-        </p:txBody>
-      </p:sp>
-      <p:sp>
-        <p:nvSpPr>
-          <p:cNvPr id="72" name="Rounded Rectangle 71"/>
-          <p:cNvSpPr/>
-          <p:nvPr/>
-        </p:nvSpPr>
-        <p:spPr>
-          <a:xfrm>
-            <a:off x="6355080" y="4471416"/>
-            <a:ext cx="841247" cy="347472"/>
-          </a:xfrm>
-          <a:prstGeom prst="roundRect">
-            <a:avLst/>
-          </a:prstGeom>
-          <a:solidFill>
-            <a:srgbClr val="4FA4E3"/>
-          </a:solidFill>
-          <a:ln>
-            <a:solidFill>
-              <a:srgbClr val="D2DBE6"/>
-            </a:solidFill>
-          </a:ln>
-        </p:spPr>
-        <p:style>
-          <a:lnRef idx="1">
-            <a:schemeClr val="accent1"/>
-          </a:lnRef>
-          <a:fillRef idx="3">
-            <a:schemeClr val="accent1"/>
-          </a:fillRef>
-          <a:effectRef idx="2">
-            <a:schemeClr val="accent1"/>
-          </a:effectRef>
-          <a:fontRef idx="minor">
-            <a:schemeClr val="lt1"/>
-          </a:fontRef>
-        </p:style>
-        <p:txBody>
-          <a:bodyPr rtlCol="0" anchor="ctr"/>
-          <a:lstStyle/>
-          <a:p>
-            <a:pPr algn="ctr"/>
-            <a:r>
-              <a:rPr sz="1200" b="1">
-                <a:solidFill>
-                  <a:srgbClr val="FFFFFF"/>
-                </a:solidFill>
-              </a:rPr>
-              <a:t>■</a:t>
-            </a:r>
-          </a:p>
-        </p:txBody>
-      </p:sp>
-      <p:sp>
-        <p:nvSpPr>
-          <p:cNvPr id="73" name="Rounded Rectangle 72"/>
-          <p:cNvSpPr/>
-          <p:nvPr/>
-        </p:nvSpPr>
-        <p:spPr>
-          <a:xfrm>
-            <a:off x="7223760" y="4471416"/>
-            <a:ext cx="841247" cy="347472"/>
-          </a:xfrm>
-          <a:prstGeom prst="roundRect">
-            <a:avLst/>
-          </a:prstGeom>
-          <a:solidFill>
-            <a:srgbClr val="359961"/>
-          </a:solidFill>
-          <a:ln>
-            <a:solidFill>
-              <a:srgbClr val="D2DBE6"/>
-            </a:solidFill>
-          </a:ln>
-        </p:spPr>
-        <p:style>
-          <a:lnRef idx="1">
-            <a:schemeClr val="accent1"/>
-          </a:lnRef>
-          <a:fillRef idx="3">
-            <a:schemeClr val="accent1"/>
-          </a:fillRef>
-          <a:effectRef idx="2">
-            <a:schemeClr val="accent1"/>
-          </a:effectRef>
-          <a:fontRef idx="minor">
-            <a:schemeClr val="lt1"/>
-          </a:fontRef>
-        </p:style>
-        <p:txBody>
-          <a:bodyPr rtlCol="0" anchor="ctr"/>
-          <a:lstStyle/>
-          <a:p>
-            <a:pPr algn="ctr"/>
-            <a:r>
-              <a:rPr sz="1200" b="1">
-                <a:solidFill>
-                  <a:srgbClr val="FFFFFF"/>
-                </a:solidFill>
-              </a:rPr>
-              <a:t>■</a:t>
-            </a:r>
-          </a:p>
-        </p:txBody>
-      </p:sp>
-      <p:sp>
-        <p:nvSpPr>
-          <p:cNvPr id="74" name="Rounded Rectangle 73"/>
-          <p:cNvSpPr/>
-          <p:nvPr/>
-        </p:nvSpPr>
-        <p:spPr>
-          <a:xfrm>
-            <a:off x="8092440" y="4471416"/>
-            <a:ext cx="841247" cy="347472"/>
-          </a:xfrm>
-          <a:prstGeom prst="roundRect">
-            <a:avLst/>
-          </a:prstGeom>
-          <a:solidFill>
-            <a:srgbClr val="7159C1"/>
-          </a:solidFill>
-          <a:ln>
-            <a:solidFill>
-              <a:srgbClr val="D2DBE6"/>
-            </a:solidFill>
-          </a:ln>
-        </p:spPr>
-        <p:style>
-          <a:lnRef idx="1">
-            <a:schemeClr val="accent1"/>
-          </a:lnRef>
-          <a:fillRef idx="3">
-            <a:schemeClr val="accent1"/>
-          </a:fillRef>
-          <a:effectRef idx="2">
-            <a:schemeClr val="accent1"/>
-          </a:effectRef>
-          <a:fontRef idx="minor">
-            <a:schemeClr val="lt1"/>
-          </a:fontRef>
-        </p:style>
-        <p:txBody>
-          <a:bodyPr rtlCol="0" anchor="ctr"/>
-          <a:lstStyle/>
-          <a:p>
-            <a:pPr algn="ctr"/>
-            <a:r>
-              <a:rPr sz="1200" b="1">
-                <a:solidFill>
-                  <a:srgbClr val="FFFFFF"/>
-                </a:solidFill>
-              </a:rPr>
-              <a:t>■</a:t>
-            </a:r>
-          </a:p>
-        </p:txBody>
-      </p:sp>
-      <p:sp>
-        <p:nvSpPr>
-          <p:cNvPr id="75" name="Rounded Rectangle 74"/>
-          <p:cNvSpPr/>
-          <p:nvPr/>
-        </p:nvSpPr>
-        <p:spPr>
-          <a:xfrm>
-            <a:off x="8961119" y="4471416"/>
-            <a:ext cx="841247" cy="347472"/>
-          </a:xfrm>
-          <a:prstGeom prst="roundRect">
-            <a:avLst/>
-          </a:prstGeom>
-          <a:solidFill>
-            <a:srgbClr val="F4A142"/>
-          </a:solidFill>
-          <a:ln>
-            <a:solidFill>
-              <a:srgbClr val="D2DBE6"/>
-            </a:solidFill>
-          </a:ln>
-        </p:spPr>
-        <p:style>
-          <a:lnRef idx="1">
-            <a:schemeClr val="accent1"/>
-          </a:lnRef>
-          <a:fillRef idx="3">
-            <a:schemeClr val="accent1"/>
-          </a:fillRef>
-          <a:effectRef idx="2">
-            <a:schemeClr val="accent1"/>
-          </a:effectRef>
-          <a:fontRef idx="minor">
-            <a:schemeClr val="lt1"/>
-          </a:fontRef>
-        </p:style>
-        <p:txBody>
-          <a:bodyPr rtlCol="0" anchor="ctr"/>
-          <a:lstStyle/>
-          <a:p>
-            <a:pPr algn="ctr"/>
-            <a:r>
-              <a:rPr sz="1200" b="1">
-                <a:solidFill>
-                  <a:srgbClr val="FFFFFF"/>
-                </a:solidFill>
-              </a:rPr>
-              <a:t>■</a:t>
-            </a:r>
-          </a:p>
-        </p:txBody>
-      </p:sp>
-      <p:sp>
-        <p:nvSpPr>
-          <p:cNvPr id="76" name="Rounded Rectangle 75"/>
-          <p:cNvSpPr/>
-          <p:nvPr/>
-        </p:nvSpPr>
-        <p:spPr>
-          <a:xfrm>
-            <a:off x="9829799" y="4471416"/>
-            <a:ext cx="841247" cy="347472"/>
-          </a:xfrm>
-          <a:prstGeom prst="roundRect">
-            <a:avLst/>
-          </a:prstGeom>
-          <a:solidFill>
-            <a:srgbClr val="D63F36"/>
-          </a:solidFill>
-          <a:ln>
-            <a:solidFill>
-              <a:srgbClr val="D2DBE6"/>
-            </a:solidFill>
-          </a:ln>
-        </p:spPr>
-        <p:style>
-          <a:lnRef idx="1">
-            <a:schemeClr val="accent1"/>
-          </a:lnRef>
-          <a:fillRef idx="3">
-            <a:schemeClr val="accent1"/>
-          </a:fillRef>
-          <a:effectRef idx="2">
-            <a:schemeClr val="accent1"/>
-          </a:effectRef>
-          <a:fontRef idx="minor">
-            <a:schemeClr val="lt1"/>
-          </a:fontRef>
-        </p:style>
-        <p:txBody>
-          <a:bodyPr rtlCol="0" anchor="ctr"/>
-          <a:lstStyle/>
-          <a:p>
-            <a:pPr algn="ctr"/>
-            <a:r>
-              <a:rPr sz="1200" b="1">
-                <a:solidFill>
-                  <a:srgbClr val="FFFFFF"/>
-                </a:solidFill>
-              </a:rPr>
-              <a:t>■</a:t>
-            </a:r>
-          </a:p>
-        </p:txBody>
-      </p:sp>
-      <p:sp>
-        <p:nvSpPr>
-          <p:cNvPr id="77" name="Rounded Rectangle 76"/>
-          <p:cNvSpPr/>
-          <p:nvPr/>
-        </p:nvSpPr>
-        <p:spPr>
-          <a:xfrm>
-            <a:off x="411480" y="4855464"/>
-            <a:ext cx="1298448" cy="347472"/>
-          </a:xfrm>
-          <a:prstGeom prst="roundRect">
-            <a:avLst/>
-          </a:prstGeom>
-          <a:solidFill>
-            <a:srgbClr val="E6EEF8"/>
-          </a:solidFill>
-          <a:ln>
-            <a:solidFill>
-              <a:srgbClr val="D2DBE6"/>
-            </a:solidFill>
-          </a:ln>
-        </p:spPr>
-        <p:style>
-          <a:lnRef idx="1">
-            <a:schemeClr val="accent1"/>
-          </a:lnRef>
-          <a:fillRef idx="3">
-            <a:schemeClr val="accent1"/>
-          </a:fillRef>
-          <a:effectRef idx="2">
-            <a:schemeClr val="accent1"/>
-          </a:effectRef>
-          <a:fontRef idx="minor">
-            <a:schemeClr val="lt1"/>
-          </a:fontRef>
-        </p:style>
-        <p:txBody>
-          <a:bodyPr rtlCol="0" anchor="ctr"/>
-          <a:lstStyle/>
-          <a:p>
-            <a:pPr algn="ctr"/>
-            <a:r>
-              <a:rPr sz="950" b="0">
-                <a:solidFill>
-                  <a:srgbClr val="292929"/>
-                </a:solidFill>
-              </a:rPr>
-              <a:t/>
-            </a:r>
-          </a:p>
-        </p:txBody>
-      </p:sp>
-      <p:sp>
-        <p:nvSpPr>
           <p:cNvPr id="78" name="Rounded Rectangle 77"/>
           <p:cNvSpPr/>
           <p:nvPr/>
@@ -8741,14 +8456,6 @@
           <a:lstStyle/>
           <a:p>
             <a:pPr algn="ctr"/>
-            <a:r>
-              <a:rPr sz="1200" b="1">
-                <a:solidFill>
-                  <a:srgbClr val="FFFFFF"/>
-                </a:solidFill>
-              </a:rPr>
-              <a:t>■</a:t>
-            </a:r>
           </a:p>
         </p:txBody>
       </p:sp>
@@ -8794,14 +8501,6 @@
           <a:lstStyle/>
           <a:p>
             <a:pPr algn="ctr"/>
-            <a:r>
-              <a:rPr sz="1200" b="1">
-                <a:solidFill>
-                  <a:srgbClr val="FFFFFF"/>
-                </a:solidFill>
-              </a:rPr>
-              <a:t>■</a:t>
-            </a:r>
           </a:p>
         </p:txBody>
       </p:sp>
@@ -8847,14 +8546,6 @@
           <a:lstStyle/>
           <a:p>
             <a:pPr algn="ctr"/>
-            <a:r>
-              <a:rPr sz="1200" b="1">
-                <a:solidFill>
-                  <a:srgbClr val="FFFFFF"/>
-                </a:solidFill>
-              </a:rPr>
-              <a:t>■</a:t>
-            </a:r>
           </a:p>
         </p:txBody>
       </p:sp>
@@ -8900,14 +8591,6 @@
           <a:lstStyle/>
           <a:p>
             <a:pPr algn="ctr"/>
-            <a:r>
-              <a:rPr sz="1200" b="1">
-                <a:solidFill>
-                  <a:srgbClr val="FFFFFF"/>
-                </a:solidFill>
-              </a:rPr>
-              <a:t>■</a:t>
-            </a:r>
           </a:p>
         </p:txBody>
       </p:sp>
@@ -8953,14 +8636,6 @@
           <a:lstStyle/>
           <a:p>
             <a:pPr algn="ctr"/>
-            <a:r>
-              <a:rPr sz="1200" b="1">
-                <a:solidFill>
-                  <a:srgbClr val="FFFFFF"/>
-                </a:solidFill>
-              </a:rPr>
-              <a:t/>
-            </a:r>
           </a:p>
         </p:txBody>
       </p:sp>
@@ -9006,14 +8681,6 @@
           <a:lstStyle/>
           <a:p>
             <a:pPr algn="ctr"/>
-            <a:r>
-              <a:rPr sz="1200" b="1">
-                <a:solidFill>
-                  <a:srgbClr val="FFFFFF"/>
-                </a:solidFill>
-              </a:rPr>
-              <a:t/>
-            </a:r>
           </a:p>
         </p:txBody>
       </p:sp>
@@ -9165,14 +8832,6 @@
           <a:lstStyle/>
           <a:p>
             <a:pPr algn="ctr"/>
-            <a:r>
-              <a:rPr sz="1200" b="1">
-                <a:solidFill>
-                  <a:srgbClr val="FFFFFF"/>
-                </a:solidFill>
-              </a:rPr>
-              <a:t>■</a:t>
-            </a:r>
           </a:p>
         </p:txBody>
       </p:sp>
@@ -9218,14 +8877,6 @@
           <a:lstStyle/>
           <a:p>
             <a:pPr algn="ctr"/>
-            <a:r>
-              <a:rPr sz="1200" b="1">
-                <a:solidFill>
-                  <a:srgbClr val="FFFFFF"/>
-                </a:solidFill>
-              </a:rPr>
-              <a:t>■</a:t>
-            </a:r>
           </a:p>
         </p:txBody>
       </p:sp>
@@ -9271,14 +8922,6 @@
           <a:lstStyle/>
           <a:p>
             <a:pPr algn="ctr"/>
-            <a:r>
-              <a:rPr sz="1200" b="1">
-                <a:solidFill>
-                  <a:srgbClr val="FFFFFF"/>
-                </a:solidFill>
-              </a:rPr>
-              <a:t>■</a:t>
-            </a:r>
           </a:p>
         </p:txBody>
       </p:sp>
@@ -9324,14 +8967,6 @@
           <a:lstStyle/>
           <a:p>
             <a:pPr algn="ctr"/>
-            <a:r>
-              <a:rPr sz="1200" b="1">
-                <a:solidFill>
-                  <a:srgbClr val="FFFFFF"/>
-                </a:solidFill>
-              </a:rPr>
-              <a:t>■</a:t>
-            </a:r>
           </a:p>
         </p:txBody>
       </p:sp>
@@ -9377,14 +9012,6 @@
           <a:lstStyle/>
           <a:p>
             <a:pPr algn="ctr"/>
-            <a:r>
-              <a:rPr sz="1200" b="1">
-                <a:solidFill>
-                  <a:srgbClr val="FFFFFF"/>
-                </a:solidFill>
-              </a:rPr>
-              <a:t>■</a:t>
-            </a:r>
           </a:p>
         </p:txBody>
       </p:sp>
@@ -9430,14 +9057,6 @@
           <a:lstStyle/>
           <a:p>
             <a:pPr algn="ctr"/>
-            <a:r>
-              <a:rPr sz="1200" b="1">
-                <a:solidFill>
-                  <a:srgbClr val="FFFFFF"/>
-                </a:solidFill>
-              </a:rPr>
-              <a:t/>
-            </a:r>
           </a:p>
         </p:txBody>
       </p:sp>
@@ -9589,14 +9208,6 @@
           <a:lstStyle/>
           <a:p>
             <a:pPr algn="ctr"/>
-            <a:r>
-              <a:rPr sz="1200" b="1">
-                <a:solidFill>
-                  <a:srgbClr val="FFFFFF"/>
-                </a:solidFill>
-              </a:rPr>
-              <a:t>■</a:t>
-            </a:r>
           </a:p>
         </p:txBody>
       </p:sp>
@@ -9642,14 +9253,6 @@
           <a:lstStyle/>
           <a:p>
             <a:pPr algn="ctr"/>
-            <a:r>
-              <a:rPr sz="1200" b="1">
-                <a:solidFill>
-                  <a:srgbClr val="FFFFFF"/>
-                </a:solidFill>
-              </a:rPr>
-              <a:t>■</a:t>
-            </a:r>
           </a:p>
         </p:txBody>
       </p:sp>
@@ -9695,14 +9298,6 @@
           <a:lstStyle/>
           <a:p>
             <a:pPr algn="ctr"/>
-            <a:r>
-              <a:rPr sz="1200" b="1">
-                <a:solidFill>
-                  <a:srgbClr val="FFFFFF"/>
-                </a:solidFill>
-              </a:rPr>
-              <a:t>■</a:t>
-            </a:r>
           </a:p>
         </p:txBody>
       </p:sp>
@@ -9748,14 +9343,6 @@
           <a:lstStyle/>
           <a:p>
             <a:pPr algn="ctr"/>
-            <a:r>
-              <a:rPr sz="1200" b="1">
-                <a:solidFill>
-                  <a:srgbClr val="FFFFFF"/>
-                </a:solidFill>
-              </a:rPr>
-              <a:t>■</a:t>
-            </a:r>
           </a:p>
         </p:txBody>
       </p:sp>
@@ -9801,14 +9388,6 @@
           <a:lstStyle/>
           <a:p>
             <a:pPr algn="ctr"/>
-            <a:r>
-              <a:rPr sz="1200" b="1">
-                <a:solidFill>
-                  <a:srgbClr val="FFFFFF"/>
-                </a:solidFill>
-              </a:rPr>
-              <a:t>■</a:t>
-            </a:r>
           </a:p>
         </p:txBody>
       </p:sp>
@@ -9854,14 +9433,6 @@
           <a:lstStyle/>
           <a:p>
             <a:pPr algn="ctr"/>
-            <a:r>
-              <a:rPr sz="1200" b="1">
-                <a:solidFill>
-                  <a:srgbClr val="FFFFFF"/>
-                </a:solidFill>
-              </a:rPr>
-              <a:t>■</a:t>
-            </a:r>
           </a:p>
         </p:txBody>
       </p:sp>
@@ -9887,15 +9458,8 @@
           </a:bodyPr>
           <a:lstStyle/>
           <a:p>
-            <a:pPr>
-              <a:defRPr sz="1000">
-                <a:solidFill>
-                  <a:srgbClr val="667080"/>
-                </a:solidFill>
-              </a:defRPr>
-            </a:pPr>
-            <a:r>
-              <a:t>※ 색상 블록은 해당 월에 기능 개발이 진행됨을 의미하며, M/D 및 인력등급 표시는 제외함</a:t>
+            <a:r>
+              <a:t>※ 일정은 repository의 doc 폴더 아래 xlsx 기능 항목을 기준으로 정리했으며, 월별 진행은 색상 블록으로 표현함</a:t>
             </a:r>
           </a:p>
         </p:txBody>
@@ -10040,7 +9604,7 @@
                   <a:srgbClr val="112743"/>
                 </a:solidFill>
               </a:rPr>
-              <a:t>2. HUAWEI 장비 인벤토리 정보 조회 기능</a:t>
+              <a:t>HUAWEI 장비 인벤토리 정보 조회 기능</a:t>
             </a:r>
           </a:p>
           <a:p>
@@ -11211,7 +10775,7 @@
                   <a:srgbClr val="112743"/>
                 </a:solidFill>
               </a:rPr>
-              <a:t>3. HUAWEI OTDR 측정 Profile 관리 기능</a:t>
+              <a:t>HUAWEI OTDR 측정 Profile 관리 기능</a:t>
             </a:r>
           </a:p>
           <a:p>
@@ -12329,7 +11893,7 @@
                   <a:srgbClr val="112743"/>
                 </a:solidFill>
               </a:rPr>
-              <a:t>4. HUAWEI OTDR 측정 작업 실행 기능</a:t>
+              <a:t>HUAWEI OTDR 측정 작업 실행 기능</a:t>
             </a:r>
           </a:p>
           <a:p>
@@ -13447,7 +13011,7 @@
                   <a:srgbClr val="112743"/>
                 </a:solidFill>
               </a:rPr>
-              <a:t>5. HUAWEI OTDR 측정 결과 조회 기능</a:t>
+              <a:t>HUAWEI OTDR 측정 결과 조회 기능</a:t>
             </a:r>
           </a:p>
           <a:p>
@@ -14565,7 +14129,7 @@
                   <a:srgbClr val="112743"/>
                 </a:solidFill>
               </a:rPr>
-              <a:t>6. HUAWEI EMS 자동점검 조회 기능</a:t>
+              <a:t>HUAWEI EMS 자동점검 조회 기능</a:t>
             </a:r>
           </a:p>
           <a:p>
@@ -15683,7 +15247,7 @@
                   <a:srgbClr val="112743"/>
                 </a:solidFill>
               </a:rPr>
-              <a:t>7. TANGO 링 정보, GIS 선번 정보 연동 기능</a:t>
+              <a:t>TANGO 링 정보, GIS 선번 정보 연동 기능</a:t>
             </a:r>
           </a:p>
           <a:p>
@@ -16801,7 +16365,7 @@
                   <a:srgbClr val="112743"/>
                 </a:solidFill>
               </a:rPr>
-              <a:t>8. NOKIA EMS 자동점검 조회 기능 개발</a:t>
+              <a:t>NOKIA EMS 자동점검 조회 기능 개발</a:t>
             </a:r>
           </a:p>
           <a:p>
@@ -17919,7 +17483,7 @@
                   <a:srgbClr val="112743"/>
                 </a:solidFill>
               </a:rPr>
-              <a:t>9. OTDR 선로 길이 보정 기능 개발</a:t>
+              <a:t>OTDR 선로 길이 보정 기능 개발</a:t>
             </a:r>
           </a:p>
           <a:p>

</xml_diff>

<commit_message>
docs: further refine OTDR project plan PPT
</commit_message>
<xml_diff>
--- a/output/SKT_OTDR_선로품질관리시스템_고도화_개발계획서_최종.pptx
+++ b/output/SKT_OTDR_선로품질관리시스템_고도화_개발계획서_최종.pptx
@@ -3422,7 +3422,7 @@
           </a:p>
           <a:p>
             <a:pPr>
-              <a:defRPr sz="1600">
+              <a:defRPr sz="1500">
                 <a:solidFill>
                   <a:srgbClr val="292929"/>
                 </a:solidFill>
@@ -3434,26 +3434,26 @@
           </a:p>
           <a:p>
             <a:pPr>
-              <a:defRPr sz="1300">
+              <a:defRPr sz="1500">
                 <a:solidFill>
                   <a:srgbClr val="292929"/>
                 </a:solidFill>
               </a:defRPr>
             </a:pPr>
             <a:r>
-              <a:t>작성자: 입력</a:t>
+              <a:t>HUAWEI / NOKIA EMS 연계 기반 운영 체계 강화</a:t>
             </a:r>
           </a:p>
           <a:p>
             <a:pPr>
-              <a:defRPr sz="1300">
+              <a:defRPr sz="1200">
                 <a:solidFill>
                   <a:srgbClr val="292929"/>
                 </a:solidFill>
               </a:defRPr>
             </a:pPr>
             <a:r>
-              <a:t>날짜: 입력</a:t>
+              <a:t>작성자: 입력    날짜: 입력</a:t>
             </a:r>
           </a:p>
         </p:txBody>
@@ -3501,12 +3501,12 @@
           <a:p>
             <a:pPr algn="ctr"/>
             <a:r>
-              <a:rPr sz="1200" b="1">
+              <a:rPr sz="1150" b="1">
                 <a:solidFill>
                   <a:srgbClr val="FFFFFF"/>
                 </a:solidFill>
               </a:rPr>
-              <a:t>HUAWEI/NOKIA EMS 연동</a:t>
+              <a:t>인벤토리 자동수집</a:t>
             </a:r>
           </a:p>
         </p:txBody>
@@ -3554,12 +3554,12 @@
           <a:p>
             <a:pPr algn="ctr"/>
             <a:r>
-              <a:rPr sz="1200" b="1">
+              <a:rPr sz="1150" b="1">
                 <a:solidFill>
                   <a:srgbClr val="FFFFFF"/>
                 </a:solidFill>
               </a:rPr>
-              <a:t>OTDR 측정 자동화</a:t>
+              <a:t>OTDR 작업 자동화</a:t>
             </a:r>
           </a:p>
         </p:txBody>
@@ -3607,12 +3607,12 @@
           <a:p>
             <a:pPr algn="ctr"/>
             <a:r>
-              <a:rPr sz="1200" b="1">
+              <a:rPr sz="1150" b="1">
                 <a:solidFill>
                   <a:srgbClr val="FFFFFF"/>
                 </a:solidFill>
               </a:rPr>
-              <a:t>결과 분석/보고서 고도화</a:t>
+              <a:t>결과 분석/보고서</a:t>
             </a:r>
           </a:p>
         </p:txBody>
@@ -3769,7 +3769,7 @@
               </a:defRPr>
             </a:pPr>
             <a:r>
-              <a:t>링 단위 정기/수동 보고서 생성과 비교 분석 기능 제공</a:t>
+              <a:t>링 단위 보고서 생성과 비교 분석 기능으로 운영 인사이트 강화</a:t>
             </a:r>
           </a:p>
         </p:txBody>
@@ -3821,51 +3821,53 @@
       </p:sp>
       <p:sp>
         <p:nvSpPr>
-          <p:cNvPr id="6" name="Rectangle 5"/>
-          <p:cNvSpPr/>
-          <p:nvPr/>
-        </p:nvSpPr>
-        <p:spPr>
-          <a:xfrm>
-            <a:off x="502920" y="1417320"/>
-            <a:ext cx="5029200" cy="347472"/>
-          </a:xfrm>
-          <a:prstGeom prst="rect">
+          <p:cNvPr id="6" name="Rounded Rectangle 5"/>
+          <p:cNvSpPr/>
+          <p:nvPr/>
+        </p:nvSpPr>
+        <p:spPr>
+          <a:xfrm>
+            <a:off x="640080" y="1527048"/>
+            <a:ext cx="1005840" cy="310896"/>
+          </a:xfrm>
+          <a:prstGeom prst="roundRect">
             <a:avLst/>
           </a:prstGeom>
           <a:solidFill>
             <a:srgbClr val="245CA5"/>
           </a:solidFill>
           <a:ln>
-            <a:noFill/>
-          </a:ln>
-        </p:spPr>
-        <p:style>
-          <a:lnRef idx="1">
-            <a:schemeClr val="accent1"/>
-          </a:lnRef>
-          <a:fillRef idx="3">
-            <a:schemeClr val="accent1"/>
-          </a:fillRef>
-          <a:effectRef idx="2">
-            <a:schemeClr val="accent1"/>
-          </a:effectRef>
-          <a:fontRef idx="minor">
-            <a:schemeClr val="lt1"/>
-          </a:fontRef>
-        </p:style>
-        <p:txBody>
-          <a:bodyPr rtlCol="0" anchor="ctr"/>
-          <a:lstStyle/>
-          <a:p>
-            <a:pPr algn="ctr"/>
-            <a:r>
-              <a:rPr sz="1200" b="1">
+            <a:solidFill>
+              <a:srgbClr val="245CA5"/>
+            </a:solidFill>
+          </a:ln>
+        </p:spPr>
+        <p:style>
+          <a:lnRef idx="1">
+            <a:schemeClr val="accent1"/>
+          </a:lnRef>
+          <a:fillRef idx="3">
+            <a:schemeClr val="accent1"/>
+          </a:fillRef>
+          <a:effectRef idx="2">
+            <a:schemeClr val="accent1"/>
+          </a:effectRef>
+          <a:fontRef idx="minor">
+            <a:schemeClr val="lt1"/>
+          </a:fontRef>
+        </p:style>
+        <p:txBody>
+          <a:bodyPr rtlCol="0" anchor="ctr"/>
+          <a:lstStyle/>
+          <a:p>
+            <a:pPr algn="ctr"/>
+            <a:r>
+              <a:rPr sz="1000" b="1">
                 <a:solidFill>
                   <a:srgbClr val="FFFFFF"/>
                 </a:solidFill>
               </a:rPr>
-              <a:t>핵심 기능</a:t>
+              <a:t>핵심</a:t>
             </a:r>
           </a:p>
         </p:txBody>
@@ -3878,8 +3880,8 @@
         </p:nvSpPr>
         <p:spPr>
           <a:xfrm>
-            <a:off x="667512" y="1856232"/>
-            <a:ext cx="4700016" cy="1527048"/>
+            <a:off x="667512" y="1965960"/>
+            <a:ext cx="4709160" cy="1399032"/>
           </a:xfrm>
           <a:prstGeom prst="rect">
             <a:avLst/>
@@ -3918,7 +3920,7 @@
               </a:defRPr>
             </a:pPr>
             <a:r>
-              <a:t>• 측정 기간, 측정 종류, 비교 대상 기준 통계 산출</a:t>
+              <a:t>• 측정 기간/종류/비교 대상 기준 통계 산출</a:t>
             </a:r>
           </a:p>
           <a:p>
@@ -3933,7 +3935,7 @@
               </a:defRPr>
             </a:pPr>
             <a:r>
-              <a:t>• DB 저장 후 Backend API와 Web UI 조회 제공</a:t>
+              <a:t>• DB 저장 후 API와 UI 조회 제공</a:t>
             </a:r>
           </a:p>
         </p:txBody>
@@ -3985,51 +3987,53 @@
       </p:sp>
       <p:sp>
         <p:nvSpPr>
-          <p:cNvPr id="9" name="Rectangle 8"/>
-          <p:cNvSpPr/>
-          <p:nvPr/>
-        </p:nvSpPr>
-        <p:spPr>
-          <a:xfrm>
-            <a:off x="502920" y="3657600"/>
-            <a:ext cx="5029200" cy="347472"/>
-          </a:xfrm>
-          <a:prstGeom prst="rect">
+          <p:cNvPr id="9" name="Rounded Rectangle 8"/>
+          <p:cNvSpPr/>
+          <p:nvPr/>
+        </p:nvSpPr>
+        <p:spPr>
+          <a:xfrm>
+            <a:off x="640080" y="3767328"/>
+            <a:ext cx="1005840" cy="310896"/>
+          </a:xfrm>
+          <a:prstGeom prst="roundRect">
             <a:avLst/>
           </a:prstGeom>
           <a:solidFill>
             <a:srgbClr val="7159C1"/>
           </a:solidFill>
           <a:ln>
-            <a:noFill/>
-          </a:ln>
-        </p:spPr>
-        <p:style>
-          <a:lnRef idx="1">
-            <a:schemeClr val="accent1"/>
-          </a:lnRef>
-          <a:fillRef idx="3">
-            <a:schemeClr val="accent1"/>
-          </a:fillRef>
-          <a:effectRef idx="2">
-            <a:schemeClr val="accent1"/>
-          </a:effectRef>
-          <a:fontRef idx="minor">
-            <a:schemeClr val="lt1"/>
-          </a:fontRef>
-        </p:style>
-        <p:txBody>
-          <a:bodyPr rtlCol="0" anchor="ctr"/>
-          <a:lstStyle/>
-          <a:p>
-            <a:pPr algn="ctr"/>
-            <a:r>
-              <a:rPr sz="1200" b="1">
+            <a:solidFill>
+              <a:srgbClr val="7159C1"/>
+            </a:solidFill>
+          </a:ln>
+        </p:spPr>
+        <p:style>
+          <a:lnRef idx="1">
+            <a:schemeClr val="accent1"/>
+          </a:lnRef>
+          <a:fillRef idx="3">
+            <a:schemeClr val="accent1"/>
+          </a:fillRef>
+          <a:effectRef idx="2">
+            <a:schemeClr val="accent1"/>
+          </a:effectRef>
+          <a:fontRef idx="minor">
+            <a:schemeClr val="lt1"/>
+          </a:fontRef>
+        </p:style>
+        <p:txBody>
+          <a:bodyPr rtlCol="0" anchor="ctr"/>
+          <a:lstStyle/>
+          <a:p>
+            <a:pPr algn="ctr"/>
+            <a:r>
+              <a:rPr sz="1000" b="1">
                 <a:solidFill>
                   <a:srgbClr val="FFFFFF"/>
                 </a:solidFill>
               </a:rPr>
-              <a:t>운영 기능</a:t>
+              <a:t>보강</a:t>
             </a:r>
           </a:p>
         </p:txBody>
@@ -4042,8 +4046,8 @@
         </p:nvSpPr>
         <p:spPr>
           <a:xfrm>
-            <a:off x="667512" y="4096512"/>
-            <a:ext cx="4700016" cy="1252728"/>
+            <a:off x="667512" y="4206240"/>
+            <a:ext cx="4709160" cy="1124712"/>
           </a:xfrm>
           <a:prstGeom prst="rect">
             <a:avLst/>
@@ -4132,7 +4136,7 @@
               </a:defRPr>
             </a:pPr>
             <a:r>
-              <a:t>기능 구조도</a:t>
+              <a:t>상세 구조도</a:t>
             </a:r>
           </a:p>
         </p:txBody>
@@ -4145,8 +4149,8 @@
         </p:nvSpPr>
         <p:spPr>
           <a:xfrm>
-            <a:off x="6309360" y="1783080"/>
-            <a:ext cx="1234440" cy="438912"/>
+            <a:off x="6217920" y="1783080"/>
+            <a:ext cx="1188720" cy="438912"/>
           </a:xfrm>
           <a:prstGeom prst="roundRect">
             <a:avLst/>
@@ -4180,7 +4184,7 @@
           <a:p>
             <a:pPr algn="ctr"/>
             <a:r>
-              <a:rPr sz="1200" b="1">
+              <a:rPr sz="1150" b="1">
                 <a:solidFill>
                   <a:srgbClr val="FFFFFF"/>
                 </a:solidFill>
@@ -4198,8 +4202,8 @@
         </p:nvSpPr>
         <p:spPr>
           <a:xfrm>
-            <a:off x="7818120" y="1783080"/>
-            <a:ext cx="1234440" cy="438912"/>
+            <a:off x="7680960" y="1783080"/>
+            <a:ext cx="1188720" cy="438912"/>
           </a:xfrm>
           <a:prstGeom prst="roundRect">
             <a:avLst/>
@@ -4233,7 +4237,7 @@
           <a:p>
             <a:pPr algn="ctr"/>
             <a:r>
-              <a:rPr sz="1200" b="1">
+              <a:rPr sz="1150" b="1">
                 <a:solidFill>
                   <a:srgbClr val="FFFFFF"/>
                 </a:solidFill>
@@ -4251,8 +4255,8 @@
         </p:nvSpPr>
         <p:spPr>
           <a:xfrm>
-            <a:off x="9326880" y="1783080"/>
-            <a:ext cx="1234440" cy="438912"/>
+            <a:off x="9144000" y="1783080"/>
+            <a:ext cx="1188720" cy="438912"/>
           </a:xfrm>
           <a:prstGeom prst="roundRect">
             <a:avLst/>
@@ -4286,7 +4290,7 @@
           <a:p>
             <a:pPr algn="ctr"/>
             <a:r>
-              <a:rPr sz="1200" b="1">
+              <a:rPr sz="1150" b="1">
                 <a:solidFill>
                   <a:srgbClr val="FFFFFF"/>
                 </a:solidFill>
@@ -4304,8 +4308,8 @@
         </p:nvSpPr>
         <p:spPr>
           <a:xfrm>
-            <a:off x="7086600" y="2743200"/>
-            <a:ext cx="1234440" cy="438912"/>
+            <a:off x="7040880" y="2743200"/>
+            <a:ext cx="1188720" cy="438912"/>
           </a:xfrm>
           <a:prstGeom prst="roundRect">
             <a:avLst/>
@@ -4339,7 +4343,7 @@
           <a:p>
             <a:pPr algn="ctr"/>
             <a:r>
-              <a:rPr sz="1200" b="1">
+              <a:rPr sz="1150" b="1">
                 <a:solidFill>
                   <a:srgbClr val="FFFFFF"/>
                 </a:solidFill>
@@ -4357,8 +4361,8 @@
         </p:nvSpPr>
         <p:spPr>
           <a:xfrm>
-            <a:off x="8732520" y="2743200"/>
-            <a:ext cx="1234440" cy="438912"/>
+            <a:off x="8641080" y="2743200"/>
+            <a:ext cx="1097280" cy="438912"/>
           </a:xfrm>
           <a:prstGeom prst="roundRect">
             <a:avLst/>
@@ -4392,7 +4396,7 @@
           <a:p>
             <a:pPr algn="ctr"/>
             <a:r>
-              <a:rPr sz="1200" b="1">
+              <a:rPr sz="1150" b="1">
                 <a:solidFill>
                   <a:srgbClr val="FFFFFF"/>
                 </a:solidFill>
@@ -4410,8 +4414,8 @@
         </p:nvSpPr>
         <p:spPr>
           <a:xfrm>
-            <a:off x="7818120" y="3749039"/>
-            <a:ext cx="1234440" cy="438912"/>
+            <a:off x="7726679" y="3749039"/>
+            <a:ext cx="1097280" cy="438912"/>
           </a:xfrm>
           <a:prstGeom prst="roundRect">
             <a:avLst/>
@@ -4445,7 +4449,7 @@
           <a:p>
             <a:pPr algn="ctr"/>
             <a:r>
-              <a:rPr sz="1200" b="1">
+              <a:rPr sz="1150" b="1">
                 <a:solidFill>
                   <a:srgbClr val="FFFFFF"/>
                 </a:solidFill>
@@ -4463,8 +4467,8 @@
         </p:nvCxnSpPr>
         <p:spPr>
           <a:xfrm>
-            <a:off x="7452360" y="2011680"/>
-            <a:ext cx="274319" cy="0"/>
+            <a:off x="7315200" y="2011680"/>
+            <a:ext cx="228600" cy="0"/>
           </a:xfrm>
           <a:prstGeom prst="line">
             <a:avLst/>
@@ -4498,7 +4502,7 @@
         </p:nvCxnSpPr>
         <p:spPr>
           <a:xfrm>
-            <a:off x="9052560" y="2011680"/>
+            <a:off x="8869680" y="2011680"/>
             <a:ext cx="274320" cy="0"/>
           </a:xfrm>
           <a:prstGeom prst="line">
@@ -4533,7 +4537,7 @@
         </p:nvCxnSpPr>
         <p:spPr>
           <a:xfrm>
-            <a:off x="8046720" y="2221992"/>
+            <a:off x="8001000" y="2221992"/>
             <a:ext cx="0" cy="502920"/>
           </a:xfrm>
           <a:prstGeom prst="line">
@@ -4568,7 +4572,7 @@
         </p:nvCxnSpPr>
         <p:spPr>
           <a:xfrm>
-            <a:off x="10012680" y="2221992"/>
+            <a:off x="9875520" y="2221992"/>
             <a:ext cx="0" cy="502920"/>
           </a:xfrm>
           <a:prstGeom prst="line">
@@ -4603,8 +4607,8 @@
         </p:nvCxnSpPr>
         <p:spPr>
           <a:xfrm flipH="1">
-            <a:off x="7086600" y="2971800"/>
-            <a:ext cx="457200" cy="0"/>
+            <a:off x="7040880" y="2971800"/>
+            <a:ext cx="411480" cy="0"/>
           </a:xfrm>
           <a:prstGeom prst="line">
             <a:avLst/>
@@ -4639,7 +4643,7 @@
         <p:spPr>
           <a:xfrm>
             <a:off x="8229600" y="2971800"/>
-            <a:ext cx="594360" cy="0"/>
+            <a:ext cx="411480" cy="0"/>
           </a:xfrm>
           <a:prstGeom prst="line">
             <a:avLst/>
@@ -4673,8 +4677,8 @@
         </p:nvCxnSpPr>
         <p:spPr>
           <a:xfrm>
-            <a:off x="7680960" y="3154680"/>
-            <a:ext cx="457200" cy="594359"/>
+            <a:off x="7635240" y="3154680"/>
+            <a:ext cx="411480" cy="594359"/>
           </a:xfrm>
           <a:prstGeom prst="line">
             <a:avLst/>
@@ -4708,8 +4712,8 @@
         </p:nvCxnSpPr>
         <p:spPr>
           <a:xfrm flipH="1">
-            <a:off x="8549640" y="3154680"/>
-            <a:ext cx="594360" cy="594359"/>
+            <a:off x="8503920" y="3154680"/>
+            <a:ext cx="548640" cy="594359"/>
           </a:xfrm>
           <a:prstGeom prst="line">
             <a:avLst/>
@@ -4887,7 +4891,7 @@
               </a:defRPr>
             </a:pPr>
             <a:r>
-              <a:t>doc 폴더의 개발계획서 xlsx 기준 기능별 진행 일정(M ~ M+5)</a:t>
+              <a:t>Repository의 doc/xlsx 기준 기능별 진행 일정을 색상 블록으로 표현</a:t>
             </a:r>
           </a:p>
         </p:txBody>
@@ -4910,7 +4914,9 @@
             <a:srgbClr val="112743"/>
           </a:solidFill>
           <a:ln>
-            <a:noFill/>
+            <a:solidFill>
+              <a:srgbClr val="112743"/>
+            </a:solidFill>
           </a:ln>
         </p:spPr>
         <p:style>
@@ -4961,7 +4967,9 @@
             <a:srgbClr val="112743"/>
           </a:solidFill>
           <a:ln>
-            <a:noFill/>
+            <a:solidFill>
+              <a:srgbClr val="112743"/>
+            </a:solidFill>
           </a:ln>
         </p:spPr>
         <p:style>
@@ -5012,7 +5020,9 @@
             <a:srgbClr val="112743"/>
           </a:solidFill>
           <a:ln>
-            <a:noFill/>
+            <a:solidFill>
+              <a:srgbClr val="112743"/>
+            </a:solidFill>
           </a:ln>
         </p:spPr>
         <p:style>
@@ -5063,7 +5073,9 @@
             <a:srgbClr val="112743"/>
           </a:solidFill>
           <a:ln>
-            <a:noFill/>
+            <a:solidFill>
+              <a:srgbClr val="112743"/>
+            </a:solidFill>
           </a:ln>
         </p:spPr>
         <p:style>
@@ -5114,7 +5126,9 @@
             <a:srgbClr val="112743"/>
           </a:solidFill>
           <a:ln>
-            <a:noFill/>
+            <a:solidFill>
+              <a:srgbClr val="112743"/>
+            </a:solidFill>
           </a:ln>
         </p:spPr>
         <p:style>
@@ -5165,7 +5179,9 @@
             <a:srgbClr val="112743"/>
           </a:solidFill>
           <a:ln>
-            <a:noFill/>
+            <a:solidFill>
+              <a:srgbClr val="112743"/>
+            </a:solidFill>
           </a:ln>
         </p:spPr>
         <p:style>
@@ -5216,7 +5232,9 @@
             <a:srgbClr val="112743"/>
           </a:solidFill>
           <a:ln>
-            <a:noFill/>
+            <a:solidFill>
+              <a:srgbClr val="112743"/>
+            </a:solidFill>
           </a:ln>
         </p:spPr>
         <p:style>
@@ -5267,7 +5285,9 @@
             <a:srgbClr val="112743"/>
           </a:solidFill>
           <a:ln>
-            <a:noFill/>
+            <a:solidFill>
+              <a:srgbClr val="112743"/>
+            </a:solidFill>
           </a:ln>
         </p:spPr>
         <p:style>
@@ -5396,7 +5416,7 @@
           <a:p>
             <a:pPr algn="l"/>
             <a:r>
-              <a:rPr sz="950" b="0">
+              <a:rPr sz="950">
                 <a:solidFill>
                   <a:srgbClr val="292929"/>
                 </a:solidFill>
@@ -5772,7 +5792,7 @@
           <a:p>
             <a:pPr algn="l"/>
             <a:r>
-              <a:rPr sz="950" b="0">
+              <a:rPr sz="950">
                 <a:solidFill>
                   <a:srgbClr val="292929"/>
                 </a:solidFill>
@@ -6148,7 +6168,7 @@
           <a:p>
             <a:pPr algn="l"/>
             <a:r>
-              <a:rPr sz="950" b="0">
+              <a:rPr sz="950">
                 <a:solidFill>
                   <a:srgbClr val="292929"/>
                 </a:solidFill>
@@ -6524,7 +6544,7 @@
           <a:p>
             <a:pPr algn="l"/>
             <a:r>
-              <a:rPr sz="950" b="0">
+              <a:rPr sz="950">
                 <a:solidFill>
                   <a:srgbClr val="292929"/>
                 </a:solidFill>
@@ -6900,7 +6920,7 @@
           <a:p>
             <a:pPr algn="l"/>
             <a:r>
-              <a:rPr sz="950" b="0">
+              <a:rPr sz="950">
                 <a:solidFill>
                   <a:srgbClr val="292929"/>
                 </a:solidFill>
@@ -7276,7 +7296,7 @@
           <a:p>
             <a:pPr algn="l"/>
             <a:r>
-              <a:rPr sz="950" b="0">
+              <a:rPr sz="950">
                 <a:solidFill>
                   <a:srgbClr val="292929"/>
                 </a:solidFill>
@@ -7652,7 +7672,7 @@
           <a:p>
             <a:pPr algn="l"/>
             <a:r>
-              <a:rPr sz="950" b="0">
+              <a:rPr sz="950">
                 <a:solidFill>
                   <a:srgbClr val="292929"/>
                 </a:solidFill>
@@ -8028,7 +8048,7 @@
           <a:p>
             <a:pPr algn="l"/>
             <a:r>
-              <a:rPr sz="950" b="0">
+              <a:rPr sz="950">
                 <a:solidFill>
                   <a:srgbClr val="292929"/>
                 </a:solidFill>
@@ -8404,7 +8424,7 @@
           <a:p>
             <a:pPr algn="l"/>
             <a:r>
-              <a:rPr sz="950" b="0">
+              <a:rPr sz="950">
                 <a:solidFill>
                   <a:srgbClr val="292929"/>
                 </a:solidFill>
@@ -8780,7 +8800,7 @@
           <a:p>
             <a:pPr algn="l"/>
             <a:r>
-              <a:rPr sz="950" b="0">
+              <a:rPr sz="950">
                 <a:solidFill>
                   <a:srgbClr val="292929"/>
                 </a:solidFill>
@@ -9156,7 +9176,7 @@
           <a:p>
             <a:pPr algn="l"/>
             <a:r>
-              <a:rPr sz="950" b="0">
+              <a:rPr sz="950">
                 <a:solidFill>
                   <a:srgbClr val="292929"/>
                 </a:solidFill>
@@ -9458,8 +9478,15 @@
           </a:bodyPr>
           <a:lstStyle/>
           <a:p>
-            <a:r>
-              <a:t>※ 일정은 repository의 doc 폴더 아래 xlsx 기능 항목을 기준으로 정리했으며, 월별 진행은 색상 블록으로 표현함</a:t>
+            <a:pPr>
+              <a:defRPr sz="1000">
+                <a:solidFill>
+                  <a:srgbClr val="667080"/>
+                </a:solidFill>
+              </a:defRPr>
+            </a:pPr>
+            <a:r>
+              <a:t>※ 일정은 doc 폴더의 개발계획서 xlsx 기준 기능 항목을 따르며, 월별 진행은 색상 블록으로만 표현</a:t>
             </a:r>
           </a:p>
         </p:txBody>
@@ -9616,7 +9643,7 @@
               </a:defRPr>
             </a:pPr>
             <a:r>
-              <a:t>HUAWEI NCE REST API 기반 인벤토리 수집, 분석, 저장, 조회</a:t>
+              <a:t>인벤토리 수집, 분석, 저장, 조회의 End-to-End 자동화</a:t>
             </a:r>
           </a:p>
         </p:txBody>
@@ -9668,51 +9695,53 @@
       </p:sp>
       <p:sp>
         <p:nvSpPr>
-          <p:cNvPr id="6" name="Rectangle 5"/>
-          <p:cNvSpPr/>
-          <p:nvPr/>
-        </p:nvSpPr>
-        <p:spPr>
-          <a:xfrm>
-            <a:off x="502920" y="1417320"/>
-            <a:ext cx="5029200" cy="347472"/>
-          </a:xfrm>
-          <a:prstGeom prst="rect">
+          <p:cNvPr id="6" name="Rounded Rectangle 5"/>
+          <p:cNvSpPr/>
+          <p:nvPr/>
+        </p:nvSpPr>
+        <p:spPr>
+          <a:xfrm>
+            <a:off x="640080" y="1527048"/>
+            <a:ext cx="1005840" cy="310896"/>
+          </a:xfrm>
+          <a:prstGeom prst="roundRect">
             <a:avLst/>
           </a:prstGeom>
           <a:solidFill>
             <a:srgbClr val="245CA5"/>
           </a:solidFill>
           <a:ln>
-            <a:noFill/>
-          </a:ln>
-        </p:spPr>
-        <p:style>
-          <a:lnRef idx="1">
-            <a:schemeClr val="accent1"/>
-          </a:lnRef>
-          <a:fillRef idx="3">
-            <a:schemeClr val="accent1"/>
-          </a:fillRef>
-          <a:effectRef idx="2">
-            <a:schemeClr val="accent1"/>
-          </a:effectRef>
-          <a:fontRef idx="minor">
-            <a:schemeClr val="lt1"/>
-          </a:fontRef>
-        </p:style>
-        <p:txBody>
-          <a:bodyPr rtlCol="0" anchor="ctr"/>
-          <a:lstStyle/>
-          <a:p>
-            <a:pPr algn="ctr"/>
-            <a:r>
-              <a:rPr sz="1200" b="1">
+            <a:solidFill>
+              <a:srgbClr val="245CA5"/>
+            </a:solidFill>
+          </a:ln>
+        </p:spPr>
+        <p:style>
+          <a:lnRef idx="1">
+            <a:schemeClr val="accent1"/>
+          </a:lnRef>
+          <a:fillRef idx="3">
+            <a:schemeClr val="accent1"/>
+          </a:fillRef>
+          <a:effectRef idx="2">
+            <a:schemeClr val="accent1"/>
+          </a:effectRef>
+          <a:fontRef idx="minor">
+            <a:schemeClr val="lt1"/>
+          </a:fontRef>
+        </p:style>
+        <p:txBody>
+          <a:bodyPr rtlCol="0" anchor="ctr"/>
+          <a:lstStyle/>
+          <a:p>
+            <a:pPr algn="ctr"/>
+            <a:r>
+              <a:rPr sz="1000" b="1">
                 <a:solidFill>
                   <a:srgbClr val="FFFFFF"/>
                 </a:solidFill>
               </a:rPr>
-              <a:t>핵심 기능</a:t>
+              <a:t>핵심</a:t>
             </a:r>
           </a:p>
         </p:txBody>
@@ -9725,8 +9754,8 @@
         </p:nvSpPr>
         <p:spPr>
           <a:xfrm>
-            <a:off x="667512" y="1856232"/>
-            <a:ext cx="4700016" cy="1527048"/>
+            <a:off x="667512" y="1965960"/>
+            <a:ext cx="4709160" cy="1399032"/>
           </a:xfrm>
           <a:prstGeom prst="rect">
             <a:avLst/>
@@ -9750,7 +9779,7 @@
               </a:defRPr>
             </a:pPr>
             <a:r>
-              <a:t>• 장비/서비스 Port/OTDR Port 수집</a:t>
+              <a:t>• 장비/서비스 Port/OTDR Port 인벤토리 수집</a:t>
             </a:r>
           </a:p>
           <a:p>
@@ -9780,7 +9809,7 @@
               </a:defRPr>
             </a:pPr>
             <a:r>
-              <a:t>• SFTP 보조 연계와 Pagination 처리</a:t>
+              <a:t>• SFTP 보조 연계 및 Pagination 유틸 제공</a:t>
             </a:r>
           </a:p>
         </p:txBody>
@@ -9832,51 +9861,53 @@
       </p:sp>
       <p:sp>
         <p:nvSpPr>
-          <p:cNvPr id="9" name="Rectangle 8"/>
-          <p:cNvSpPr/>
-          <p:nvPr/>
-        </p:nvSpPr>
-        <p:spPr>
-          <a:xfrm>
-            <a:off x="502920" y="3657600"/>
-            <a:ext cx="5029200" cy="347472"/>
-          </a:xfrm>
-          <a:prstGeom prst="rect">
+          <p:cNvPr id="9" name="Rounded Rectangle 8"/>
+          <p:cNvSpPr/>
+          <p:nvPr/>
+        </p:nvSpPr>
+        <p:spPr>
+          <a:xfrm>
+            <a:off x="640080" y="3767328"/>
+            <a:ext cx="1005840" cy="310896"/>
+          </a:xfrm>
+          <a:prstGeom prst="roundRect">
             <a:avLst/>
           </a:prstGeom>
           <a:solidFill>
             <a:srgbClr val="7159C1"/>
           </a:solidFill>
           <a:ln>
-            <a:noFill/>
-          </a:ln>
-        </p:spPr>
-        <p:style>
-          <a:lnRef idx="1">
-            <a:schemeClr val="accent1"/>
-          </a:lnRef>
-          <a:fillRef idx="3">
-            <a:schemeClr val="accent1"/>
-          </a:fillRef>
-          <a:effectRef idx="2">
-            <a:schemeClr val="accent1"/>
-          </a:effectRef>
-          <a:fontRef idx="minor">
-            <a:schemeClr val="lt1"/>
-          </a:fontRef>
-        </p:style>
-        <p:txBody>
-          <a:bodyPr rtlCol="0" anchor="ctr"/>
-          <a:lstStyle/>
-          <a:p>
-            <a:pPr algn="ctr"/>
-            <a:r>
-              <a:rPr sz="1200" b="1">
+            <a:solidFill>
+              <a:srgbClr val="7159C1"/>
+            </a:solidFill>
+          </a:ln>
+        </p:spPr>
+        <p:style>
+          <a:lnRef idx="1">
+            <a:schemeClr val="accent1"/>
+          </a:lnRef>
+          <a:fillRef idx="3">
+            <a:schemeClr val="accent1"/>
+          </a:fillRef>
+          <a:effectRef idx="2">
+            <a:schemeClr val="accent1"/>
+          </a:effectRef>
+          <a:fontRef idx="minor">
+            <a:schemeClr val="lt1"/>
+          </a:fontRef>
+        </p:style>
+        <p:txBody>
+          <a:bodyPr rtlCol="0" anchor="ctr"/>
+          <a:lstStyle/>
+          <a:p>
+            <a:pPr algn="ctr"/>
+            <a:r>
+              <a:rPr sz="1000" b="1">
                 <a:solidFill>
                   <a:srgbClr val="FFFFFF"/>
                 </a:solidFill>
               </a:rPr>
-              <a:t>분석 및 저장</a:t>
+              <a:t>보강</a:t>
             </a:r>
           </a:p>
         </p:txBody>
@@ -9889,8 +9920,8 @@
         </p:nvSpPr>
         <p:spPr>
           <a:xfrm>
-            <a:off x="667512" y="4096512"/>
-            <a:ext cx="4700016" cy="1252728"/>
+            <a:off x="667512" y="4206240"/>
+            <a:ext cx="4709160" cy="1124712"/>
           </a:xfrm>
           <a:prstGeom prst="rect">
             <a:avLst/>
@@ -9929,7 +9960,7 @@
               </a:defRPr>
             </a:pPr>
             <a:r>
-              <a:t>• OTDR Port-서비스 Port 연관성 분석</a:t>
+              <a:t>• OTDR Port와 서비스 Port 연관성 분석</a:t>
             </a:r>
           </a:p>
           <a:p>
@@ -9944,7 +9975,7 @@
               </a:defRPr>
             </a:pPr>
             <a:r>
-              <a:t>• OTDR DB 테이블 저장 및 Web UI 조회</a:t>
+              <a:t>• OTDR DB 저장 및 Web UI 조회</a:t>
             </a:r>
           </a:p>
         </p:txBody>
@@ -9979,7 +10010,7 @@
               </a:defRPr>
             </a:pPr>
             <a:r>
-              <a:t>기능 구조도</a:t>
+              <a:t>상세 구조도</a:t>
             </a:r>
           </a:p>
         </p:txBody>
@@ -9992,8 +10023,8 @@
         </p:nvSpPr>
         <p:spPr>
           <a:xfrm>
-            <a:off x="6309360" y="1783080"/>
-            <a:ext cx="1143000" cy="438912"/>
+            <a:off x="6217920" y="1783080"/>
+            <a:ext cx="1097280" cy="438912"/>
           </a:xfrm>
           <a:prstGeom prst="roundRect">
             <a:avLst/>
@@ -10027,7 +10058,7 @@
           <a:p>
             <a:pPr algn="ctr"/>
             <a:r>
-              <a:rPr sz="1200" b="1">
+              <a:rPr sz="1150" b="1">
                 <a:solidFill>
                   <a:srgbClr val="FFFFFF"/>
                 </a:solidFill>
@@ -10045,7 +10076,7 @@
         </p:nvSpPr>
         <p:spPr>
           <a:xfrm>
-            <a:off x="7726679" y="1783080"/>
+            <a:off x="7543800" y="1783080"/>
             <a:ext cx="1325880" cy="438912"/>
           </a:xfrm>
           <a:prstGeom prst="roundRect">
@@ -10080,12 +10111,12 @@
           <a:p>
             <a:pPr algn="ctr"/>
             <a:r>
-              <a:rPr sz="1200" b="1">
+              <a:rPr sz="1150" b="1">
                 <a:solidFill>
                   <a:srgbClr val="FFFFFF"/>
                 </a:solidFill>
               </a:rPr>
-              <a:t>Inventory API</a:t>
+              <a:t>인벤토리 API</a:t>
             </a:r>
           </a:p>
         </p:txBody>
@@ -10098,8 +10129,8 @@
         </p:nvSpPr>
         <p:spPr>
           <a:xfrm>
-            <a:off x="9372600" y="1783080"/>
-            <a:ext cx="1325880" cy="438912"/>
+            <a:off x="9144000" y="1783080"/>
+            <a:ext cx="1417320" cy="438912"/>
           </a:xfrm>
           <a:prstGeom prst="roundRect">
             <a:avLst/>
@@ -10133,7 +10164,7 @@
           <a:p>
             <a:pPr algn="ctr"/>
             <a:r>
-              <a:rPr sz="1200" b="1">
+              <a:rPr sz="1150" b="1">
                 <a:solidFill>
                   <a:srgbClr val="FFFFFF"/>
                 </a:solidFill>
@@ -10151,7 +10182,7 @@
         </p:nvSpPr>
         <p:spPr>
           <a:xfrm>
-            <a:off x="6949440" y="2743200"/>
+            <a:off x="6903720" y="2743200"/>
             <a:ext cx="1234440" cy="438912"/>
           </a:xfrm>
           <a:prstGeom prst="roundRect">
@@ -10186,7 +10217,7 @@
           <a:p>
             <a:pPr algn="ctr"/>
             <a:r>
-              <a:rPr sz="1200" b="1">
+              <a:rPr sz="1150" b="1">
                 <a:solidFill>
                   <a:srgbClr val="FFFFFF"/>
                 </a:solidFill>
@@ -10205,65 +10236,65 @@
         <p:spPr>
           <a:xfrm>
             <a:off x="8549640" y="2743200"/>
+            <a:ext cx="1417320" cy="438912"/>
+          </a:xfrm>
+          <a:prstGeom prst="roundRect">
+            <a:avLst/>
+          </a:prstGeom>
+          <a:solidFill>
+            <a:srgbClr val="F4A142"/>
+          </a:solidFill>
+          <a:ln>
+            <a:solidFill>
+              <a:srgbClr val="F4A142"/>
+            </a:solidFill>
+          </a:ln>
+        </p:spPr>
+        <p:style>
+          <a:lnRef idx="1">
+            <a:schemeClr val="accent1"/>
+          </a:lnRef>
+          <a:fillRef idx="3">
+            <a:schemeClr val="accent1"/>
+          </a:fillRef>
+          <a:effectRef idx="2">
+            <a:schemeClr val="accent1"/>
+          </a:effectRef>
+          <a:fontRef idx="minor">
+            <a:schemeClr val="lt1"/>
+          </a:fontRef>
+        </p:style>
+        <p:txBody>
+          <a:bodyPr rtlCol="0" anchor="ctr"/>
+          <a:lstStyle/>
+          <a:p>
+            <a:pPr algn="ctr"/>
+            <a:r>
+              <a:rPr sz="1150" b="1">
+                <a:solidFill>
+                  <a:srgbClr val="FFFFFF"/>
+                </a:solidFill>
+              </a:rPr>
+              <a:t>Port 연관분석</a:t>
+            </a:r>
+          </a:p>
+        </p:txBody>
+      </p:sp>
+      <p:sp>
+        <p:nvSpPr>
+          <p:cNvPr id="17" name="Rounded Rectangle 16"/>
+          <p:cNvSpPr/>
+          <p:nvPr/>
+        </p:nvSpPr>
+        <p:spPr>
+          <a:xfrm>
+            <a:off x="7635240" y="3749039"/>
             <a:ext cx="1234440" cy="438912"/>
           </a:xfrm>
           <a:prstGeom prst="roundRect">
             <a:avLst/>
           </a:prstGeom>
           <a:solidFill>
-            <a:srgbClr val="F4A142"/>
-          </a:solidFill>
-          <a:ln>
-            <a:solidFill>
-              <a:srgbClr val="F4A142"/>
-            </a:solidFill>
-          </a:ln>
-        </p:spPr>
-        <p:style>
-          <a:lnRef idx="1">
-            <a:schemeClr val="accent1"/>
-          </a:lnRef>
-          <a:fillRef idx="3">
-            <a:schemeClr val="accent1"/>
-          </a:fillRef>
-          <a:effectRef idx="2">
-            <a:schemeClr val="accent1"/>
-          </a:effectRef>
-          <a:fontRef idx="minor">
-            <a:schemeClr val="lt1"/>
-          </a:fontRef>
-        </p:style>
-        <p:txBody>
-          <a:bodyPr rtlCol="0" anchor="ctr"/>
-          <a:lstStyle/>
-          <a:p>
-            <a:pPr algn="ctr"/>
-            <a:r>
-              <a:rPr sz="1200" b="1">
-                <a:solidFill>
-                  <a:srgbClr val="FFFFFF"/>
-                </a:solidFill>
-              </a:rPr>
-              <a:t>Port 매핑</a:t>
-            </a:r>
-          </a:p>
-        </p:txBody>
-      </p:sp>
-      <p:sp>
-        <p:nvSpPr>
-          <p:cNvPr id="17" name="Rounded Rectangle 16"/>
-          <p:cNvSpPr/>
-          <p:nvPr/>
-        </p:nvSpPr>
-        <p:spPr>
-          <a:xfrm>
-            <a:off x="7726679" y="3749039"/>
-            <a:ext cx="1325880" cy="438912"/>
-          </a:xfrm>
-          <a:prstGeom prst="roundRect">
-            <a:avLst/>
-          </a:prstGeom>
-          <a:solidFill>
             <a:srgbClr val="D63F36"/>
           </a:solidFill>
           <a:ln>
@@ -10292,7 +10323,7 @@
           <a:p>
             <a:pPr algn="ctr"/>
             <a:r>
-              <a:rPr sz="1200" b="1">
+              <a:rPr sz="1150" b="1">
                 <a:solidFill>
                   <a:srgbClr val="FFFFFF"/>
                 </a:solidFill>
@@ -10310,8 +10341,8 @@
         </p:nvSpPr>
         <p:spPr>
           <a:xfrm>
-            <a:off x="9372600" y="3749039"/>
-            <a:ext cx="1143000" cy="438912"/>
+            <a:off x="9326880" y="3749039"/>
+            <a:ext cx="1097280" cy="438912"/>
           </a:xfrm>
           <a:prstGeom prst="roundRect">
             <a:avLst/>
@@ -10345,7 +10376,7 @@
           <a:p>
             <a:pPr algn="ctr"/>
             <a:r>
-              <a:rPr sz="1200" b="1">
+              <a:rPr sz="1150" b="1">
                 <a:solidFill>
                   <a:srgbClr val="FFFFFF"/>
                 </a:solidFill>
@@ -10363,8 +10394,8 @@
         </p:nvCxnSpPr>
         <p:spPr>
           <a:xfrm>
-            <a:off x="7452360" y="2011680"/>
-            <a:ext cx="274319" cy="0"/>
+            <a:off x="7315200" y="2011680"/>
+            <a:ext cx="228600" cy="0"/>
           </a:xfrm>
           <a:prstGeom prst="line">
             <a:avLst/>
@@ -10398,7 +10429,7 @@
         </p:nvCxnSpPr>
         <p:spPr>
           <a:xfrm>
-            <a:off x="9052560" y="2011680"/>
+            <a:off x="8869680" y="2011680"/>
             <a:ext cx="274320" cy="0"/>
           </a:xfrm>
           <a:prstGeom prst="line">
@@ -10433,7 +10464,7 @@
         </p:nvCxnSpPr>
         <p:spPr>
           <a:xfrm>
-            <a:off x="8046720" y="2221992"/>
+            <a:off x="8001000" y="2221992"/>
             <a:ext cx="0" cy="502920"/>
           </a:xfrm>
           <a:prstGeom prst="line">
@@ -10468,7 +10499,7 @@
         </p:nvCxnSpPr>
         <p:spPr>
           <a:xfrm>
-            <a:off x="10012680" y="2221992"/>
+            <a:off x="9875520" y="2221992"/>
             <a:ext cx="0" cy="502920"/>
           </a:xfrm>
           <a:prstGeom prst="line">
@@ -10503,8 +10534,8 @@
         </p:nvCxnSpPr>
         <p:spPr>
           <a:xfrm flipH="1">
-            <a:off x="7086600" y="2971800"/>
-            <a:ext cx="457200" cy="0"/>
+            <a:off x="7040880" y="2971800"/>
+            <a:ext cx="411480" cy="0"/>
           </a:xfrm>
           <a:prstGeom prst="line">
             <a:avLst/>
@@ -10539,7 +10570,7 @@
         <p:spPr>
           <a:xfrm>
             <a:off x="8229600" y="2971800"/>
-            <a:ext cx="594360" cy="0"/>
+            <a:ext cx="411480" cy="0"/>
           </a:xfrm>
           <a:prstGeom prst="line">
             <a:avLst/>
@@ -10573,8 +10604,8 @@
         </p:nvCxnSpPr>
         <p:spPr>
           <a:xfrm>
-            <a:off x="7680960" y="3154680"/>
-            <a:ext cx="457200" cy="594359"/>
+            <a:off x="7635240" y="3154680"/>
+            <a:ext cx="411480" cy="594359"/>
           </a:xfrm>
           <a:prstGeom prst="line">
             <a:avLst/>
@@ -10608,8 +10639,8 @@
         </p:nvCxnSpPr>
         <p:spPr>
           <a:xfrm flipH="1">
-            <a:off x="8549640" y="3154680"/>
-            <a:ext cx="594360" cy="594359"/>
+            <a:off x="8503920" y="3154680"/>
+            <a:ext cx="548640" cy="594359"/>
           </a:xfrm>
           <a:prstGeom prst="line">
             <a:avLst/>
@@ -10787,7 +10818,7 @@
               </a:defRPr>
             </a:pPr>
             <a:r>
-              <a:t>Link 단위 OTDR 측정 Profile과 Default Profile 정책 관리</a:t>
+              <a:t>측정 Profile 표준화와 Default 정책 기반 운영 일관성 확보</a:t>
             </a:r>
           </a:p>
         </p:txBody>
@@ -10839,51 +10870,53 @@
       </p:sp>
       <p:sp>
         <p:nvSpPr>
-          <p:cNvPr id="6" name="Rectangle 5"/>
-          <p:cNvSpPr/>
-          <p:nvPr/>
-        </p:nvSpPr>
-        <p:spPr>
-          <a:xfrm>
-            <a:off x="502920" y="1417320"/>
-            <a:ext cx="5029200" cy="347472"/>
-          </a:xfrm>
-          <a:prstGeom prst="rect">
+          <p:cNvPr id="6" name="Rounded Rectangle 5"/>
+          <p:cNvSpPr/>
+          <p:nvPr/>
+        </p:nvSpPr>
+        <p:spPr>
+          <a:xfrm>
+            <a:off x="640080" y="1527048"/>
+            <a:ext cx="1005840" cy="310896"/>
+          </a:xfrm>
+          <a:prstGeom prst="roundRect">
             <a:avLst/>
           </a:prstGeom>
           <a:solidFill>
             <a:srgbClr val="245CA5"/>
           </a:solidFill>
           <a:ln>
-            <a:noFill/>
-          </a:ln>
-        </p:spPr>
-        <p:style>
-          <a:lnRef idx="1">
-            <a:schemeClr val="accent1"/>
-          </a:lnRef>
-          <a:fillRef idx="3">
-            <a:schemeClr val="accent1"/>
-          </a:fillRef>
-          <a:effectRef idx="2">
-            <a:schemeClr val="accent1"/>
-          </a:effectRef>
-          <a:fontRef idx="minor">
-            <a:schemeClr val="lt1"/>
-          </a:fontRef>
-        </p:style>
-        <p:txBody>
-          <a:bodyPr rtlCol="0" anchor="ctr"/>
-          <a:lstStyle/>
-          <a:p>
-            <a:pPr algn="ctr"/>
-            <a:r>
-              <a:rPr sz="1200" b="1">
+            <a:solidFill>
+              <a:srgbClr val="245CA5"/>
+            </a:solidFill>
+          </a:ln>
+        </p:spPr>
+        <p:style>
+          <a:lnRef idx="1">
+            <a:schemeClr val="accent1"/>
+          </a:lnRef>
+          <a:fillRef idx="3">
+            <a:schemeClr val="accent1"/>
+          </a:fillRef>
+          <a:effectRef idx="2">
+            <a:schemeClr val="accent1"/>
+          </a:effectRef>
+          <a:fontRef idx="minor">
+            <a:schemeClr val="lt1"/>
+          </a:fontRef>
+        </p:style>
+        <p:txBody>
+          <a:bodyPr rtlCol="0" anchor="ctr"/>
+          <a:lstStyle/>
+          <a:p>
+            <a:pPr algn="ctr"/>
+            <a:r>
+              <a:rPr sz="1000" b="1">
                 <a:solidFill>
                   <a:srgbClr val="FFFFFF"/>
                 </a:solidFill>
               </a:rPr>
-              <a:t>핵심 기능</a:t>
+              <a:t>핵심</a:t>
             </a:r>
           </a:p>
         </p:txBody>
@@ -10896,8 +10929,8 @@
         </p:nvSpPr>
         <p:spPr>
           <a:xfrm>
-            <a:off x="667512" y="1856232"/>
-            <a:ext cx="4700016" cy="1527048"/>
+            <a:off x="667512" y="1965960"/>
+            <a:ext cx="4709160" cy="1399032"/>
           </a:xfrm>
           <a:prstGeom prst="rect">
             <a:avLst/>
@@ -10936,7 +10969,7 @@
               </a:defRPr>
             </a:pPr>
             <a:r>
-              <a:t>• Default Profile 별도 관리</a:t>
+              <a:t>• Default Profile 정책 관리</a:t>
             </a:r>
           </a:p>
           <a:p>
@@ -11003,51 +11036,53 @@
       </p:sp>
       <p:sp>
         <p:nvSpPr>
-          <p:cNvPr id="9" name="Rectangle 8"/>
-          <p:cNvSpPr/>
-          <p:nvPr/>
-        </p:nvSpPr>
-        <p:spPr>
-          <a:xfrm>
-            <a:off x="502920" y="3657600"/>
-            <a:ext cx="5029200" cy="347472"/>
-          </a:xfrm>
-          <a:prstGeom prst="rect">
+          <p:cNvPr id="9" name="Rounded Rectangle 8"/>
+          <p:cNvSpPr/>
+          <p:nvPr/>
+        </p:nvSpPr>
+        <p:spPr>
+          <a:xfrm>
+            <a:off x="640080" y="3767328"/>
+            <a:ext cx="1005840" cy="310896"/>
+          </a:xfrm>
+          <a:prstGeom prst="roundRect">
             <a:avLst/>
           </a:prstGeom>
           <a:solidFill>
             <a:srgbClr val="7159C1"/>
           </a:solidFill>
           <a:ln>
-            <a:noFill/>
-          </a:ln>
-        </p:spPr>
-        <p:style>
-          <a:lnRef idx="1">
-            <a:schemeClr val="accent1"/>
-          </a:lnRef>
-          <a:fillRef idx="3">
-            <a:schemeClr val="accent1"/>
-          </a:fillRef>
-          <a:effectRef idx="2">
-            <a:schemeClr val="accent1"/>
-          </a:effectRef>
-          <a:fontRef idx="minor">
-            <a:schemeClr val="lt1"/>
-          </a:fontRef>
-        </p:style>
-        <p:txBody>
-          <a:bodyPr rtlCol="0" anchor="ctr"/>
-          <a:lstStyle/>
-          <a:p>
-            <a:pPr algn="ctr"/>
-            <a:r>
-              <a:rPr sz="1200" b="1">
+            <a:solidFill>
+              <a:srgbClr val="7159C1"/>
+            </a:solidFill>
+          </a:ln>
+        </p:spPr>
+        <p:style>
+          <a:lnRef idx="1">
+            <a:schemeClr val="accent1"/>
+          </a:lnRef>
+          <a:fillRef idx="3">
+            <a:schemeClr val="accent1"/>
+          </a:fillRef>
+          <a:effectRef idx="2">
+            <a:schemeClr val="accent1"/>
+          </a:effectRef>
+          <a:fontRef idx="minor">
+            <a:schemeClr val="lt1"/>
+          </a:fontRef>
+        </p:style>
+        <p:txBody>
+          <a:bodyPr rtlCol="0" anchor="ctr"/>
+          <a:lstStyle/>
+          <a:p>
+            <a:pPr algn="ctr"/>
+            <a:r>
+              <a:rPr sz="1000" b="1">
                 <a:solidFill>
                   <a:srgbClr val="FFFFFF"/>
                 </a:solidFill>
               </a:rPr>
-              <a:t>보강 제안</a:t>
+              <a:t>보강</a:t>
             </a:r>
           </a:p>
         </p:txBody>
@@ -11060,8 +11095,8 @@
         </p:nvSpPr>
         <p:spPr>
           <a:xfrm>
-            <a:off x="667512" y="4096512"/>
-            <a:ext cx="4700016" cy="1252728"/>
+            <a:off x="667512" y="4206240"/>
+            <a:ext cx="4709160" cy="1124712"/>
           </a:xfrm>
           <a:prstGeom prst="rect">
             <a:avLst/>
@@ -11085,7 +11120,7 @@
               </a:defRPr>
             </a:pPr>
             <a:r>
-              <a:t>• 평균화 횟수, 샘플링 해상도</a:t>
+              <a:t>• 평균화 횟수, 샘플링 해상도 확장</a:t>
             </a:r>
           </a:p>
           <a:p>
@@ -11150,7 +11185,7 @@
               </a:defRPr>
             </a:pPr>
             <a:r>
-              <a:t>기능 구조도</a:t>
+              <a:t>상세 구조도</a:t>
             </a:r>
           </a:p>
         </p:txBody>
@@ -11163,8 +11198,8 @@
         </p:nvSpPr>
         <p:spPr>
           <a:xfrm>
-            <a:off x="6309360" y="1783080"/>
-            <a:ext cx="1143000" cy="438912"/>
+            <a:off x="6217920" y="1783080"/>
+            <a:ext cx="1097280" cy="438912"/>
           </a:xfrm>
           <a:prstGeom prst="roundRect">
             <a:avLst/>
@@ -11198,7 +11233,7 @@
           <a:p>
             <a:pPr algn="ctr"/>
             <a:r>
-              <a:rPr sz="1200" b="1">
+              <a:rPr sz="1150" b="1">
                 <a:solidFill>
                   <a:srgbClr val="FFFFFF"/>
                 </a:solidFill>
@@ -11216,7 +11251,7 @@
         </p:nvSpPr>
         <p:spPr>
           <a:xfrm>
-            <a:off x="7726679" y="1783080"/>
+            <a:off x="7543800" y="1783080"/>
             <a:ext cx="1325880" cy="438912"/>
           </a:xfrm>
           <a:prstGeom prst="roundRect">
@@ -11251,7 +11286,7 @@
           <a:p>
             <a:pPr algn="ctr"/>
             <a:r>
-              <a:rPr sz="1200" b="1">
+              <a:rPr sz="1150" b="1">
                 <a:solidFill>
                   <a:srgbClr val="FFFFFF"/>
                 </a:solidFill>
@@ -11269,119 +11304,119 @@
         </p:nvSpPr>
         <p:spPr>
           <a:xfrm>
-            <a:off x="9372600" y="1783080"/>
+            <a:off x="9144000" y="1783080"/>
+            <a:ext cx="1280160" cy="438912"/>
+          </a:xfrm>
+          <a:prstGeom prst="roundRect">
+            <a:avLst/>
+          </a:prstGeom>
+          <a:solidFill>
+            <a:srgbClr val="359961"/>
+          </a:solidFill>
+          <a:ln>
+            <a:solidFill>
+              <a:srgbClr val="359961"/>
+            </a:solidFill>
+          </a:ln>
+        </p:spPr>
+        <p:style>
+          <a:lnRef idx="1">
+            <a:schemeClr val="accent1"/>
+          </a:lnRef>
+          <a:fillRef idx="3">
+            <a:schemeClr val="accent1"/>
+          </a:fillRef>
+          <a:effectRef idx="2">
+            <a:schemeClr val="accent1"/>
+          </a:effectRef>
+          <a:fontRef idx="minor">
+            <a:schemeClr val="lt1"/>
+          </a:fontRef>
+        </p:style>
+        <p:txBody>
+          <a:bodyPr rtlCol="0" anchor="ctr"/>
+          <a:lstStyle/>
+          <a:p>
+            <a:pPr algn="ctr"/>
+            <a:r>
+              <a:rPr sz="1150" b="1">
+                <a:solidFill>
+                  <a:srgbClr val="FFFFFF"/>
+                </a:solidFill>
+              </a:rPr>
+              <a:t>정책관리</a:t>
+            </a:r>
+          </a:p>
+        </p:txBody>
+      </p:sp>
+      <p:sp>
+        <p:nvSpPr>
+          <p:cNvPr id="15" name="Rounded Rectangle 14"/>
+          <p:cNvSpPr/>
+          <p:nvPr/>
+        </p:nvSpPr>
+        <p:spPr>
+          <a:xfrm>
+            <a:off x="6903720" y="2743200"/>
             <a:ext cx="1325880" cy="438912"/>
           </a:xfrm>
           <a:prstGeom prst="roundRect">
             <a:avLst/>
           </a:prstGeom>
           <a:solidFill>
-            <a:srgbClr val="359961"/>
-          </a:solidFill>
-          <a:ln>
-            <a:solidFill>
-              <a:srgbClr val="359961"/>
-            </a:solidFill>
-          </a:ln>
-        </p:spPr>
-        <p:style>
-          <a:lnRef idx="1">
-            <a:schemeClr val="accent1"/>
-          </a:lnRef>
-          <a:fillRef idx="3">
-            <a:schemeClr val="accent1"/>
-          </a:fillRef>
-          <a:effectRef idx="2">
-            <a:schemeClr val="accent1"/>
-          </a:effectRef>
-          <a:fontRef idx="minor">
-            <a:schemeClr val="lt1"/>
-          </a:fontRef>
-        </p:style>
-        <p:txBody>
-          <a:bodyPr rtlCol="0" anchor="ctr"/>
-          <a:lstStyle/>
-          <a:p>
-            <a:pPr algn="ctr"/>
-            <a:r>
-              <a:rPr sz="1200" b="1">
+            <a:srgbClr val="7159C1"/>
+          </a:solidFill>
+          <a:ln>
+            <a:solidFill>
+              <a:srgbClr val="7159C1"/>
+            </a:solidFill>
+          </a:ln>
+        </p:spPr>
+        <p:style>
+          <a:lnRef idx="1">
+            <a:schemeClr val="accent1"/>
+          </a:lnRef>
+          <a:fillRef idx="3">
+            <a:schemeClr val="accent1"/>
+          </a:fillRef>
+          <a:effectRef idx="2">
+            <a:schemeClr val="accent1"/>
+          </a:effectRef>
+          <a:fontRef idx="minor">
+            <a:schemeClr val="lt1"/>
+          </a:fontRef>
+        </p:style>
+        <p:txBody>
+          <a:bodyPr rtlCol="0" anchor="ctr"/>
+          <a:lstStyle/>
+          <a:p>
+            <a:pPr algn="ctr"/>
+            <a:r>
+              <a:rPr sz="1150" b="1">
                 <a:solidFill>
                   <a:srgbClr val="FFFFFF"/>
                 </a:solidFill>
               </a:rPr>
-              <a:t>Default 정책</a:t>
-            </a:r>
-          </a:p>
-        </p:txBody>
-      </p:sp>
-      <p:sp>
-        <p:nvSpPr>
-          <p:cNvPr id="15" name="Rounded Rectangle 14"/>
-          <p:cNvSpPr/>
-          <p:nvPr/>
-        </p:nvSpPr>
-        <p:spPr>
-          <a:xfrm>
-            <a:off x="7178040" y="2743200"/>
+              <a:t>기본값 적용</a:t>
+            </a:r>
+          </a:p>
+        </p:txBody>
+      </p:sp>
+      <p:sp>
+        <p:nvSpPr>
+          <p:cNvPr id="16" name="Rounded Rectangle 15"/>
+          <p:cNvSpPr/>
+          <p:nvPr/>
+        </p:nvSpPr>
+        <p:spPr>
+          <a:xfrm>
+            <a:off x="8549640" y="2743200"/>
             <a:ext cx="1417320" cy="438912"/>
           </a:xfrm>
           <a:prstGeom prst="roundRect">
             <a:avLst/>
           </a:prstGeom>
           <a:solidFill>
-            <a:srgbClr val="7159C1"/>
-          </a:solidFill>
-          <a:ln>
-            <a:solidFill>
-              <a:srgbClr val="7159C1"/>
-            </a:solidFill>
-          </a:ln>
-        </p:spPr>
-        <p:style>
-          <a:lnRef idx="1">
-            <a:schemeClr val="accent1"/>
-          </a:lnRef>
-          <a:fillRef idx="3">
-            <a:schemeClr val="accent1"/>
-          </a:fillRef>
-          <a:effectRef idx="2">
-            <a:schemeClr val="accent1"/>
-          </a:effectRef>
-          <a:fontRef idx="minor">
-            <a:schemeClr val="lt1"/>
-          </a:fontRef>
-        </p:style>
-        <p:txBody>
-          <a:bodyPr rtlCol="0" anchor="ctr"/>
-          <a:lstStyle/>
-          <a:p>
-            <a:pPr algn="ctr"/>
-            <a:r>
-              <a:rPr sz="1200" b="1">
-                <a:solidFill>
-                  <a:srgbClr val="FFFFFF"/>
-                </a:solidFill>
-              </a:rPr>
-              <a:t>Profile 저장</a:t>
-            </a:r>
-          </a:p>
-        </p:txBody>
-      </p:sp>
-      <p:sp>
-        <p:nvSpPr>
-          <p:cNvPr id="16" name="Rounded Rectangle 15"/>
-          <p:cNvSpPr/>
-          <p:nvPr/>
-        </p:nvSpPr>
-        <p:spPr>
-          <a:xfrm>
-            <a:off x="8961120" y="2743200"/>
-            <a:ext cx="1417320" cy="438912"/>
-          </a:xfrm>
-          <a:prstGeom prst="roundRect">
-            <a:avLst/>
-          </a:prstGeom>
-          <a:solidFill>
             <a:srgbClr val="F4A142"/>
           </a:solidFill>
           <a:ln>
@@ -11410,7 +11445,7 @@
           <a:p>
             <a:pPr algn="ctr"/>
             <a:r>
-              <a:rPr sz="1200" b="1">
+              <a:rPr sz="1150" b="1">
                 <a:solidFill>
                   <a:srgbClr val="FFFFFF"/>
                 </a:solidFill>
@@ -11428,8 +11463,8 @@
         </p:nvSpPr>
         <p:spPr>
           <a:xfrm>
-            <a:off x="8001000" y="3749039"/>
-            <a:ext cx="1325880" cy="438912"/>
+            <a:off x="7635240" y="3749039"/>
+            <a:ext cx="1234440" cy="438912"/>
           </a:xfrm>
           <a:prstGeom prst="roundRect">
             <a:avLst/>
@@ -11463,7 +11498,7 @@
           <a:p>
             <a:pPr algn="ctr"/>
             <a:r>
-              <a:rPr sz="1200" b="1">
+              <a:rPr sz="1150" b="1">
                 <a:solidFill>
                   <a:srgbClr val="FFFFFF"/>
                 </a:solidFill>
@@ -11481,8 +11516,8 @@
         </p:nvCxnSpPr>
         <p:spPr>
           <a:xfrm>
-            <a:off x="7452360" y="2011680"/>
-            <a:ext cx="274319" cy="0"/>
+            <a:off x="7315200" y="2011680"/>
+            <a:ext cx="228600" cy="0"/>
           </a:xfrm>
           <a:prstGeom prst="line">
             <a:avLst/>
@@ -11516,7 +11551,7 @@
         </p:nvCxnSpPr>
         <p:spPr>
           <a:xfrm>
-            <a:off x="9052560" y="2011680"/>
+            <a:off x="8869680" y="2011680"/>
             <a:ext cx="274320" cy="0"/>
           </a:xfrm>
           <a:prstGeom prst="line">
@@ -11551,7 +11586,7 @@
         </p:nvCxnSpPr>
         <p:spPr>
           <a:xfrm>
-            <a:off x="8046720" y="2221992"/>
+            <a:off x="8001000" y="2221992"/>
             <a:ext cx="0" cy="502920"/>
           </a:xfrm>
           <a:prstGeom prst="line">
@@ -11586,7 +11621,7 @@
         </p:nvCxnSpPr>
         <p:spPr>
           <a:xfrm>
-            <a:off x="10012680" y="2221992"/>
+            <a:off x="9875520" y="2221992"/>
             <a:ext cx="0" cy="502920"/>
           </a:xfrm>
           <a:prstGeom prst="line">
@@ -11621,8 +11656,8 @@
         </p:nvCxnSpPr>
         <p:spPr>
           <a:xfrm flipH="1">
-            <a:off x="7086600" y="2971800"/>
-            <a:ext cx="457200" cy="0"/>
+            <a:off x="7040880" y="2971800"/>
+            <a:ext cx="411480" cy="0"/>
           </a:xfrm>
           <a:prstGeom prst="line">
             <a:avLst/>
@@ -11657,7 +11692,7 @@
         <p:spPr>
           <a:xfrm>
             <a:off x="8229600" y="2971800"/>
-            <a:ext cx="594360" cy="0"/>
+            <a:ext cx="411480" cy="0"/>
           </a:xfrm>
           <a:prstGeom prst="line">
             <a:avLst/>
@@ -11691,8 +11726,8 @@
         </p:nvCxnSpPr>
         <p:spPr>
           <a:xfrm>
-            <a:off x="7680960" y="3154680"/>
-            <a:ext cx="457200" cy="594359"/>
+            <a:off x="7635240" y="3154680"/>
+            <a:ext cx="411480" cy="594359"/>
           </a:xfrm>
           <a:prstGeom prst="line">
             <a:avLst/>
@@ -11726,8 +11761,8 @@
         </p:nvCxnSpPr>
         <p:spPr>
           <a:xfrm flipH="1">
-            <a:off x="8549640" y="3154680"/>
-            <a:ext cx="594360" cy="594359"/>
+            <a:off x="8503920" y="3154680"/>
+            <a:ext cx="548640" cy="594359"/>
           </a:xfrm>
           <a:prstGeom prst="line">
             <a:avLst/>
@@ -11905,7 +11940,7 @@
               </a:defRPr>
             </a:pPr>
             <a:r>
-              <a:t>측정 등록, 스케줄링, 실행, 상태 관리까지의 전주기 자동화</a:t>
+              <a:t>측정 등록부터 스케줄링, 실행, 상태 관리까지 자동화</a:t>
             </a:r>
           </a:p>
         </p:txBody>
@@ -11957,51 +11992,53 @@
       </p:sp>
       <p:sp>
         <p:nvSpPr>
-          <p:cNvPr id="6" name="Rectangle 5"/>
-          <p:cNvSpPr/>
-          <p:nvPr/>
-        </p:nvSpPr>
-        <p:spPr>
-          <a:xfrm>
-            <a:off x="502920" y="1417320"/>
-            <a:ext cx="5029200" cy="347472"/>
-          </a:xfrm>
-          <a:prstGeom prst="rect">
+          <p:cNvPr id="6" name="Rounded Rectangle 5"/>
+          <p:cNvSpPr/>
+          <p:nvPr/>
+        </p:nvSpPr>
+        <p:spPr>
+          <a:xfrm>
+            <a:off x="640080" y="1527048"/>
+            <a:ext cx="1005840" cy="310896"/>
+          </a:xfrm>
+          <a:prstGeom prst="roundRect">
             <a:avLst/>
           </a:prstGeom>
           <a:solidFill>
             <a:srgbClr val="245CA5"/>
           </a:solidFill>
           <a:ln>
-            <a:noFill/>
-          </a:ln>
-        </p:spPr>
-        <p:style>
-          <a:lnRef idx="1">
-            <a:schemeClr val="accent1"/>
-          </a:lnRef>
-          <a:fillRef idx="3">
-            <a:schemeClr val="accent1"/>
-          </a:fillRef>
-          <a:effectRef idx="2">
-            <a:schemeClr val="accent1"/>
-          </a:effectRef>
-          <a:fontRef idx="minor">
-            <a:schemeClr val="lt1"/>
-          </a:fontRef>
-        </p:style>
-        <p:txBody>
-          <a:bodyPr rtlCol="0" anchor="ctr"/>
-          <a:lstStyle/>
-          <a:p>
-            <a:pPr algn="ctr"/>
-            <a:r>
-              <a:rPr sz="1200" b="1">
+            <a:solidFill>
+              <a:srgbClr val="245CA5"/>
+            </a:solidFill>
+          </a:ln>
+        </p:spPr>
+        <p:style>
+          <a:lnRef idx="1">
+            <a:schemeClr val="accent1"/>
+          </a:lnRef>
+          <a:fillRef idx="3">
+            <a:schemeClr val="accent1"/>
+          </a:fillRef>
+          <a:effectRef idx="2">
+            <a:schemeClr val="accent1"/>
+          </a:effectRef>
+          <a:fontRef idx="minor">
+            <a:schemeClr val="lt1"/>
+          </a:fontRef>
+        </p:style>
+        <p:txBody>
+          <a:bodyPr rtlCol="0" anchor="ctr"/>
+          <a:lstStyle/>
+          <a:p>
+            <a:pPr algn="ctr"/>
+            <a:r>
+              <a:rPr sz="1000" b="1">
                 <a:solidFill>
                   <a:srgbClr val="FFFFFF"/>
                 </a:solidFill>
               </a:rPr>
-              <a:t>핵심 기능</a:t>
+              <a:t>핵심</a:t>
             </a:r>
           </a:p>
         </p:txBody>
@@ -12014,8 +12051,8 @@
         </p:nvSpPr>
         <p:spPr>
           <a:xfrm>
-            <a:off x="667512" y="1856232"/>
-            <a:ext cx="4700016" cy="1527048"/>
+            <a:off x="667512" y="1965960"/>
+            <a:ext cx="4709160" cy="1399032"/>
           </a:xfrm>
           <a:prstGeom prst="rect">
             <a:avLst/>
@@ -12054,7 +12091,7 @@
               </a:defRPr>
             </a:pPr>
             <a:r>
-              <a:t>• 우선순위/동시성 조건 기반 스케줄링</a:t>
+              <a:t>• 우선순위/동시성 기반 스케줄링</a:t>
             </a:r>
           </a:p>
           <a:p>
@@ -12069,7 +12106,7 @@
               </a:defRPr>
             </a:pPr>
             <a:r>
-              <a:t>• NCE 측정 요청 후 Polling 또는 Event 상태관리</a:t>
+              <a:t>• Polling 또는 Event 기반 상태 관리</a:t>
             </a:r>
           </a:p>
         </p:txBody>
@@ -12121,51 +12158,53 @@
       </p:sp>
       <p:sp>
         <p:nvSpPr>
-          <p:cNvPr id="9" name="Rectangle 8"/>
-          <p:cNvSpPr/>
-          <p:nvPr/>
-        </p:nvSpPr>
-        <p:spPr>
-          <a:xfrm>
-            <a:off x="502920" y="3657600"/>
-            <a:ext cx="5029200" cy="347472"/>
-          </a:xfrm>
-          <a:prstGeom prst="rect">
+          <p:cNvPr id="9" name="Rounded Rectangle 8"/>
+          <p:cNvSpPr/>
+          <p:nvPr/>
+        </p:nvSpPr>
+        <p:spPr>
+          <a:xfrm>
+            <a:off x="640080" y="3767328"/>
+            <a:ext cx="1005840" cy="310896"/>
+          </a:xfrm>
+          <a:prstGeom prst="roundRect">
             <a:avLst/>
           </a:prstGeom>
           <a:solidFill>
             <a:srgbClr val="7159C1"/>
           </a:solidFill>
           <a:ln>
-            <a:noFill/>
-          </a:ln>
-        </p:spPr>
-        <p:style>
-          <a:lnRef idx="1">
-            <a:schemeClr val="accent1"/>
-          </a:lnRef>
-          <a:fillRef idx="3">
-            <a:schemeClr val="accent1"/>
-          </a:fillRef>
-          <a:effectRef idx="2">
-            <a:schemeClr val="accent1"/>
-          </a:effectRef>
-          <a:fontRef idx="minor">
-            <a:schemeClr val="lt1"/>
-          </a:fontRef>
-        </p:style>
-        <p:txBody>
-          <a:bodyPr rtlCol="0" anchor="ctr"/>
-          <a:lstStyle/>
-          <a:p>
-            <a:pPr algn="ctr"/>
-            <a:r>
-              <a:rPr sz="1200" b="1">
+            <a:solidFill>
+              <a:srgbClr val="7159C1"/>
+            </a:solidFill>
+          </a:ln>
+        </p:spPr>
+        <p:style>
+          <a:lnRef idx="1">
+            <a:schemeClr val="accent1"/>
+          </a:lnRef>
+          <a:fillRef idx="3">
+            <a:schemeClr val="accent1"/>
+          </a:fillRef>
+          <a:effectRef idx="2">
+            <a:schemeClr val="accent1"/>
+          </a:effectRef>
+          <a:fontRef idx="minor">
+            <a:schemeClr val="lt1"/>
+          </a:fontRef>
+        </p:style>
+        <p:txBody>
+          <a:bodyPr rtlCol="0" anchor="ctr"/>
+          <a:lstStyle/>
+          <a:p>
+            <a:pPr algn="ctr"/>
+            <a:r>
+              <a:rPr sz="1000" b="1">
                 <a:solidFill>
                   <a:srgbClr val="FFFFFF"/>
                 </a:solidFill>
               </a:rPr>
-              <a:t>운영 설정</a:t>
+              <a:t>보강</a:t>
             </a:r>
           </a:p>
         </p:txBody>
@@ -12178,8 +12217,8 @@
         </p:nvSpPr>
         <p:spPr>
           <a:xfrm>
-            <a:off x="667512" y="4096512"/>
-            <a:ext cx="4700016" cy="1252728"/>
+            <a:off x="667512" y="4206240"/>
+            <a:ext cx="4709160" cy="1124712"/>
           </a:xfrm>
           <a:prstGeom prst="rect">
             <a:avLst/>
@@ -12268,7 +12307,7 @@
               </a:defRPr>
             </a:pPr>
             <a:r>
-              <a:t>기능 구조도</a:t>
+              <a:t>상세 구조도</a:t>
             </a:r>
           </a:p>
         </p:txBody>
@@ -12282,65 +12321,65 @@
         <p:spPr>
           <a:xfrm>
             <a:off x="6217920" y="1783080"/>
+            <a:ext cx="1234440" cy="438912"/>
+          </a:xfrm>
+          <a:prstGeom prst="roundRect">
+            <a:avLst/>
+          </a:prstGeom>
+          <a:solidFill>
+            <a:srgbClr val="245CA5"/>
+          </a:solidFill>
+          <a:ln>
+            <a:solidFill>
+              <a:srgbClr val="245CA5"/>
+            </a:solidFill>
+          </a:ln>
+        </p:spPr>
+        <p:style>
+          <a:lnRef idx="1">
+            <a:schemeClr val="accent1"/>
+          </a:lnRef>
+          <a:fillRef idx="3">
+            <a:schemeClr val="accent1"/>
+          </a:fillRef>
+          <a:effectRef idx="2">
+            <a:schemeClr val="accent1"/>
+          </a:effectRef>
+          <a:fontRef idx="minor">
+            <a:schemeClr val="lt1"/>
+          </a:fontRef>
+        </p:style>
+        <p:txBody>
+          <a:bodyPr rtlCol="0" anchor="ctr"/>
+          <a:lstStyle/>
+          <a:p>
+            <a:pPr algn="ctr"/>
+            <a:r>
+              <a:rPr sz="1150" b="1">
+                <a:solidFill>
+                  <a:srgbClr val="FFFFFF"/>
+                </a:solidFill>
+              </a:rPr>
+              <a:t>측정등록 UI</a:t>
+            </a:r>
+          </a:p>
+        </p:txBody>
+      </p:sp>
+      <p:sp>
+        <p:nvSpPr>
+          <p:cNvPr id="13" name="Rounded Rectangle 12"/>
+          <p:cNvSpPr/>
+          <p:nvPr/>
+        </p:nvSpPr>
+        <p:spPr>
+          <a:xfrm>
+            <a:off x="7680960" y="1783080"/>
             <a:ext cx="1325880" cy="438912"/>
           </a:xfrm>
           <a:prstGeom prst="roundRect">
             <a:avLst/>
           </a:prstGeom>
           <a:solidFill>
-            <a:srgbClr val="245CA5"/>
-          </a:solidFill>
-          <a:ln>
-            <a:solidFill>
-              <a:srgbClr val="245CA5"/>
-            </a:solidFill>
-          </a:ln>
-        </p:spPr>
-        <p:style>
-          <a:lnRef idx="1">
-            <a:schemeClr val="accent1"/>
-          </a:lnRef>
-          <a:fillRef idx="3">
-            <a:schemeClr val="accent1"/>
-          </a:fillRef>
-          <a:effectRef idx="2">
-            <a:schemeClr val="accent1"/>
-          </a:effectRef>
-          <a:fontRef idx="minor">
-            <a:schemeClr val="lt1"/>
-          </a:fontRef>
-        </p:style>
-        <p:txBody>
-          <a:bodyPr rtlCol="0" anchor="ctr"/>
-          <a:lstStyle/>
-          <a:p>
-            <a:pPr algn="ctr"/>
-            <a:r>
-              <a:rPr sz="1200" b="1">
-                <a:solidFill>
-                  <a:srgbClr val="FFFFFF"/>
-                </a:solidFill>
-              </a:rPr>
-              <a:t>측정 등록 UI</a:t>
-            </a:r>
-          </a:p>
-        </p:txBody>
-      </p:sp>
-      <p:sp>
-        <p:nvSpPr>
-          <p:cNvPr id="13" name="Rounded Rectangle 12"/>
-          <p:cNvSpPr/>
-          <p:nvPr/>
-        </p:nvSpPr>
-        <p:spPr>
-          <a:xfrm>
-            <a:off x="7818120" y="1783080"/>
-            <a:ext cx="1417320" cy="438912"/>
-          </a:xfrm>
-          <a:prstGeom prst="roundRect">
-            <a:avLst/>
-          </a:prstGeom>
-          <a:solidFill>
             <a:srgbClr val="4FA4E3"/>
           </a:solidFill>
           <a:ln>
@@ -12369,7 +12408,7 @@
           <a:p>
             <a:pPr algn="ctr"/>
             <a:r>
-              <a:rPr sz="1200" b="1">
+              <a:rPr sz="1150" b="1">
                 <a:solidFill>
                   <a:srgbClr val="FFFFFF"/>
                 </a:solidFill>
@@ -12387,7 +12426,7 @@
         </p:nvSpPr>
         <p:spPr>
           <a:xfrm>
-            <a:off x="9555480" y="1783080"/>
+            <a:off x="9326880" y="1783080"/>
             <a:ext cx="1143000" cy="438912"/>
           </a:xfrm>
           <a:prstGeom prst="roundRect">
@@ -12422,7 +12461,7 @@
           <a:p>
             <a:pPr algn="ctr"/>
             <a:r>
-              <a:rPr sz="1200" b="1">
+              <a:rPr sz="1150" b="1">
                 <a:solidFill>
                   <a:srgbClr val="FFFFFF"/>
                 </a:solidFill>
@@ -12441,7 +12480,7 @@
         <p:spPr>
           <a:xfrm>
             <a:off x="6949440" y="2743200"/>
-            <a:ext cx="1234440" cy="438912"/>
+            <a:ext cx="1188720" cy="438912"/>
           </a:xfrm>
           <a:prstGeom prst="roundRect">
             <a:avLst/>
@@ -12475,7 +12514,7 @@
           <a:p>
             <a:pPr algn="ctr"/>
             <a:r>
-              <a:rPr sz="1200" b="1">
+              <a:rPr sz="1150" b="1">
                 <a:solidFill>
                   <a:srgbClr val="FFFFFF"/>
                 </a:solidFill>
@@ -12493,8 +12532,8 @@
         </p:nvSpPr>
         <p:spPr>
           <a:xfrm>
-            <a:off x="8549640" y="2743200"/>
-            <a:ext cx="1234440" cy="438912"/>
+            <a:off x="8503920" y="2743200"/>
+            <a:ext cx="1188720" cy="438912"/>
           </a:xfrm>
           <a:prstGeom prst="roundRect">
             <a:avLst/>
@@ -12528,7 +12567,7 @@
           <a:p>
             <a:pPr algn="ctr"/>
             <a:r>
-              <a:rPr sz="1200" b="1">
+              <a:rPr sz="1150" b="1">
                 <a:solidFill>
                   <a:srgbClr val="FFFFFF"/>
                 </a:solidFill>
@@ -12546,7 +12585,7 @@
         </p:nvSpPr>
         <p:spPr>
           <a:xfrm>
-            <a:off x="7726679" y="3749039"/>
+            <a:off x="7680960" y="3749039"/>
             <a:ext cx="1325880" cy="438912"/>
           </a:xfrm>
           <a:prstGeom prst="roundRect">
@@ -12581,7 +12620,7 @@
           <a:p>
             <a:pPr algn="ctr"/>
             <a:r>
-              <a:rPr sz="1200" b="1">
+              <a:rPr sz="1150" b="1">
                 <a:solidFill>
                   <a:srgbClr val="FFFFFF"/>
                 </a:solidFill>
@@ -12599,8 +12638,8 @@
         </p:nvCxnSpPr>
         <p:spPr>
           <a:xfrm>
-            <a:off x="7452360" y="2011680"/>
-            <a:ext cx="274319" cy="0"/>
+            <a:off x="7315200" y="2011680"/>
+            <a:ext cx="228600" cy="0"/>
           </a:xfrm>
           <a:prstGeom prst="line">
             <a:avLst/>
@@ -12634,7 +12673,7 @@
         </p:nvCxnSpPr>
         <p:spPr>
           <a:xfrm>
-            <a:off x="9052560" y="2011680"/>
+            <a:off x="8869680" y="2011680"/>
             <a:ext cx="274320" cy="0"/>
           </a:xfrm>
           <a:prstGeom prst="line">
@@ -12669,7 +12708,7 @@
         </p:nvCxnSpPr>
         <p:spPr>
           <a:xfrm>
-            <a:off x="8046720" y="2221992"/>
+            <a:off x="8001000" y="2221992"/>
             <a:ext cx="0" cy="502920"/>
           </a:xfrm>
           <a:prstGeom prst="line">
@@ -12704,7 +12743,7 @@
         </p:nvCxnSpPr>
         <p:spPr>
           <a:xfrm>
-            <a:off x="10012680" y="2221992"/>
+            <a:off x="9875520" y="2221992"/>
             <a:ext cx="0" cy="502920"/>
           </a:xfrm>
           <a:prstGeom prst="line">
@@ -12739,8 +12778,8 @@
         </p:nvCxnSpPr>
         <p:spPr>
           <a:xfrm flipH="1">
-            <a:off x="7086600" y="2971800"/>
-            <a:ext cx="457200" cy="0"/>
+            <a:off x="7040880" y="2971800"/>
+            <a:ext cx="411480" cy="0"/>
           </a:xfrm>
           <a:prstGeom prst="line">
             <a:avLst/>
@@ -12775,7 +12814,7 @@
         <p:spPr>
           <a:xfrm>
             <a:off x="8229600" y="2971800"/>
-            <a:ext cx="594360" cy="0"/>
+            <a:ext cx="411480" cy="0"/>
           </a:xfrm>
           <a:prstGeom prst="line">
             <a:avLst/>
@@ -12809,8 +12848,8 @@
         </p:nvCxnSpPr>
         <p:spPr>
           <a:xfrm>
-            <a:off x="7680960" y="3154680"/>
-            <a:ext cx="457200" cy="594359"/>
+            <a:off x="7635240" y="3154680"/>
+            <a:ext cx="411480" cy="594359"/>
           </a:xfrm>
           <a:prstGeom prst="line">
             <a:avLst/>
@@ -12844,8 +12883,8 @@
         </p:nvCxnSpPr>
         <p:spPr>
           <a:xfrm flipH="1">
-            <a:off x="8549640" y="3154680"/>
-            <a:ext cx="594360" cy="594359"/>
+            <a:off x="8503920" y="3154680"/>
+            <a:ext cx="548640" cy="594359"/>
           </a:xfrm>
           <a:prstGeom prst="line">
             <a:avLst/>
@@ -13023,7 +13062,7 @@
               </a:defRPr>
             </a:pPr>
             <a:r>
-              <a:t>측정 결과 수집, SOR 분석, 통합 조회 화면 개선</a:t>
+              <a:t>측정 결과와 SOR 파일을 통합 분석하여 운영 가시성 강화</a:t>
             </a:r>
           </a:p>
         </p:txBody>
@@ -13075,51 +13114,53 @@
       </p:sp>
       <p:sp>
         <p:nvSpPr>
-          <p:cNvPr id="6" name="Rectangle 5"/>
-          <p:cNvSpPr/>
-          <p:nvPr/>
-        </p:nvSpPr>
-        <p:spPr>
-          <a:xfrm>
-            <a:off x="502920" y="1417320"/>
-            <a:ext cx="5029200" cy="347472"/>
-          </a:xfrm>
-          <a:prstGeom prst="rect">
+          <p:cNvPr id="6" name="Rounded Rectangle 5"/>
+          <p:cNvSpPr/>
+          <p:nvPr/>
+        </p:nvSpPr>
+        <p:spPr>
+          <a:xfrm>
+            <a:off x="640080" y="1527048"/>
+            <a:ext cx="1005840" cy="310896"/>
+          </a:xfrm>
+          <a:prstGeom prst="roundRect">
             <a:avLst/>
           </a:prstGeom>
           <a:solidFill>
             <a:srgbClr val="245CA5"/>
           </a:solidFill>
           <a:ln>
-            <a:noFill/>
-          </a:ln>
-        </p:spPr>
-        <p:style>
-          <a:lnRef idx="1">
-            <a:schemeClr val="accent1"/>
-          </a:lnRef>
-          <a:fillRef idx="3">
-            <a:schemeClr val="accent1"/>
-          </a:fillRef>
-          <a:effectRef idx="2">
-            <a:schemeClr val="accent1"/>
-          </a:effectRef>
-          <a:fontRef idx="minor">
-            <a:schemeClr val="lt1"/>
-          </a:fontRef>
-        </p:style>
-        <p:txBody>
-          <a:bodyPr rtlCol="0" anchor="ctr"/>
-          <a:lstStyle/>
-          <a:p>
-            <a:pPr algn="ctr"/>
-            <a:r>
-              <a:rPr sz="1200" b="1">
+            <a:solidFill>
+              <a:srgbClr val="245CA5"/>
+            </a:solidFill>
+          </a:ln>
+        </p:spPr>
+        <p:style>
+          <a:lnRef idx="1">
+            <a:schemeClr val="accent1"/>
+          </a:lnRef>
+          <a:fillRef idx="3">
+            <a:schemeClr val="accent1"/>
+          </a:fillRef>
+          <a:effectRef idx="2">
+            <a:schemeClr val="accent1"/>
+          </a:effectRef>
+          <a:fontRef idx="minor">
+            <a:schemeClr val="lt1"/>
+          </a:fontRef>
+        </p:style>
+        <p:txBody>
+          <a:bodyPr rtlCol="0" anchor="ctr"/>
+          <a:lstStyle/>
+          <a:p>
+            <a:pPr algn="ctr"/>
+            <a:r>
+              <a:rPr sz="1000" b="1">
                 <a:solidFill>
                   <a:srgbClr val="FFFFFF"/>
                 </a:solidFill>
               </a:rPr>
-              <a:t>핵심 기능</a:t>
+              <a:t>핵심</a:t>
             </a:r>
           </a:p>
         </p:txBody>
@@ -13132,8 +13173,8 @@
         </p:nvSpPr>
         <p:spPr>
           <a:xfrm>
-            <a:off x="667512" y="1856232"/>
-            <a:ext cx="4700016" cy="1527048"/>
+            <a:off x="667512" y="1965960"/>
+            <a:ext cx="4709160" cy="1399032"/>
           </a:xfrm>
           <a:prstGeom prst="rect">
             <a:avLst/>
@@ -13187,7 +13228,7 @@
               </a:defRPr>
             </a:pPr>
             <a:r>
-              <a:t>• 기존 결과 조회 화면에 HUAWEI 결과 통합</a:t>
+              <a:t>• 기존 조회 화면에 HUAWEI 결과 통합</a:t>
             </a:r>
           </a:p>
         </p:txBody>
@@ -13239,51 +13280,53 @@
       </p:sp>
       <p:sp>
         <p:nvSpPr>
-          <p:cNvPr id="9" name="Rectangle 8"/>
-          <p:cNvSpPr/>
-          <p:nvPr/>
-        </p:nvSpPr>
-        <p:spPr>
-          <a:xfrm>
-            <a:off x="502920" y="3657600"/>
-            <a:ext cx="5029200" cy="347472"/>
-          </a:xfrm>
-          <a:prstGeom prst="rect">
+          <p:cNvPr id="9" name="Rounded Rectangle 8"/>
+          <p:cNvSpPr/>
+          <p:nvPr/>
+        </p:nvSpPr>
+        <p:spPr>
+          <a:xfrm>
+            <a:off x="640080" y="3767328"/>
+            <a:ext cx="1005840" cy="310896"/>
+          </a:xfrm>
+          <a:prstGeom prst="roundRect">
             <a:avLst/>
           </a:prstGeom>
           <a:solidFill>
             <a:srgbClr val="7159C1"/>
           </a:solidFill>
           <a:ln>
-            <a:noFill/>
-          </a:ln>
-        </p:spPr>
-        <p:style>
-          <a:lnRef idx="1">
-            <a:schemeClr val="accent1"/>
-          </a:lnRef>
-          <a:fillRef idx="3">
-            <a:schemeClr val="accent1"/>
-          </a:fillRef>
-          <a:effectRef idx="2">
-            <a:schemeClr val="accent1"/>
-          </a:effectRef>
-          <a:fontRef idx="minor">
-            <a:schemeClr val="lt1"/>
-          </a:fontRef>
-        </p:style>
-        <p:txBody>
-          <a:bodyPr rtlCol="0" anchor="ctr"/>
-          <a:lstStyle/>
-          <a:p>
-            <a:pPr algn="ctr"/>
-            <a:r>
-              <a:rPr sz="1200" b="1">
+            <a:solidFill>
+              <a:srgbClr val="7159C1"/>
+            </a:solidFill>
+          </a:ln>
+        </p:spPr>
+        <p:style>
+          <a:lnRef idx="1">
+            <a:schemeClr val="accent1"/>
+          </a:lnRef>
+          <a:fillRef idx="3">
+            <a:schemeClr val="accent1"/>
+          </a:fillRef>
+          <a:effectRef idx="2">
+            <a:schemeClr val="accent1"/>
+          </a:effectRef>
+          <a:fontRef idx="minor">
+            <a:schemeClr val="lt1"/>
+          </a:fontRef>
+        </p:style>
+        <p:txBody>
+          <a:bodyPr rtlCol="0" anchor="ctr"/>
+          <a:lstStyle/>
+          <a:p>
+            <a:pPr algn="ctr"/>
+            <a:r>
+              <a:rPr sz="1000" b="1">
                 <a:solidFill>
                   <a:srgbClr val="FFFFFF"/>
                 </a:solidFill>
               </a:rPr>
-              <a:t>보강 제안</a:t>
+              <a:t>보강</a:t>
             </a:r>
           </a:p>
         </p:txBody>
@@ -13296,8 +13339,8 @@
         </p:nvSpPr>
         <p:spPr>
           <a:xfrm>
-            <a:off x="667512" y="4096512"/>
-            <a:ext cx="4700016" cy="1252728"/>
+            <a:off x="667512" y="4206240"/>
+            <a:ext cx="4709160" cy="1124712"/>
           </a:xfrm>
           <a:prstGeom prst="rect">
             <a:avLst/>
@@ -13351,7 +13394,7 @@
               </a:defRPr>
             </a:pPr>
             <a:r>
-              <a:t>• 비교 탐색과 결과 시각화 강화</a:t>
+              <a:t>• 비교 탐색과 시각화 강화</a:t>
             </a:r>
           </a:p>
         </p:txBody>
@@ -13386,7 +13429,7 @@
               </a:defRPr>
             </a:pPr>
             <a:r>
-              <a:t>기능 구조도</a:t>
+              <a:t>상세 구조도</a:t>
             </a:r>
           </a:p>
         </p:txBody>
@@ -13399,8 +13442,8 @@
         </p:nvSpPr>
         <p:spPr>
           <a:xfrm>
-            <a:off x="6309360" y="1783080"/>
-            <a:ext cx="1143000" cy="438912"/>
+            <a:off x="6217920" y="1783080"/>
+            <a:ext cx="1097280" cy="438912"/>
           </a:xfrm>
           <a:prstGeom prst="roundRect">
             <a:avLst/>
@@ -13434,7 +13477,7 @@
           <a:p>
             <a:pPr algn="ctr"/>
             <a:r>
-              <a:rPr sz="1200" b="1">
+              <a:rPr sz="1150" b="1">
                 <a:solidFill>
                   <a:srgbClr val="FFFFFF"/>
                 </a:solidFill>
@@ -13452,8 +13495,8 @@
         </p:nvSpPr>
         <p:spPr>
           <a:xfrm>
-            <a:off x="7726679" y="1783080"/>
-            <a:ext cx="1234440" cy="438912"/>
+            <a:off x="7543800" y="1783080"/>
+            <a:ext cx="1143000" cy="438912"/>
           </a:xfrm>
           <a:prstGeom prst="roundRect">
             <a:avLst/>
@@ -13487,7 +13530,7 @@
           <a:p>
             <a:pPr algn="ctr"/>
             <a:r>
-              <a:rPr sz="1200" b="1">
+              <a:rPr sz="1150" b="1">
                 <a:solidFill>
                   <a:srgbClr val="FFFFFF"/>
                 </a:solidFill>
@@ -13505,8 +13548,8 @@
         </p:nvSpPr>
         <p:spPr>
           <a:xfrm>
-            <a:off x="9235440" y="1783080"/>
-            <a:ext cx="1325880" cy="438912"/>
+            <a:off x="9006840" y="1783080"/>
+            <a:ext cx="1280160" cy="438912"/>
           </a:xfrm>
           <a:prstGeom prst="roundRect">
             <a:avLst/>
@@ -13540,7 +13583,7 @@
           <a:p>
             <a:pPr algn="ctr"/>
             <a:r>
-              <a:rPr sz="1200" b="1">
+              <a:rPr sz="1150" b="1">
                 <a:solidFill>
                   <a:srgbClr val="FFFFFF"/>
                 </a:solidFill>
@@ -13558,8 +13601,8 @@
         </p:nvSpPr>
         <p:spPr>
           <a:xfrm>
-            <a:off x="7086600" y="2743200"/>
-            <a:ext cx="1325880" cy="438912"/>
+            <a:off x="6949440" y="2743200"/>
+            <a:ext cx="1234440" cy="438912"/>
           </a:xfrm>
           <a:prstGeom prst="roundRect">
             <a:avLst/>
@@ -13593,7 +13636,7 @@
           <a:p>
             <a:pPr algn="ctr"/>
             <a:r>
-              <a:rPr sz="1200" b="1">
+              <a:rPr sz="1150" b="1">
                 <a:solidFill>
                   <a:srgbClr val="FFFFFF"/>
                 </a:solidFill>
@@ -13611,8 +13654,8 @@
         </p:nvSpPr>
         <p:spPr>
           <a:xfrm>
-            <a:off x="8823960" y="2743200"/>
-            <a:ext cx="1508760" cy="438912"/>
+            <a:off x="8549640" y="2743200"/>
+            <a:ext cx="1280160" cy="438912"/>
           </a:xfrm>
           <a:prstGeom prst="roundRect">
             <a:avLst/>
@@ -13646,12 +13689,12 @@
           <a:p>
             <a:pPr algn="ctr"/>
             <a:r>
-              <a:rPr sz="1200" b="1">
+              <a:rPr sz="1150" b="1">
                 <a:solidFill>
                   <a:srgbClr val="FFFFFF"/>
                 </a:solidFill>
               </a:rPr>
-              <a:t>통합 조회 UI</a:t>
+              <a:t>통합 조회</a:t>
             </a:r>
           </a:p>
         </p:txBody>
@@ -13664,7 +13707,7 @@
         </p:nvSpPr>
         <p:spPr>
           <a:xfrm>
-            <a:off x="7818120" y="3749039"/>
+            <a:off x="7726679" y="3749039"/>
             <a:ext cx="1325880" cy="438912"/>
           </a:xfrm>
           <a:prstGeom prst="roundRect">
@@ -13699,12 +13742,12 @@
           <a:p>
             <a:pPr algn="ctr"/>
             <a:r>
-              <a:rPr sz="1200" b="1">
+              <a:rPr sz="1150" b="1">
                 <a:solidFill>
                   <a:srgbClr val="FFFFFF"/>
                 </a:solidFill>
               </a:rPr>
-              <a:t>이력 비교</a:t>
+              <a:t>비교/이력</a:t>
             </a:r>
           </a:p>
         </p:txBody>
@@ -13717,8 +13760,8 @@
         </p:nvCxnSpPr>
         <p:spPr>
           <a:xfrm>
-            <a:off x="7452360" y="2011680"/>
-            <a:ext cx="274319" cy="0"/>
+            <a:off x="7315200" y="2011680"/>
+            <a:ext cx="228600" cy="0"/>
           </a:xfrm>
           <a:prstGeom prst="line">
             <a:avLst/>
@@ -13752,7 +13795,7 @@
         </p:nvCxnSpPr>
         <p:spPr>
           <a:xfrm>
-            <a:off x="9052560" y="2011680"/>
+            <a:off x="8869680" y="2011680"/>
             <a:ext cx="274320" cy="0"/>
           </a:xfrm>
           <a:prstGeom prst="line">
@@ -13787,7 +13830,7 @@
         </p:nvCxnSpPr>
         <p:spPr>
           <a:xfrm>
-            <a:off x="8046720" y="2221992"/>
+            <a:off x="8001000" y="2221992"/>
             <a:ext cx="0" cy="502920"/>
           </a:xfrm>
           <a:prstGeom prst="line">
@@ -13822,7 +13865,7 @@
         </p:nvCxnSpPr>
         <p:spPr>
           <a:xfrm>
-            <a:off x="10012680" y="2221992"/>
+            <a:off x="9875520" y="2221992"/>
             <a:ext cx="0" cy="502920"/>
           </a:xfrm>
           <a:prstGeom prst="line">
@@ -13857,8 +13900,8 @@
         </p:nvCxnSpPr>
         <p:spPr>
           <a:xfrm flipH="1">
-            <a:off x="7086600" y="2971800"/>
-            <a:ext cx="457200" cy="0"/>
+            <a:off x="7040880" y="2971800"/>
+            <a:ext cx="411480" cy="0"/>
           </a:xfrm>
           <a:prstGeom prst="line">
             <a:avLst/>
@@ -13893,7 +13936,7 @@
         <p:spPr>
           <a:xfrm>
             <a:off x="8229600" y="2971800"/>
-            <a:ext cx="594360" cy="0"/>
+            <a:ext cx="411480" cy="0"/>
           </a:xfrm>
           <a:prstGeom prst="line">
             <a:avLst/>
@@ -13927,8 +13970,8 @@
         </p:nvCxnSpPr>
         <p:spPr>
           <a:xfrm>
-            <a:off x="7680960" y="3154680"/>
-            <a:ext cx="457200" cy="594359"/>
+            <a:off x="7635240" y="3154680"/>
+            <a:ext cx="411480" cy="594359"/>
           </a:xfrm>
           <a:prstGeom prst="line">
             <a:avLst/>
@@ -13962,8 +14005,8 @@
         </p:nvCxnSpPr>
         <p:spPr>
           <a:xfrm flipH="1">
-            <a:off x="8549640" y="3154680"/>
-            <a:ext cx="594360" cy="594359"/>
+            <a:off x="8503920" y="3154680"/>
+            <a:ext cx="548640" cy="594359"/>
           </a:xfrm>
           <a:prstGeom prst="line">
             <a:avLst/>
@@ -14141,7 +14184,7 @@
               </a:defRPr>
             </a:pPr>
             <a:r>
-              <a:t>자동점검 이력 탐색과 결과 수집/저장 및 실시간 연동 검토</a:t>
+              <a:t>자동점검 이력 탐색과 결과 저장을 자동화해 운영 부하 절감</a:t>
             </a:r>
           </a:p>
         </p:txBody>
@@ -14193,51 +14236,53 @@
       </p:sp>
       <p:sp>
         <p:nvSpPr>
-          <p:cNvPr id="6" name="Rectangle 5"/>
-          <p:cNvSpPr/>
-          <p:nvPr/>
-        </p:nvSpPr>
-        <p:spPr>
-          <a:xfrm>
-            <a:off x="502920" y="1417320"/>
-            <a:ext cx="5029200" cy="347472"/>
-          </a:xfrm>
-          <a:prstGeom prst="rect">
+          <p:cNvPr id="6" name="Rounded Rectangle 5"/>
+          <p:cNvSpPr/>
+          <p:nvPr/>
+        </p:nvSpPr>
+        <p:spPr>
+          <a:xfrm>
+            <a:off x="640080" y="1527048"/>
+            <a:ext cx="1005840" cy="310896"/>
+          </a:xfrm>
+          <a:prstGeom prst="roundRect">
             <a:avLst/>
           </a:prstGeom>
           <a:solidFill>
             <a:srgbClr val="245CA5"/>
           </a:solidFill>
           <a:ln>
-            <a:noFill/>
-          </a:ln>
-        </p:spPr>
-        <p:style>
-          <a:lnRef idx="1">
-            <a:schemeClr val="accent1"/>
-          </a:lnRef>
-          <a:fillRef idx="3">
-            <a:schemeClr val="accent1"/>
-          </a:fillRef>
-          <a:effectRef idx="2">
-            <a:schemeClr val="accent1"/>
-          </a:effectRef>
-          <a:fontRef idx="minor">
-            <a:schemeClr val="lt1"/>
-          </a:fontRef>
-        </p:style>
-        <p:txBody>
-          <a:bodyPr rtlCol="0" anchor="ctr"/>
-          <a:lstStyle/>
-          <a:p>
-            <a:pPr algn="ctr"/>
-            <a:r>
-              <a:rPr sz="1200" b="1">
+            <a:solidFill>
+              <a:srgbClr val="245CA5"/>
+            </a:solidFill>
+          </a:ln>
+        </p:spPr>
+        <p:style>
+          <a:lnRef idx="1">
+            <a:schemeClr val="accent1"/>
+          </a:lnRef>
+          <a:fillRef idx="3">
+            <a:schemeClr val="accent1"/>
+          </a:fillRef>
+          <a:effectRef idx="2">
+            <a:schemeClr val="accent1"/>
+          </a:effectRef>
+          <a:fontRef idx="minor">
+            <a:schemeClr val="lt1"/>
+          </a:fontRef>
+        </p:style>
+        <p:txBody>
+          <a:bodyPr rtlCol="0" anchor="ctr"/>
+          <a:lstStyle/>
+          <a:p>
+            <a:pPr algn="ctr"/>
+            <a:r>
+              <a:rPr sz="1000" b="1">
                 <a:solidFill>
                   <a:srgbClr val="FFFFFF"/>
                 </a:solidFill>
               </a:rPr>
-              <a:t>핵심 기능</a:t>
+              <a:t>핵심</a:t>
             </a:r>
           </a:p>
         </p:txBody>
@@ -14250,8 +14295,8 @@
         </p:nvSpPr>
         <p:spPr>
           <a:xfrm>
-            <a:off x="667512" y="1856232"/>
-            <a:ext cx="4700016" cy="1527048"/>
+            <a:off x="667512" y="1965960"/>
+            <a:ext cx="4709160" cy="1399032"/>
           </a:xfrm>
           <a:prstGeom prst="rect">
             <a:avLst/>
@@ -14290,7 +14335,7 @@
               </a:defRPr>
             </a:pPr>
             <a:r>
-              <a:t>• 수동/자동 측정 혼재 환경에서 자동점검 Task 분류</a:t>
+              <a:t>• 자동/수동 측정 혼재 환경 분류 로직</a:t>
             </a:r>
           </a:p>
           <a:p>
@@ -14305,7 +14350,7 @@
               </a:defRPr>
             </a:pPr>
             <a:r>
-              <a:t>• 자동점검 결과 수집/분석/저장 후 UI 조회</a:t>
+              <a:t>• 자동점검 결과 수집/분석/저장</a:t>
             </a:r>
           </a:p>
         </p:txBody>
@@ -14357,51 +14402,53 @@
       </p:sp>
       <p:sp>
         <p:nvSpPr>
-          <p:cNvPr id="9" name="Rectangle 8"/>
-          <p:cNvSpPr/>
-          <p:nvPr/>
-        </p:nvSpPr>
-        <p:spPr>
-          <a:xfrm>
-            <a:off x="502920" y="3657600"/>
-            <a:ext cx="5029200" cy="347472"/>
-          </a:xfrm>
-          <a:prstGeom prst="rect">
+          <p:cNvPr id="9" name="Rounded Rectangle 8"/>
+          <p:cNvSpPr/>
+          <p:nvPr/>
+        </p:nvSpPr>
+        <p:spPr>
+          <a:xfrm>
+            <a:off x="640080" y="3767328"/>
+            <a:ext cx="1005840" cy="310896"/>
+          </a:xfrm>
+          <a:prstGeom prst="roundRect">
             <a:avLst/>
           </a:prstGeom>
           <a:solidFill>
             <a:srgbClr val="7159C1"/>
           </a:solidFill>
           <a:ln>
-            <a:noFill/>
-          </a:ln>
-        </p:spPr>
-        <p:style>
-          <a:lnRef idx="1">
-            <a:schemeClr val="accent1"/>
-          </a:lnRef>
-          <a:fillRef idx="3">
-            <a:schemeClr val="accent1"/>
-          </a:fillRef>
-          <a:effectRef idx="2">
-            <a:schemeClr val="accent1"/>
-          </a:effectRef>
-          <a:fontRef idx="minor">
-            <a:schemeClr val="lt1"/>
-          </a:fontRef>
-        </p:style>
-        <p:txBody>
-          <a:bodyPr rtlCol="0" anchor="ctr"/>
-          <a:lstStyle/>
-          <a:p>
-            <a:pPr algn="ctr"/>
-            <a:r>
-              <a:rPr sz="1200" b="1">
+            <a:solidFill>
+              <a:srgbClr val="7159C1"/>
+            </a:solidFill>
+          </a:ln>
+        </p:spPr>
+        <p:style>
+          <a:lnRef idx="1">
+            <a:schemeClr val="accent1"/>
+          </a:lnRef>
+          <a:fillRef idx="3">
+            <a:schemeClr val="accent1"/>
+          </a:fillRef>
+          <a:effectRef idx="2">
+            <a:schemeClr val="accent1"/>
+          </a:effectRef>
+          <a:fontRef idx="minor">
+            <a:schemeClr val="lt1"/>
+          </a:fontRef>
+        </p:style>
+        <p:txBody>
+          <a:bodyPr rtlCol="0" anchor="ctr"/>
+          <a:lstStyle/>
+          <a:p>
+            <a:pPr algn="ctr"/>
+            <a:r>
+              <a:rPr sz="1000" b="1">
                 <a:solidFill>
                   <a:srgbClr val="FFFFFF"/>
                 </a:solidFill>
               </a:rPr>
-              <a:t>운영 방향</a:t>
+              <a:t>보강</a:t>
             </a:r>
           </a:p>
         </p:txBody>
@@ -14414,8 +14461,8 @@
         </p:nvSpPr>
         <p:spPr>
           <a:xfrm>
-            <a:off x="667512" y="4096512"/>
-            <a:ext cx="4700016" cy="1252728"/>
+            <a:off x="667512" y="4206240"/>
+            <a:ext cx="4709160" cy="1124712"/>
           </a:xfrm>
           <a:prstGeom prst="rect">
             <a:avLst/>
@@ -14454,7 +14501,7 @@
               </a:defRPr>
             </a:pPr>
             <a:r>
-              <a:t>• 이벤트 실시간 연동 방안 검토</a:t>
+              <a:t>• 실시간 이벤트 연동 검토</a:t>
             </a:r>
           </a:p>
           <a:p>
@@ -14504,7 +14551,7 @@
               </a:defRPr>
             </a:pPr>
             <a:r>
-              <a:t>기능 구조도</a:t>
+              <a:t>상세 구조도</a:t>
             </a:r>
           </a:p>
         </p:txBody>
@@ -14518,7 +14565,7 @@
         <p:spPr>
           <a:xfrm>
             <a:off x="6217920" y="1783080"/>
-            <a:ext cx="1417320" cy="438912"/>
+            <a:ext cx="1097280" cy="438912"/>
           </a:xfrm>
           <a:prstGeom prst="roundRect">
             <a:avLst/>
@@ -14552,12 +14599,12 @@
           <a:p>
             <a:pPr algn="ctr"/>
             <a:r>
-              <a:rPr sz="1200" b="1">
+              <a:rPr sz="1150" b="1">
                 <a:solidFill>
                   <a:srgbClr val="FFFFFF"/>
                 </a:solidFill>
               </a:rPr>
-              <a:t>EMS Task 이력</a:t>
+              <a:t>EMS 이력</a:t>
             </a:r>
           </a:p>
         </p:txBody>
@@ -14570,7 +14617,7 @@
         </p:nvSpPr>
         <p:spPr>
           <a:xfrm>
-            <a:off x="7955279" y="1783080"/>
+            <a:off x="7543800" y="1783080"/>
             <a:ext cx="1325880" cy="438912"/>
           </a:xfrm>
           <a:prstGeom prst="roundRect">
@@ -14605,7 +14652,7 @@
           <a:p>
             <a:pPr algn="ctr"/>
             <a:r>
-              <a:rPr sz="1200" b="1">
+              <a:rPr sz="1150" b="1">
                 <a:solidFill>
                   <a:srgbClr val="FFFFFF"/>
                 </a:solidFill>
@@ -14623,8 +14670,8 @@
         </p:nvSpPr>
         <p:spPr>
           <a:xfrm>
-            <a:off x="9601200" y="1783080"/>
-            <a:ext cx="1325880" cy="438912"/>
+            <a:off x="9144000" y="1783080"/>
+            <a:ext cx="1417320" cy="438912"/>
           </a:xfrm>
           <a:prstGeom prst="roundRect">
             <a:avLst/>
@@ -14658,7 +14705,7 @@
           <a:p>
             <a:pPr algn="ctr"/>
             <a:r>
-              <a:rPr sz="1200" b="1">
+              <a:rPr sz="1150" b="1">
                 <a:solidFill>
                   <a:srgbClr val="FFFFFF"/>
                 </a:solidFill>
@@ -14676,8 +14723,8 @@
         </p:nvSpPr>
         <p:spPr>
           <a:xfrm>
-            <a:off x="7178040" y="2743200"/>
-            <a:ext cx="1325880" cy="438912"/>
+            <a:off x="6995160" y="2743200"/>
+            <a:ext cx="1234440" cy="438912"/>
           </a:xfrm>
           <a:prstGeom prst="roundRect">
             <a:avLst/>
@@ -14711,7 +14758,7 @@
           <a:p>
             <a:pPr algn="ctr"/>
             <a:r>
-              <a:rPr sz="1200" b="1">
+              <a:rPr sz="1150" b="1">
                 <a:solidFill>
                   <a:srgbClr val="FFFFFF"/>
                 </a:solidFill>
@@ -14729,8 +14776,8 @@
         </p:nvSpPr>
         <p:spPr>
           <a:xfrm>
-            <a:off x="8869680" y="2743200"/>
-            <a:ext cx="1417320" cy="438912"/>
+            <a:off x="8549640" y="2743200"/>
+            <a:ext cx="1371600" cy="438912"/>
           </a:xfrm>
           <a:prstGeom prst="roundRect">
             <a:avLst/>
@@ -14764,7 +14811,7 @@
           <a:p>
             <a:pPr algn="ctr"/>
             <a:r>
-              <a:rPr sz="1200" b="1">
+              <a:rPr sz="1150" b="1">
                 <a:solidFill>
                   <a:srgbClr val="FFFFFF"/>
                 </a:solidFill>
@@ -14782,7 +14829,7 @@
         </p:nvSpPr>
         <p:spPr>
           <a:xfrm>
-            <a:off x="8001000" y="3749039"/>
+            <a:off x="7726679" y="3749039"/>
             <a:ext cx="1234440" cy="438912"/>
           </a:xfrm>
           <a:prstGeom prst="roundRect">
@@ -14817,7 +14864,7 @@
           <a:p>
             <a:pPr algn="ctr"/>
             <a:r>
-              <a:rPr sz="1200" b="1">
+              <a:rPr sz="1150" b="1">
                 <a:solidFill>
                   <a:srgbClr val="FFFFFF"/>
                 </a:solidFill>
@@ -14835,8 +14882,8 @@
         </p:nvCxnSpPr>
         <p:spPr>
           <a:xfrm>
-            <a:off x="7452360" y="2011680"/>
-            <a:ext cx="274319" cy="0"/>
+            <a:off x="7315200" y="2011680"/>
+            <a:ext cx="228600" cy="0"/>
           </a:xfrm>
           <a:prstGeom prst="line">
             <a:avLst/>
@@ -14870,7 +14917,7 @@
         </p:nvCxnSpPr>
         <p:spPr>
           <a:xfrm>
-            <a:off x="9052560" y="2011680"/>
+            <a:off x="8869680" y="2011680"/>
             <a:ext cx="274320" cy="0"/>
           </a:xfrm>
           <a:prstGeom prst="line">
@@ -14905,7 +14952,7 @@
         </p:nvCxnSpPr>
         <p:spPr>
           <a:xfrm>
-            <a:off x="8046720" y="2221992"/>
+            <a:off x="8001000" y="2221992"/>
             <a:ext cx="0" cy="502920"/>
           </a:xfrm>
           <a:prstGeom prst="line">
@@ -14940,7 +14987,7 @@
         </p:nvCxnSpPr>
         <p:spPr>
           <a:xfrm>
-            <a:off x="10012680" y="2221992"/>
+            <a:off x="9875520" y="2221992"/>
             <a:ext cx="0" cy="502920"/>
           </a:xfrm>
           <a:prstGeom prst="line">
@@ -14975,8 +15022,8 @@
         </p:nvCxnSpPr>
         <p:spPr>
           <a:xfrm flipH="1">
-            <a:off x="7086600" y="2971800"/>
-            <a:ext cx="457200" cy="0"/>
+            <a:off x="7040880" y="2971800"/>
+            <a:ext cx="411480" cy="0"/>
           </a:xfrm>
           <a:prstGeom prst="line">
             <a:avLst/>
@@ -15011,7 +15058,7 @@
         <p:spPr>
           <a:xfrm>
             <a:off x="8229600" y="2971800"/>
-            <a:ext cx="594360" cy="0"/>
+            <a:ext cx="411480" cy="0"/>
           </a:xfrm>
           <a:prstGeom prst="line">
             <a:avLst/>
@@ -15045,8 +15092,8 @@
         </p:nvCxnSpPr>
         <p:spPr>
           <a:xfrm>
-            <a:off x="7680960" y="3154680"/>
-            <a:ext cx="457200" cy="594359"/>
+            <a:off x="7635240" y="3154680"/>
+            <a:ext cx="411480" cy="594359"/>
           </a:xfrm>
           <a:prstGeom prst="line">
             <a:avLst/>
@@ -15080,8 +15127,8 @@
         </p:nvCxnSpPr>
         <p:spPr>
           <a:xfrm flipH="1">
-            <a:off x="8549640" y="3154680"/>
-            <a:ext cx="594360" cy="594359"/>
+            <a:off x="8503920" y="3154680"/>
+            <a:ext cx="548640" cy="594359"/>
           </a:xfrm>
           <a:prstGeom prst="line">
             <a:avLst/>
@@ -15259,7 +15306,7 @@
               </a:defRPr>
             </a:pPr>
             <a:r>
-              <a:t>수동 업로드 기반 구성정보 갱신을 M2M 방식으로 자동화</a:t>
+              <a:t>수동 업로드를 M2M 연동으로 전환해 구성정보 최신성 확보</a:t>
             </a:r>
           </a:p>
         </p:txBody>
@@ -15311,51 +15358,53 @@
       </p:sp>
       <p:sp>
         <p:nvSpPr>
-          <p:cNvPr id="6" name="Rectangle 5"/>
-          <p:cNvSpPr/>
-          <p:nvPr/>
-        </p:nvSpPr>
-        <p:spPr>
-          <a:xfrm>
-            <a:off x="502920" y="1417320"/>
-            <a:ext cx="5029200" cy="347472"/>
-          </a:xfrm>
-          <a:prstGeom prst="rect">
+          <p:cNvPr id="6" name="Rounded Rectangle 5"/>
+          <p:cNvSpPr/>
+          <p:nvPr/>
+        </p:nvSpPr>
+        <p:spPr>
+          <a:xfrm>
+            <a:off x="640080" y="1527048"/>
+            <a:ext cx="1005840" cy="310896"/>
+          </a:xfrm>
+          <a:prstGeom prst="roundRect">
             <a:avLst/>
           </a:prstGeom>
           <a:solidFill>
             <a:srgbClr val="245CA5"/>
           </a:solidFill>
           <a:ln>
-            <a:noFill/>
-          </a:ln>
-        </p:spPr>
-        <p:style>
-          <a:lnRef idx="1">
-            <a:schemeClr val="accent1"/>
-          </a:lnRef>
-          <a:fillRef idx="3">
-            <a:schemeClr val="accent1"/>
-          </a:fillRef>
-          <a:effectRef idx="2">
-            <a:schemeClr val="accent1"/>
-          </a:effectRef>
-          <a:fontRef idx="minor">
-            <a:schemeClr val="lt1"/>
-          </a:fontRef>
-        </p:style>
-        <p:txBody>
-          <a:bodyPr rtlCol="0" anchor="ctr"/>
-          <a:lstStyle/>
-          <a:p>
-            <a:pPr algn="ctr"/>
-            <a:r>
-              <a:rPr sz="1200" b="1">
+            <a:solidFill>
+              <a:srgbClr val="245CA5"/>
+            </a:solidFill>
+          </a:ln>
+        </p:spPr>
+        <p:style>
+          <a:lnRef idx="1">
+            <a:schemeClr val="accent1"/>
+          </a:lnRef>
+          <a:fillRef idx="3">
+            <a:schemeClr val="accent1"/>
+          </a:fillRef>
+          <a:effectRef idx="2">
+            <a:schemeClr val="accent1"/>
+          </a:effectRef>
+          <a:fontRef idx="minor">
+            <a:schemeClr val="lt1"/>
+          </a:fontRef>
+        </p:style>
+        <p:txBody>
+          <a:bodyPr rtlCol="0" anchor="ctr"/>
+          <a:lstStyle/>
+          <a:p>
+            <a:pPr algn="ctr"/>
+            <a:r>
+              <a:rPr sz="1000" b="1">
                 <a:solidFill>
                   <a:srgbClr val="FFFFFF"/>
                 </a:solidFill>
               </a:rPr>
-              <a:t>핵심 기능</a:t>
+              <a:t>핵심</a:t>
             </a:r>
           </a:p>
         </p:txBody>
@@ -15368,8 +15417,8 @@
         </p:nvSpPr>
         <p:spPr>
           <a:xfrm>
-            <a:off x="667512" y="1856232"/>
-            <a:ext cx="4700016" cy="1527048"/>
+            <a:off x="667512" y="1965960"/>
+            <a:ext cx="4709160" cy="1399032"/>
           </a:xfrm>
           <a:prstGeom prst="rect">
             <a:avLst/>
@@ -15408,7 +15457,7 @@
               </a:defRPr>
             </a:pPr>
             <a:r>
-              <a:t>• REST API/Kafka/SFTP 등 규격 협의 후 개발</a:t>
+              <a:t>• REST API/Kafka/SFTP 규격 협의 후 구현</a:t>
             </a:r>
           </a:p>
           <a:p>
@@ -15475,51 +15524,53 @@
       </p:sp>
       <p:sp>
         <p:nvSpPr>
-          <p:cNvPr id="9" name="Rectangle 8"/>
-          <p:cNvSpPr/>
-          <p:nvPr/>
-        </p:nvSpPr>
-        <p:spPr>
-          <a:xfrm>
-            <a:off x="502920" y="3657600"/>
-            <a:ext cx="5029200" cy="347472"/>
-          </a:xfrm>
-          <a:prstGeom prst="rect">
+          <p:cNvPr id="9" name="Rounded Rectangle 8"/>
+          <p:cNvSpPr/>
+          <p:nvPr/>
+        </p:nvSpPr>
+        <p:spPr>
+          <a:xfrm>
+            <a:off x="640080" y="3767328"/>
+            <a:ext cx="1005840" cy="310896"/>
+          </a:xfrm>
+          <a:prstGeom prst="roundRect">
             <a:avLst/>
           </a:prstGeom>
           <a:solidFill>
             <a:srgbClr val="7159C1"/>
           </a:solidFill>
           <a:ln>
-            <a:noFill/>
-          </a:ln>
-        </p:spPr>
-        <p:style>
-          <a:lnRef idx="1">
-            <a:schemeClr val="accent1"/>
-          </a:lnRef>
-          <a:fillRef idx="3">
-            <a:schemeClr val="accent1"/>
-          </a:fillRef>
-          <a:effectRef idx="2">
-            <a:schemeClr val="accent1"/>
-          </a:effectRef>
-          <a:fontRef idx="minor">
-            <a:schemeClr val="lt1"/>
-          </a:fontRef>
-        </p:style>
-        <p:txBody>
-          <a:bodyPr rtlCol="0" anchor="ctr"/>
-          <a:lstStyle/>
-          <a:p>
-            <a:pPr algn="ctr"/>
-            <a:r>
-              <a:rPr sz="1200" b="1">
+            <a:solidFill>
+              <a:srgbClr val="7159C1"/>
+            </a:solidFill>
+          </a:ln>
+        </p:spPr>
+        <p:style>
+          <a:lnRef idx="1">
+            <a:schemeClr val="accent1"/>
+          </a:lnRef>
+          <a:fillRef idx="3">
+            <a:schemeClr val="accent1"/>
+          </a:fillRef>
+          <a:effectRef idx="2">
+            <a:schemeClr val="accent1"/>
+          </a:effectRef>
+          <a:fontRef idx="minor">
+            <a:schemeClr val="lt1"/>
+          </a:fontRef>
+        </p:style>
+        <p:txBody>
+          <a:bodyPr rtlCol="0" anchor="ctr"/>
+          <a:lstStyle/>
+          <a:p>
+            <a:pPr algn="ctr"/>
+            <a:r>
+              <a:rPr sz="1000" b="1">
                 <a:solidFill>
                   <a:srgbClr val="FFFFFF"/>
                 </a:solidFill>
               </a:rPr>
-              <a:t>기대 효과</a:t>
+              <a:t>보강</a:t>
             </a:r>
           </a:p>
         </p:txBody>
@@ -15532,8 +15583,8 @@
         </p:nvSpPr>
         <p:spPr>
           <a:xfrm>
-            <a:off x="667512" y="4096512"/>
-            <a:ext cx="4700016" cy="1252728"/>
+            <a:off x="667512" y="4206240"/>
+            <a:ext cx="4709160" cy="1124712"/>
           </a:xfrm>
           <a:prstGeom prst="rect">
             <a:avLst/>
@@ -15622,7 +15673,7 @@
               </a:defRPr>
             </a:pPr>
             <a:r>
-              <a:t>기능 구조도</a:t>
+              <a:t>상세 구조도</a:t>
             </a:r>
           </a:p>
         </p:txBody>
@@ -15635,8 +15686,8 @@
         </p:nvSpPr>
         <p:spPr>
           <a:xfrm>
-            <a:off x="6309360" y="1783080"/>
-            <a:ext cx="1234440" cy="438912"/>
+            <a:off x="6217920" y="1783080"/>
+            <a:ext cx="1143000" cy="438912"/>
           </a:xfrm>
           <a:prstGeom prst="roundRect">
             <a:avLst/>
@@ -15670,7 +15721,7 @@
           <a:p>
             <a:pPr algn="ctr"/>
             <a:r>
-              <a:rPr sz="1200" b="1">
+              <a:rPr sz="1150" b="1">
                 <a:solidFill>
                   <a:srgbClr val="FFFFFF"/>
                 </a:solidFill>
@@ -15688,8 +15739,8 @@
         </p:nvSpPr>
         <p:spPr>
           <a:xfrm>
-            <a:off x="7818120" y="1783080"/>
-            <a:ext cx="1234440" cy="438912"/>
+            <a:off x="7589520" y="1783080"/>
+            <a:ext cx="1188720" cy="438912"/>
           </a:xfrm>
           <a:prstGeom prst="roundRect">
             <a:avLst/>
@@ -15723,7 +15774,7 @@
           <a:p>
             <a:pPr algn="ctr"/>
             <a:r>
-              <a:rPr sz="1200" b="1">
+              <a:rPr sz="1150" b="1">
                 <a:solidFill>
                   <a:srgbClr val="FFFFFF"/>
                 </a:solidFill>
@@ -15741,7 +15792,7 @@
         </p:nvSpPr>
         <p:spPr>
           <a:xfrm>
-            <a:off x="9326880" y="1783080"/>
+            <a:off x="9098280" y="1783080"/>
             <a:ext cx="1234440" cy="438912"/>
           </a:xfrm>
           <a:prstGeom prst="roundRect">
@@ -15776,7 +15827,7 @@
           <a:p>
             <a:pPr algn="ctr"/>
             <a:r>
-              <a:rPr sz="1200" b="1">
+              <a:rPr sz="1150" b="1">
                 <a:solidFill>
                   <a:srgbClr val="FFFFFF"/>
                 </a:solidFill>
@@ -15794,8 +15845,8 @@
         </p:nvSpPr>
         <p:spPr>
           <a:xfrm>
-            <a:off x="7086600" y="2743200"/>
-            <a:ext cx="1417320" cy="438912"/>
+            <a:off x="7040880" y="2743200"/>
+            <a:ext cx="1325880" cy="438912"/>
           </a:xfrm>
           <a:prstGeom prst="roundRect">
             <a:avLst/>
@@ -15829,7 +15880,7 @@
           <a:p>
             <a:pPr algn="ctr"/>
             <a:r>
-              <a:rPr sz="1200" b="1">
+              <a:rPr sz="1150" b="1">
                 <a:solidFill>
                   <a:srgbClr val="FFFFFF"/>
                 </a:solidFill>
@@ -15847,8 +15898,8 @@
         </p:nvSpPr>
         <p:spPr>
           <a:xfrm>
-            <a:off x="8915400" y="2743200"/>
-            <a:ext cx="1234440" cy="438912"/>
+            <a:off x="8732520" y="2743200"/>
+            <a:ext cx="1097280" cy="438912"/>
           </a:xfrm>
           <a:prstGeom prst="roundRect">
             <a:avLst/>
@@ -15882,7 +15933,7 @@
           <a:p>
             <a:pPr algn="ctr"/>
             <a:r>
-              <a:rPr sz="1200" b="1">
+              <a:rPr sz="1150" b="1">
                 <a:solidFill>
                   <a:srgbClr val="FFFFFF"/>
                 </a:solidFill>
@@ -15900,7 +15951,7 @@
         </p:nvSpPr>
         <p:spPr>
           <a:xfrm>
-            <a:off x="7909560" y="3749039"/>
+            <a:off x="7726679" y="3749039"/>
             <a:ext cx="1417320" cy="438912"/>
           </a:xfrm>
           <a:prstGeom prst="roundRect">
@@ -15935,7 +15986,7 @@
           <a:p>
             <a:pPr algn="ctr"/>
             <a:r>
-              <a:rPr sz="1200" b="1">
+              <a:rPr sz="1150" b="1">
                 <a:solidFill>
                   <a:srgbClr val="FFFFFF"/>
                 </a:solidFill>
@@ -15953,8 +16004,8 @@
         </p:nvCxnSpPr>
         <p:spPr>
           <a:xfrm>
-            <a:off x="7452360" y="2011680"/>
-            <a:ext cx="274319" cy="0"/>
+            <a:off x="7315200" y="2011680"/>
+            <a:ext cx="228600" cy="0"/>
           </a:xfrm>
           <a:prstGeom prst="line">
             <a:avLst/>
@@ -15988,7 +16039,7 @@
         </p:nvCxnSpPr>
         <p:spPr>
           <a:xfrm>
-            <a:off x="9052560" y="2011680"/>
+            <a:off x="8869680" y="2011680"/>
             <a:ext cx="274320" cy="0"/>
           </a:xfrm>
           <a:prstGeom prst="line">
@@ -16023,7 +16074,7 @@
         </p:nvCxnSpPr>
         <p:spPr>
           <a:xfrm>
-            <a:off x="8046720" y="2221992"/>
+            <a:off x="8001000" y="2221992"/>
             <a:ext cx="0" cy="502920"/>
           </a:xfrm>
           <a:prstGeom prst="line">
@@ -16058,7 +16109,7 @@
         </p:nvCxnSpPr>
         <p:spPr>
           <a:xfrm>
-            <a:off x="10012680" y="2221992"/>
+            <a:off x="9875520" y="2221992"/>
             <a:ext cx="0" cy="502920"/>
           </a:xfrm>
           <a:prstGeom prst="line">
@@ -16093,8 +16144,8 @@
         </p:nvCxnSpPr>
         <p:spPr>
           <a:xfrm flipH="1">
-            <a:off x="7086600" y="2971800"/>
-            <a:ext cx="457200" cy="0"/>
+            <a:off x="7040880" y="2971800"/>
+            <a:ext cx="411480" cy="0"/>
           </a:xfrm>
           <a:prstGeom prst="line">
             <a:avLst/>
@@ -16129,7 +16180,7 @@
         <p:spPr>
           <a:xfrm>
             <a:off x="8229600" y="2971800"/>
-            <a:ext cx="594360" cy="0"/>
+            <a:ext cx="411480" cy="0"/>
           </a:xfrm>
           <a:prstGeom prst="line">
             <a:avLst/>
@@ -16163,8 +16214,8 @@
         </p:nvCxnSpPr>
         <p:spPr>
           <a:xfrm>
-            <a:off x="7680960" y="3154680"/>
-            <a:ext cx="457200" cy="594359"/>
+            <a:off x="7635240" y="3154680"/>
+            <a:ext cx="411480" cy="594359"/>
           </a:xfrm>
           <a:prstGeom prst="line">
             <a:avLst/>
@@ -16198,8 +16249,8 @@
         </p:nvCxnSpPr>
         <p:spPr>
           <a:xfrm flipH="1">
-            <a:off x="8549640" y="3154680"/>
-            <a:ext cx="594360" cy="594359"/>
+            <a:off x="8503920" y="3154680"/>
+            <a:ext cx="548640" cy="594359"/>
           </a:xfrm>
           <a:prstGeom prst="line">
             <a:avLst/>
@@ -16377,7 +16428,7 @@
               </a:defRPr>
             </a:pPr>
             <a:r>
-              <a:t>Kafka 이벤트 기반으로 NOKIA 자동점검 측정 실시간 연동</a:t>
+              <a:t>Kafka 이벤트 기반 연동으로 자동점검 실시간성 확보</a:t>
             </a:r>
           </a:p>
         </p:txBody>
@@ -16429,51 +16480,53 @@
       </p:sp>
       <p:sp>
         <p:nvSpPr>
-          <p:cNvPr id="6" name="Rectangle 5"/>
-          <p:cNvSpPr/>
-          <p:nvPr/>
-        </p:nvSpPr>
-        <p:spPr>
-          <a:xfrm>
-            <a:off x="502920" y="1417320"/>
-            <a:ext cx="5029200" cy="347472"/>
-          </a:xfrm>
-          <a:prstGeom prst="rect">
+          <p:cNvPr id="6" name="Rounded Rectangle 5"/>
+          <p:cNvSpPr/>
+          <p:nvPr/>
+        </p:nvSpPr>
+        <p:spPr>
+          <a:xfrm>
+            <a:off x="640080" y="1527048"/>
+            <a:ext cx="1005840" cy="310896"/>
+          </a:xfrm>
+          <a:prstGeom prst="roundRect">
             <a:avLst/>
           </a:prstGeom>
           <a:solidFill>
             <a:srgbClr val="245CA5"/>
           </a:solidFill>
           <a:ln>
-            <a:noFill/>
-          </a:ln>
-        </p:spPr>
-        <p:style>
-          <a:lnRef idx="1">
-            <a:schemeClr val="accent1"/>
-          </a:lnRef>
-          <a:fillRef idx="3">
-            <a:schemeClr val="accent1"/>
-          </a:fillRef>
-          <a:effectRef idx="2">
-            <a:schemeClr val="accent1"/>
-          </a:effectRef>
-          <a:fontRef idx="minor">
-            <a:schemeClr val="lt1"/>
-          </a:fontRef>
-        </p:style>
-        <p:txBody>
-          <a:bodyPr rtlCol="0" anchor="ctr"/>
-          <a:lstStyle/>
-          <a:p>
-            <a:pPr algn="ctr"/>
-            <a:r>
-              <a:rPr sz="1200" b="1">
+            <a:solidFill>
+              <a:srgbClr val="245CA5"/>
+            </a:solidFill>
+          </a:ln>
+        </p:spPr>
+        <p:style>
+          <a:lnRef idx="1">
+            <a:schemeClr val="accent1"/>
+          </a:lnRef>
+          <a:fillRef idx="3">
+            <a:schemeClr val="accent1"/>
+          </a:fillRef>
+          <a:effectRef idx="2">
+            <a:schemeClr val="accent1"/>
+          </a:effectRef>
+          <a:fontRef idx="minor">
+            <a:schemeClr val="lt1"/>
+          </a:fontRef>
+        </p:style>
+        <p:txBody>
+          <a:bodyPr rtlCol="0" anchor="ctr"/>
+          <a:lstStyle/>
+          <a:p>
+            <a:pPr algn="ctr"/>
+            <a:r>
+              <a:rPr sz="1000" b="1">
                 <a:solidFill>
                   <a:srgbClr val="FFFFFF"/>
                 </a:solidFill>
               </a:rPr>
-              <a:t>핵심 기능</a:t>
+              <a:t>핵심</a:t>
             </a:r>
           </a:p>
         </p:txBody>
@@ -16486,8 +16539,8 @@
         </p:nvSpPr>
         <p:spPr>
           <a:xfrm>
-            <a:off x="667512" y="1856232"/>
-            <a:ext cx="4700016" cy="1527048"/>
+            <a:off x="667512" y="1965960"/>
+            <a:ext cx="4709160" cy="1399032"/>
           </a:xfrm>
           <a:prstGeom prst="rect">
             <a:avLst/>
@@ -16541,7 +16594,7 @@
               </a:defRPr>
             </a:pPr>
             <a:r>
-              <a:t>• SOR 포함 측정결과 저장과 화면 개선</a:t>
+              <a:t>• SOR 포함 측정결과 저장 및 화면 개선</a:t>
             </a:r>
           </a:p>
         </p:txBody>
@@ -16593,51 +16646,53 @@
       </p:sp>
       <p:sp>
         <p:nvSpPr>
-          <p:cNvPr id="9" name="Rectangle 8"/>
-          <p:cNvSpPr/>
-          <p:nvPr/>
-        </p:nvSpPr>
-        <p:spPr>
-          <a:xfrm>
-            <a:off x="502920" y="3657600"/>
-            <a:ext cx="5029200" cy="347472"/>
-          </a:xfrm>
-          <a:prstGeom prst="rect">
+          <p:cNvPr id="9" name="Rounded Rectangle 8"/>
+          <p:cNvSpPr/>
+          <p:nvPr/>
+        </p:nvSpPr>
+        <p:spPr>
+          <a:xfrm>
+            <a:off x="640080" y="3767328"/>
+            <a:ext cx="1005840" cy="310896"/>
+          </a:xfrm>
+          <a:prstGeom prst="roundRect">
             <a:avLst/>
           </a:prstGeom>
           <a:solidFill>
             <a:srgbClr val="7159C1"/>
           </a:solidFill>
           <a:ln>
-            <a:noFill/>
-          </a:ln>
-        </p:spPr>
-        <p:style>
-          <a:lnRef idx="1">
-            <a:schemeClr val="accent1"/>
-          </a:lnRef>
-          <a:fillRef idx="3">
-            <a:schemeClr val="accent1"/>
-          </a:fillRef>
-          <a:effectRef idx="2">
-            <a:schemeClr val="accent1"/>
-          </a:effectRef>
-          <a:fontRef idx="minor">
-            <a:schemeClr val="lt1"/>
-          </a:fontRef>
-        </p:style>
-        <p:txBody>
-          <a:bodyPr rtlCol="0" anchor="ctr"/>
-          <a:lstStyle/>
-          <a:p>
-            <a:pPr algn="ctr"/>
-            <a:r>
-              <a:rPr sz="1200" b="1">
+            <a:solidFill>
+              <a:srgbClr val="7159C1"/>
+            </a:solidFill>
+          </a:ln>
+        </p:spPr>
+        <p:style>
+          <a:lnRef idx="1">
+            <a:schemeClr val="accent1"/>
+          </a:lnRef>
+          <a:fillRef idx="3">
+            <a:schemeClr val="accent1"/>
+          </a:fillRef>
+          <a:effectRef idx="2">
+            <a:schemeClr val="accent1"/>
+          </a:effectRef>
+          <a:fontRef idx="minor">
+            <a:schemeClr val="lt1"/>
+          </a:fontRef>
+        </p:style>
+        <p:txBody>
+          <a:bodyPr rtlCol="0" anchor="ctr"/>
+          <a:lstStyle/>
+          <a:p>
+            <a:pPr algn="ctr"/>
+            <a:r>
+              <a:rPr sz="1000" b="1">
                 <a:solidFill>
                   <a:srgbClr val="FFFFFF"/>
                 </a:solidFill>
               </a:rPr>
-              <a:t>기대 효과</a:t>
+              <a:t>보강</a:t>
             </a:r>
           </a:p>
         </p:txBody>
@@ -16650,8 +16705,8 @@
         </p:nvSpPr>
         <p:spPr>
           <a:xfrm>
-            <a:off x="667512" y="4096512"/>
-            <a:ext cx="4700016" cy="1252728"/>
+            <a:off x="667512" y="4206240"/>
+            <a:ext cx="4709160" cy="1124712"/>
           </a:xfrm>
           <a:prstGeom prst="rect">
             <a:avLst/>
@@ -16740,7 +16795,7 @@
               </a:defRPr>
             </a:pPr>
             <a:r>
-              <a:t>기능 구조도</a:t>
+              <a:t>상세 구조도</a:t>
             </a:r>
           </a:p>
         </p:txBody>
@@ -16753,8 +16808,8 @@
         </p:nvSpPr>
         <p:spPr>
           <a:xfrm>
-            <a:off x="6309360" y="1783080"/>
-            <a:ext cx="1234440" cy="438912"/>
+            <a:off x="6217920" y="1783080"/>
+            <a:ext cx="1188720" cy="438912"/>
           </a:xfrm>
           <a:prstGeom prst="roundRect">
             <a:avLst/>
@@ -16788,7 +16843,7 @@
           <a:p>
             <a:pPr algn="ctr"/>
             <a:r>
-              <a:rPr sz="1200" b="1">
+              <a:rPr sz="1150" b="1">
                 <a:solidFill>
                   <a:srgbClr val="FFFFFF"/>
                 </a:solidFill>
@@ -16806,8 +16861,8 @@
         </p:nvSpPr>
         <p:spPr>
           <a:xfrm>
-            <a:off x="7818120" y="1783080"/>
-            <a:ext cx="1234440" cy="438912"/>
+            <a:off x="7680960" y="1783080"/>
+            <a:ext cx="1188720" cy="438912"/>
           </a:xfrm>
           <a:prstGeom prst="roundRect">
             <a:avLst/>
@@ -16841,7 +16896,7 @@
           <a:p>
             <a:pPr algn="ctr"/>
             <a:r>
-              <a:rPr sz="1200" b="1">
+              <a:rPr sz="1150" b="1">
                 <a:solidFill>
                   <a:srgbClr val="FFFFFF"/>
                 </a:solidFill>
@@ -16859,7 +16914,7 @@
         </p:nvSpPr>
         <p:spPr>
           <a:xfrm>
-            <a:off x="9326880" y="1783080"/>
+            <a:off x="9144000" y="1783080"/>
             <a:ext cx="1417320" cy="438912"/>
           </a:xfrm>
           <a:prstGeom prst="roundRect">
@@ -16894,7 +16949,7 @@
           <a:p>
             <a:pPr algn="ctr"/>
             <a:r>
-              <a:rPr sz="1200" b="1">
+              <a:rPr sz="1150" b="1">
                 <a:solidFill>
                   <a:srgbClr val="FFFFFF"/>
                 </a:solidFill>
@@ -16912,8 +16967,8 @@
         </p:nvSpPr>
         <p:spPr>
           <a:xfrm>
-            <a:off x="7086600" y="2743200"/>
-            <a:ext cx="1325880" cy="438912"/>
+            <a:off x="7040880" y="2743200"/>
+            <a:ext cx="1234440" cy="438912"/>
           </a:xfrm>
           <a:prstGeom prst="roundRect">
             <a:avLst/>
@@ -16947,7 +17002,7 @@
           <a:p>
             <a:pPr algn="ctr"/>
             <a:r>
-              <a:rPr sz="1200" b="1">
+              <a:rPr sz="1150" b="1">
                 <a:solidFill>
                   <a:srgbClr val="FFFFFF"/>
                 </a:solidFill>
@@ -16965,8 +17020,8 @@
         </p:nvSpPr>
         <p:spPr>
           <a:xfrm>
-            <a:off x="8823960" y="2743200"/>
-            <a:ext cx="1234440" cy="438912"/>
+            <a:off x="8686800" y="2743200"/>
+            <a:ext cx="1143000" cy="438912"/>
           </a:xfrm>
           <a:prstGeom prst="roundRect">
             <a:avLst/>
@@ -17000,7 +17055,7 @@
           <a:p>
             <a:pPr algn="ctr"/>
             <a:r>
-              <a:rPr sz="1200" b="1">
+              <a:rPr sz="1150" b="1">
                 <a:solidFill>
                   <a:srgbClr val="FFFFFF"/>
                 </a:solidFill>
@@ -17018,8 +17073,8 @@
         </p:nvSpPr>
         <p:spPr>
           <a:xfrm>
-            <a:off x="7818120" y="3749039"/>
-            <a:ext cx="1417320" cy="438912"/>
+            <a:off x="7772400" y="3749039"/>
+            <a:ext cx="1143000" cy="438912"/>
           </a:xfrm>
           <a:prstGeom prst="roundRect">
             <a:avLst/>
@@ -17053,12 +17108,12 @@
           <a:p>
             <a:pPr algn="ctr"/>
             <a:r>
-              <a:rPr sz="1200" b="1">
+              <a:rPr sz="1150" b="1">
                 <a:solidFill>
                   <a:srgbClr val="FFFFFF"/>
                 </a:solidFill>
               </a:rPr>
-              <a:t>자동점검 UI</a:t>
+              <a:t>조회 UI</a:t>
             </a:r>
           </a:p>
         </p:txBody>
@@ -17071,8 +17126,8 @@
         </p:nvCxnSpPr>
         <p:spPr>
           <a:xfrm>
-            <a:off x="7452360" y="2011680"/>
-            <a:ext cx="274319" cy="0"/>
+            <a:off x="7315200" y="2011680"/>
+            <a:ext cx="228600" cy="0"/>
           </a:xfrm>
           <a:prstGeom prst="line">
             <a:avLst/>
@@ -17106,7 +17161,7 @@
         </p:nvCxnSpPr>
         <p:spPr>
           <a:xfrm>
-            <a:off x="9052560" y="2011680"/>
+            <a:off x="8869680" y="2011680"/>
             <a:ext cx="274320" cy="0"/>
           </a:xfrm>
           <a:prstGeom prst="line">
@@ -17141,7 +17196,7 @@
         </p:nvCxnSpPr>
         <p:spPr>
           <a:xfrm>
-            <a:off x="8046720" y="2221992"/>
+            <a:off x="8001000" y="2221992"/>
             <a:ext cx="0" cy="502920"/>
           </a:xfrm>
           <a:prstGeom prst="line">
@@ -17176,7 +17231,7 @@
         </p:nvCxnSpPr>
         <p:spPr>
           <a:xfrm>
-            <a:off x="10012680" y="2221992"/>
+            <a:off x="9875520" y="2221992"/>
             <a:ext cx="0" cy="502920"/>
           </a:xfrm>
           <a:prstGeom prst="line">
@@ -17211,8 +17266,8 @@
         </p:nvCxnSpPr>
         <p:spPr>
           <a:xfrm flipH="1">
-            <a:off x="7086600" y="2971800"/>
-            <a:ext cx="457200" cy="0"/>
+            <a:off x="7040880" y="2971800"/>
+            <a:ext cx="411480" cy="0"/>
           </a:xfrm>
           <a:prstGeom prst="line">
             <a:avLst/>
@@ -17247,7 +17302,7 @@
         <p:spPr>
           <a:xfrm>
             <a:off x="8229600" y="2971800"/>
-            <a:ext cx="594360" cy="0"/>
+            <a:ext cx="411480" cy="0"/>
           </a:xfrm>
           <a:prstGeom prst="line">
             <a:avLst/>
@@ -17281,8 +17336,8 @@
         </p:nvCxnSpPr>
         <p:spPr>
           <a:xfrm>
-            <a:off x="7680960" y="3154680"/>
-            <a:ext cx="457200" cy="594359"/>
+            <a:off x="7635240" y="3154680"/>
+            <a:ext cx="411480" cy="594359"/>
           </a:xfrm>
           <a:prstGeom prst="line">
             <a:avLst/>
@@ -17316,8 +17371,8 @@
         </p:nvCxnSpPr>
         <p:spPr>
           <a:xfrm flipH="1">
-            <a:off x="8549640" y="3154680"/>
-            <a:ext cx="594360" cy="594359"/>
+            <a:off x="8503920" y="3154680"/>
+            <a:ext cx="548640" cy="594359"/>
           </a:xfrm>
           <a:prstGeom prst="line">
             <a:avLst/>
@@ -17495,7 +17550,7 @@
               </a:defRPr>
             </a:pPr>
             <a:r>
-              <a:t>Source Port 기준 거리 보정으로 Trace 그래프 정확도 향상</a:t>
+              <a:t>거리 보정 기반 Trace 정확도 향상과 운영 검증 편의성 강화</a:t>
             </a:r>
           </a:p>
         </p:txBody>
@@ -17547,51 +17602,53 @@
       </p:sp>
       <p:sp>
         <p:nvSpPr>
-          <p:cNvPr id="6" name="Rectangle 5"/>
-          <p:cNvSpPr/>
-          <p:nvPr/>
-        </p:nvSpPr>
-        <p:spPr>
-          <a:xfrm>
-            <a:off x="502920" y="1417320"/>
-            <a:ext cx="5029200" cy="347472"/>
-          </a:xfrm>
-          <a:prstGeom prst="rect">
+          <p:cNvPr id="6" name="Rounded Rectangle 5"/>
+          <p:cNvSpPr/>
+          <p:nvPr/>
+        </p:nvSpPr>
+        <p:spPr>
+          <a:xfrm>
+            <a:off x="640080" y="1527048"/>
+            <a:ext cx="1005840" cy="310896"/>
+          </a:xfrm>
+          <a:prstGeom prst="roundRect">
             <a:avLst/>
           </a:prstGeom>
           <a:solidFill>
             <a:srgbClr val="245CA5"/>
           </a:solidFill>
           <a:ln>
-            <a:noFill/>
-          </a:ln>
-        </p:spPr>
-        <p:style>
-          <a:lnRef idx="1">
-            <a:schemeClr val="accent1"/>
-          </a:lnRef>
-          <a:fillRef idx="3">
-            <a:schemeClr val="accent1"/>
-          </a:fillRef>
-          <a:effectRef idx="2">
-            <a:schemeClr val="accent1"/>
-          </a:effectRef>
-          <a:fontRef idx="minor">
-            <a:schemeClr val="lt1"/>
-          </a:fontRef>
-        </p:style>
-        <p:txBody>
-          <a:bodyPr rtlCol="0" anchor="ctr"/>
-          <a:lstStyle/>
-          <a:p>
-            <a:pPr algn="ctr"/>
-            <a:r>
-              <a:rPr sz="1200" b="1">
+            <a:solidFill>
+              <a:srgbClr val="245CA5"/>
+            </a:solidFill>
+          </a:ln>
+        </p:spPr>
+        <p:style>
+          <a:lnRef idx="1">
+            <a:schemeClr val="accent1"/>
+          </a:lnRef>
+          <a:fillRef idx="3">
+            <a:schemeClr val="accent1"/>
+          </a:fillRef>
+          <a:effectRef idx="2">
+            <a:schemeClr val="accent1"/>
+          </a:effectRef>
+          <a:fontRef idx="minor">
+            <a:schemeClr val="lt1"/>
+          </a:fontRef>
+        </p:style>
+        <p:txBody>
+          <a:bodyPr rtlCol="0" anchor="ctr"/>
+          <a:lstStyle/>
+          <a:p>
+            <a:pPr algn="ctr"/>
+            <a:r>
+              <a:rPr sz="1000" b="1">
                 <a:solidFill>
                   <a:srgbClr val="FFFFFF"/>
                 </a:solidFill>
               </a:rPr>
-              <a:t>핵심 기능</a:t>
+              <a:t>핵심</a:t>
             </a:r>
           </a:p>
         </p:txBody>
@@ -17604,8 +17661,8 @@
         </p:nvSpPr>
         <p:spPr>
           <a:xfrm>
-            <a:off x="667512" y="1856232"/>
-            <a:ext cx="4700016" cy="1527048"/>
+            <a:off x="667512" y="1965960"/>
+            <a:ext cx="4709160" cy="1399032"/>
           </a:xfrm>
           <a:prstGeom prst="rect">
             <a:avLst/>
@@ -17659,7 +17716,7 @@
               </a:defRPr>
             </a:pPr>
             <a:r>
-              <a:t>• 보정된 위치를 OTDR Trace 그래프에 표시</a:t>
+              <a:t>• 보정 위치를 OTDR Trace 그래프에 반영</a:t>
             </a:r>
           </a:p>
         </p:txBody>
@@ -17711,51 +17768,53 @@
       </p:sp>
       <p:sp>
         <p:nvSpPr>
-          <p:cNvPr id="9" name="Rectangle 8"/>
-          <p:cNvSpPr/>
-          <p:nvPr/>
-        </p:nvSpPr>
-        <p:spPr>
-          <a:xfrm>
-            <a:off x="502920" y="3657600"/>
-            <a:ext cx="5029200" cy="347472"/>
-          </a:xfrm>
-          <a:prstGeom prst="rect">
+          <p:cNvPr id="9" name="Rounded Rectangle 8"/>
+          <p:cNvSpPr/>
+          <p:nvPr/>
+        </p:nvSpPr>
+        <p:spPr>
+          <a:xfrm>
+            <a:off x="640080" y="3767328"/>
+            <a:ext cx="1005840" cy="310896"/>
+          </a:xfrm>
+          <a:prstGeom prst="roundRect">
             <a:avLst/>
           </a:prstGeom>
           <a:solidFill>
             <a:srgbClr val="7159C1"/>
           </a:solidFill>
           <a:ln>
-            <a:noFill/>
-          </a:ln>
-        </p:spPr>
-        <p:style>
-          <a:lnRef idx="1">
-            <a:schemeClr val="accent1"/>
-          </a:lnRef>
-          <a:fillRef idx="3">
-            <a:schemeClr val="accent1"/>
-          </a:fillRef>
-          <a:effectRef idx="2">
-            <a:schemeClr val="accent1"/>
-          </a:effectRef>
-          <a:fontRef idx="minor">
-            <a:schemeClr val="lt1"/>
-          </a:fontRef>
-        </p:style>
-        <p:txBody>
-          <a:bodyPr rtlCol="0" anchor="ctr"/>
-          <a:lstStyle/>
-          <a:p>
-            <a:pPr algn="ctr"/>
-            <a:r>
-              <a:rPr sz="1200" b="1">
+            <a:solidFill>
+              <a:srgbClr val="7159C1"/>
+            </a:solidFill>
+          </a:ln>
+        </p:spPr>
+        <p:style>
+          <a:lnRef idx="1">
+            <a:schemeClr val="accent1"/>
+          </a:lnRef>
+          <a:fillRef idx="3">
+            <a:schemeClr val="accent1"/>
+          </a:fillRef>
+          <a:effectRef idx="2">
+            <a:schemeClr val="accent1"/>
+          </a:effectRef>
+          <a:fontRef idx="minor">
+            <a:schemeClr val="lt1"/>
+          </a:fontRef>
+        </p:style>
+        <p:txBody>
+          <a:bodyPr rtlCol="0" anchor="ctr"/>
+          <a:lstStyle/>
+          <a:p>
+            <a:pPr algn="ctr"/>
+            <a:r>
+              <a:rPr sz="1000" b="1">
                 <a:solidFill>
                   <a:srgbClr val="FFFFFF"/>
                 </a:solidFill>
               </a:rPr>
-              <a:t>기대 효과</a:t>
+              <a:t>보강</a:t>
             </a:r>
           </a:p>
         </p:txBody>
@@ -17768,8 +17827,8 @@
         </p:nvSpPr>
         <p:spPr>
           <a:xfrm>
-            <a:off x="667512" y="4096512"/>
-            <a:ext cx="4700016" cy="1252728"/>
+            <a:off x="667512" y="4206240"/>
+            <a:ext cx="4709160" cy="1124712"/>
           </a:xfrm>
           <a:prstGeom prst="rect">
             <a:avLst/>
@@ -17793,7 +17852,7 @@
               </a:defRPr>
             </a:pPr>
             <a:r>
-              <a:t>• 실제 선로 거리와 그래프 정합성 향상</a:t>
+              <a:t>• 실제 선로 거리와 정합성 향상</a:t>
             </a:r>
           </a:p>
           <a:p>
@@ -17858,7 +17917,7 @@
               </a:defRPr>
             </a:pPr>
             <a:r>
-              <a:t>기능 구조도</a:t>
+              <a:t>상세 구조도</a:t>
             </a:r>
           </a:p>
         </p:txBody>
@@ -17871,8 +17930,8 @@
         </p:nvSpPr>
         <p:spPr>
           <a:xfrm>
-            <a:off x="6309360" y="1783080"/>
-            <a:ext cx="1143000" cy="438912"/>
+            <a:off x="6217920" y="1783080"/>
+            <a:ext cx="1097280" cy="438912"/>
           </a:xfrm>
           <a:prstGeom prst="roundRect">
             <a:avLst/>
@@ -17906,7 +17965,7 @@
           <a:p>
             <a:pPr algn="ctr"/>
             <a:r>
-              <a:rPr sz="1200" b="1">
+              <a:rPr sz="1150" b="1">
                 <a:solidFill>
                   <a:srgbClr val="FFFFFF"/>
                 </a:solidFill>
@@ -17924,8 +17983,8 @@
         </p:nvSpPr>
         <p:spPr>
           <a:xfrm>
-            <a:off x="7726679" y="1783080"/>
-            <a:ext cx="1234440" cy="438912"/>
+            <a:off x="7543800" y="1783080"/>
+            <a:ext cx="1188720" cy="438912"/>
           </a:xfrm>
           <a:prstGeom prst="roundRect">
             <a:avLst/>
@@ -17959,7 +18018,7 @@
           <a:p>
             <a:pPr algn="ctr"/>
             <a:r>
-              <a:rPr sz="1200" b="1">
+              <a:rPr sz="1150" b="1">
                 <a:solidFill>
                   <a:srgbClr val="FFFFFF"/>
                 </a:solidFill>
@@ -17977,8 +18036,8 @@
         </p:nvSpPr>
         <p:spPr>
           <a:xfrm>
-            <a:off x="9235440" y="1783080"/>
-            <a:ext cx="1143000" cy="438912"/>
+            <a:off x="9006840" y="1783080"/>
+            <a:ext cx="1097280" cy="438912"/>
           </a:xfrm>
           <a:prstGeom prst="roundRect">
             <a:avLst/>
@@ -18012,7 +18071,7 @@
           <a:p>
             <a:pPr algn="ctr"/>
             <a:r>
-              <a:rPr sz="1200" b="1">
+              <a:rPr sz="1150" b="1">
                 <a:solidFill>
                   <a:srgbClr val="FFFFFF"/>
                 </a:solidFill>
@@ -18030,8 +18089,8 @@
         </p:nvSpPr>
         <p:spPr>
           <a:xfrm>
-            <a:off x="7178040" y="2743200"/>
-            <a:ext cx="1234440" cy="438912"/>
+            <a:off x="6995160" y="2743200"/>
+            <a:ext cx="1188720" cy="438912"/>
           </a:xfrm>
           <a:prstGeom prst="roundRect">
             <a:avLst/>
@@ -18065,7 +18124,7 @@
           <a:p>
             <a:pPr algn="ctr"/>
             <a:r>
-              <a:rPr sz="1200" b="1">
+              <a:rPr sz="1150" b="1">
                 <a:solidFill>
                   <a:srgbClr val="FFFFFF"/>
                 </a:solidFill>
@@ -18083,8 +18142,8 @@
         </p:nvSpPr>
         <p:spPr>
           <a:xfrm>
-            <a:off x="8823960" y="2743200"/>
-            <a:ext cx="1234440" cy="438912"/>
+            <a:off x="8549640" y="2743200"/>
+            <a:ext cx="1188720" cy="438912"/>
           </a:xfrm>
           <a:prstGeom prst="roundRect">
             <a:avLst/>
@@ -18118,7 +18177,7 @@
           <a:p>
             <a:pPr algn="ctr"/>
             <a:r>
-              <a:rPr sz="1200" b="1">
+              <a:rPr sz="1150" b="1">
                 <a:solidFill>
                   <a:srgbClr val="FFFFFF"/>
                 </a:solidFill>
@@ -18136,7 +18195,7 @@
         </p:nvSpPr>
         <p:spPr>
           <a:xfrm>
-            <a:off x="7909560" y="3749039"/>
+            <a:off x="7635240" y="3749039"/>
             <a:ext cx="1417320" cy="438912"/>
           </a:xfrm>
           <a:prstGeom prst="roundRect">
@@ -18171,7 +18230,7 @@
           <a:p>
             <a:pPr algn="ctr"/>
             <a:r>
-              <a:rPr sz="1200" b="1">
+              <a:rPr sz="1150" b="1">
                 <a:solidFill>
                   <a:srgbClr val="FFFFFF"/>
                 </a:solidFill>
@@ -18189,8 +18248,8 @@
         </p:nvCxnSpPr>
         <p:spPr>
           <a:xfrm>
-            <a:off x="7452360" y="2011680"/>
-            <a:ext cx="274319" cy="0"/>
+            <a:off x="7315200" y="2011680"/>
+            <a:ext cx="228600" cy="0"/>
           </a:xfrm>
           <a:prstGeom prst="line">
             <a:avLst/>
@@ -18224,7 +18283,7 @@
         </p:nvCxnSpPr>
         <p:spPr>
           <a:xfrm>
-            <a:off x="9052560" y="2011680"/>
+            <a:off x="8869680" y="2011680"/>
             <a:ext cx="274320" cy="0"/>
           </a:xfrm>
           <a:prstGeom prst="line">
@@ -18259,7 +18318,7 @@
         </p:nvCxnSpPr>
         <p:spPr>
           <a:xfrm>
-            <a:off x="8046720" y="2221992"/>
+            <a:off x="8001000" y="2221992"/>
             <a:ext cx="0" cy="502920"/>
           </a:xfrm>
           <a:prstGeom prst="line">
@@ -18294,7 +18353,7 @@
         </p:nvCxnSpPr>
         <p:spPr>
           <a:xfrm>
-            <a:off x="10012680" y="2221992"/>
+            <a:off x="9875520" y="2221992"/>
             <a:ext cx="0" cy="502920"/>
           </a:xfrm>
           <a:prstGeom prst="line">
@@ -18329,8 +18388,8 @@
         </p:nvCxnSpPr>
         <p:spPr>
           <a:xfrm flipH="1">
-            <a:off x="7086600" y="2971800"/>
-            <a:ext cx="457200" cy="0"/>
+            <a:off x="7040880" y="2971800"/>
+            <a:ext cx="411480" cy="0"/>
           </a:xfrm>
           <a:prstGeom prst="line">
             <a:avLst/>
@@ -18365,7 +18424,7 @@
         <p:spPr>
           <a:xfrm>
             <a:off x="8229600" y="2971800"/>
-            <a:ext cx="594360" cy="0"/>
+            <a:ext cx="411480" cy="0"/>
           </a:xfrm>
           <a:prstGeom prst="line">
             <a:avLst/>
@@ -18399,8 +18458,8 @@
         </p:nvCxnSpPr>
         <p:spPr>
           <a:xfrm>
-            <a:off x="7680960" y="3154680"/>
-            <a:ext cx="457200" cy="594359"/>
+            <a:off x="7635240" y="3154680"/>
+            <a:ext cx="411480" cy="594359"/>
           </a:xfrm>
           <a:prstGeom prst="line">
             <a:avLst/>
@@ -18434,8 +18493,8 @@
         </p:nvCxnSpPr>
         <p:spPr>
           <a:xfrm flipH="1">
-            <a:off x="8549640" y="3154680"/>
-            <a:ext cx="594360" cy="594359"/>
+            <a:off x="8503920" y="3154680"/>
+            <a:ext cx="548640" cy="594359"/>
           </a:xfrm>
           <a:prstGeom prst="line">
             <a:avLst/>

</xml_diff>

<commit_message>
docs: unify schedule color in PPT
</commit_message>
<xml_diff>
--- a/output/SKT_OTDR_선로품질관리시스템_고도화_개발계획서_최종.pptx
+++ b/output/SKT_OTDR_선로품질관리시스템_고도화_개발계획서_최종.pptx
@@ -5486,7 +5486,7 @@
             <a:avLst/>
           </a:prstGeom>
           <a:solidFill>
-            <a:srgbClr val="4FA4E3"/>
+            <a:srgbClr val="245CA5"/>
           </a:solidFill>
           <a:ln>
             <a:solidFill>
@@ -5531,7 +5531,7 @@
             <a:avLst/>
           </a:prstGeom>
           <a:solidFill>
-            <a:srgbClr val="359961"/>
+            <a:srgbClr val="245CA5"/>
           </a:solidFill>
           <a:ln>
             <a:solidFill>
@@ -5576,7 +5576,7 @@
             <a:avLst/>
           </a:prstGeom>
           <a:solidFill>
-            <a:srgbClr val="7159C1"/>
+            <a:srgbClr val="245CA5"/>
           </a:solidFill>
           <a:ln>
             <a:solidFill>
@@ -5621,7 +5621,7 @@
             <a:avLst/>
           </a:prstGeom>
           <a:solidFill>
-            <a:srgbClr val="F4A142"/>
+            <a:srgbClr val="245CA5"/>
           </a:solidFill>
           <a:ln>
             <a:solidFill>
@@ -5666,7 +5666,7 @@
             <a:avLst/>
           </a:prstGeom>
           <a:solidFill>
-            <a:srgbClr val="D63F36"/>
+            <a:srgbClr val="245CA5"/>
           </a:solidFill>
           <a:ln>
             <a:solidFill>
@@ -5862,7 +5862,7 @@
             <a:avLst/>
           </a:prstGeom>
           <a:solidFill>
-            <a:srgbClr val="4FA4E3"/>
+            <a:srgbClr val="245CA5"/>
           </a:solidFill>
           <a:ln>
             <a:solidFill>
@@ -5907,7 +5907,7 @@
             <a:avLst/>
           </a:prstGeom>
           <a:solidFill>
-            <a:srgbClr val="359961"/>
+            <a:srgbClr val="245CA5"/>
           </a:solidFill>
           <a:ln>
             <a:solidFill>
@@ -5952,7 +5952,7 @@
             <a:avLst/>
           </a:prstGeom>
           <a:solidFill>
-            <a:srgbClr val="7159C1"/>
+            <a:srgbClr val="245CA5"/>
           </a:solidFill>
           <a:ln>
             <a:solidFill>
@@ -5997,7 +5997,7 @@
             <a:avLst/>
           </a:prstGeom>
           <a:solidFill>
-            <a:srgbClr val="F4A142"/>
+            <a:srgbClr val="245CA5"/>
           </a:solidFill>
           <a:ln>
             <a:solidFill>
@@ -6042,7 +6042,7 @@
             <a:avLst/>
           </a:prstGeom>
           <a:solidFill>
-            <a:srgbClr val="D63F36"/>
+            <a:srgbClr val="245CA5"/>
           </a:solidFill>
           <a:ln>
             <a:solidFill>
@@ -6238,7 +6238,7 @@
             <a:avLst/>
           </a:prstGeom>
           <a:solidFill>
-            <a:srgbClr val="4FA4E3"/>
+            <a:srgbClr val="245CA5"/>
           </a:solidFill>
           <a:ln>
             <a:solidFill>
@@ -6283,7 +6283,7 @@
             <a:avLst/>
           </a:prstGeom>
           <a:solidFill>
-            <a:srgbClr val="359961"/>
+            <a:srgbClr val="245CA5"/>
           </a:solidFill>
           <a:ln>
             <a:solidFill>
@@ -6328,7 +6328,7 @@
             <a:avLst/>
           </a:prstGeom>
           <a:solidFill>
-            <a:srgbClr val="7159C1"/>
+            <a:srgbClr val="245CA5"/>
           </a:solidFill>
           <a:ln>
             <a:solidFill>
@@ -6373,7 +6373,7 @@
             <a:avLst/>
           </a:prstGeom>
           <a:solidFill>
-            <a:srgbClr val="F4A142"/>
+            <a:srgbClr val="245CA5"/>
           </a:solidFill>
           <a:ln>
             <a:solidFill>
@@ -6418,7 +6418,7 @@
             <a:avLst/>
           </a:prstGeom>
           <a:solidFill>
-            <a:srgbClr val="D63F36"/>
+            <a:srgbClr val="245CA5"/>
           </a:solidFill>
           <a:ln>
             <a:solidFill>
@@ -6614,7 +6614,7 @@
             <a:avLst/>
           </a:prstGeom>
           <a:solidFill>
-            <a:srgbClr val="4FA4E3"/>
+            <a:srgbClr val="245CA5"/>
           </a:solidFill>
           <a:ln>
             <a:solidFill>
@@ -6659,7 +6659,7 @@
             <a:avLst/>
           </a:prstGeom>
           <a:solidFill>
-            <a:srgbClr val="359961"/>
+            <a:srgbClr val="245CA5"/>
           </a:solidFill>
           <a:ln>
             <a:solidFill>
@@ -6704,7 +6704,7 @@
             <a:avLst/>
           </a:prstGeom>
           <a:solidFill>
-            <a:srgbClr val="7159C1"/>
+            <a:srgbClr val="245CA5"/>
           </a:solidFill>
           <a:ln>
             <a:solidFill>
@@ -6749,7 +6749,7 @@
             <a:avLst/>
           </a:prstGeom>
           <a:solidFill>
-            <a:srgbClr val="F4A142"/>
+            <a:srgbClr val="245CA5"/>
           </a:solidFill>
           <a:ln>
             <a:solidFill>
@@ -6794,7 +6794,7 @@
             <a:avLst/>
           </a:prstGeom>
           <a:solidFill>
-            <a:srgbClr val="D63F36"/>
+            <a:srgbClr val="245CA5"/>
           </a:solidFill>
           <a:ln>
             <a:solidFill>
@@ -6990,7 +6990,7 @@
             <a:avLst/>
           </a:prstGeom>
           <a:solidFill>
-            <a:srgbClr val="4FA4E3"/>
+            <a:srgbClr val="245CA5"/>
           </a:solidFill>
           <a:ln>
             <a:solidFill>
@@ -7035,7 +7035,7 @@
             <a:avLst/>
           </a:prstGeom>
           <a:solidFill>
-            <a:srgbClr val="359961"/>
+            <a:srgbClr val="245CA5"/>
           </a:solidFill>
           <a:ln>
             <a:solidFill>
@@ -7080,7 +7080,7 @@
             <a:avLst/>
           </a:prstGeom>
           <a:solidFill>
-            <a:srgbClr val="7159C1"/>
+            <a:srgbClr val="245CA5"/>
           </a:solidFill>
           <a:ln>
             <a:solidFill>
@@ -7125,7 +7125,7 @@
             <a:avLst/>
           </a:prstGeom>
           <a:solidFill>
-            <a:srgbClr val="F4A142"/>
+            <a:srgbClr val="245CA5"/>
           </a:solidFill>
           <a:ln>
             <a:solidFill>
@@ -7170,7 +7170,7 @@
             <a:avLst/>
           </a:prstGeom>
           <a:solidFill>
-            <a:srgbClr val="D63F36"/>
+            <a:srgbClr val="245CA5"/>
           </a:solidFill>
           <a:ln>
             <a:solidFill>
@@ -7366,7 +7366,7 @@
             <a:avLst/>
           </a:prstGeom>
           <a:solidFill>
-            <a:srgbClr val="4FA4E3"/>
+            <a:srgbClr val="245CA5"/>
           </a:solidFill>
           <a:ln>
             <a:solidFill>
@@ -7411,7 +7411,7 @@
             <a:avLst/>
           </a:prstGeom>
           <a:solidFill>
-            <a:srgbClr val="359961"/>
+            <a:srgbClr val="245CA5"/>
           </a:solidFill>
           <a:ln>
             <a:solidFill>
@@ -7456,7 +7456,7 @@
             <a:avLst/>
           </a:prstGeom>
           <a:solidFill>
-            <a:srgbClr val="7159C1"/>
+            <a:srgbClr val="245CA5"/>
           </a:solidFill>
           <a:ln>
             <a:solidFill>
@@ -7501,7 +7501,7 @@
             <a:avLst/>
           </a:prstGeom>
           <a:solidFill>
-            <a:srgbClr val="F4A142"/>
+            <a:srgbClr val="245CA5"/>
           </a:solidFill>
           <a:ln>
             <a:solidFill>
@@ -7742,7 +7742,7 @@
             <a:avLst/>
           </a:prstGeom>
           <a:solidFill>
-            <a:srgbClr val="4FA4E3"/>
+            <a:srgbClr val="245CA5"/>
           </a:solidFill>
           <a:ln>
             <a:solidFill>
@@ -7787,7 +7787,7 @@
             <a:avLst/>
           </a:prstGeom>
           <a:solidFill>
-            <a:srgbClr val="359961"/>
+            <a:srgbClr val="245CA5"/>
           </a:solidFill>
           <a:ln>
             <a:solidFill>
@@ -7832,7 +7832,7 @@
             <a:avLst/>
           </a:prstGeom>
           <a:solidFill>
-            <a:srgbClr val="7159C1"/>
+            <a:srgbClr val="245CA5"/>
           </a:solidFill>
           <a:ln>
             <a:solidFill>
@@ -7877,7 +7877,7 @@
             <a:avLst/>
           </a:prstGeom>
           <a:solidFill>
-            <a:srgbClr val="F4A142"/>
+            <a:srgbClr val="245CA5"/>
           </a:solidFill>
           <a:ln>
             <a:solidFill>
@@ -7922,7 +7922,7 @@
             <a:avLst/>
           </a:prstGeom>
           <a:solidFill>
-            <a:srgbClr val="D63F36"/>
+            <a:srgbClr val="245CA5"/>
           </a:solidFill>
           <a:ln>
             <a:solidFill>
@@ -8118,7 +8118,7 @@
             <a:avLst/>
           </a:prstGeom>
           <a:solidFill>
-            <a:srgbClr val="4FA4E3"/>
+            <a:srgbClr val="245CA5"/>
           </a:solidFill>
           <a:ln>
             <a:solidFill>
@@ -8163,7 +8163,7 @@
             <a:avLst/>
           </a:prstGeom>
           <a:solidFill>
-            <a:srgbClr val="359961"/>
+            <a:srgbClr val="245CA5"/>
           </a:solidFill>
           <a:ln>
             <a:solidFill>
@@ -8208,7 +8208,7 @@
             <a:avLst/>
           </a:prstGeom>
           <a:solidFill>
-            <a:srgbClr val="7159C1"/>
+            <a:srgbClr val="245CA5"/>
           </a:solidFill>
           <a:ln>
             <a:solidFill>
@@ -8253,7 +8253,7 @@
             <a:avLst/>
           </a:prstGeom>
           <a:solidFill>
-            <a:srgbClr val="F4A142"/>
+            <a:srgbClr val="245CA5"/>
           </a:solidFill>
           <a:ln>
             <a:solidFill>
@@ -8298,7 +8298,7 @@
             <a:avLst/>
           </a:prstGeom>
           <a:solidFill>
-            <a:srgbClr val="D63F36"/>
+            <a:srgbClr val="245CA5"/>
           </a:solidFill>
           <a:ln>
             <a:solidFill>
@@ -8494,7 +8494,7 @@
             <a:avLst/>
           </a:prstGeom>
           <a:solidFill>
-            <a:srgbClr val="4FA4E3"/>
+            <a:srgbClr val="245CA5"/>
           </a:solidFill>
           <a:ln>
             <a:solidFill>
@@ -8539,7 +8539,7 @@
             <a:avLst/>
           </a:prstGeom>
           <a:solidFill>
-            <a:srgbClr val="359961"/>
+            <a:srgbClr val="245CA5"/>
           </a:solidFill>
           <a:ln>
             <a:solidFill>
@@ -8584,7 +8584,7 @@
             <a:avLst/>
           </a:prstGeom>
           <a:solidFill>
-            <a:srgbClr val="7159C1"/>
+            <a:srgbClr val="245CA5"/>
           </a:solidFill>
           <a:ln>
             <a:solidFill>
@@ -8870,7 +8870,7 @@
             <a:avLst/>
           </a:prstGeom>
           <a:solidFill>
-            <a:srgbClr val="4FA4E3"/>
+            <a:srgbClr val="245CA5"/>
           </a:solidFill>
           <a:ln>
             <a:solidFill>
@@ -8915,7 +8915,7 @@
             <a:avLst/>
           </a:prstGeom>
           <a:solidFill>
-            <a:srgbClr val="359961"/>
+            <a:srgbClr val="245CA5"/>
           </a:solidFill>
           <a:ln>
             <a:solidFill>
@@ -8960,7 +8960,7 @@
             <a:avLst/>
           </a:prstGeom>
           <a:solidFill>
-            <a:srgbClr val="7159C1"/>
+            <a:srgbClr val="245CA5"/>
           </a:solidFill>
           <a:ln>
             <a:solidFill>
@@ -9005,7 +9005,7 @@
             <a:avLst/>
           </a:prstGeom>
           <a:solidFill>
-            <a:srgbClr val="F4A142"/>
+            <a:srgbClr val="245CA5"/>
           </a:solidFill>
           <a:ln>
             <a:solidFill>
@@ -9246,7 +9246,7 @@
             <a:avLst/>
           </a:prstGeom>
           <a:solidFill>
-            <a:srgbClr val="4FA4E3"/>
+            <a:srgbClr val="245CA5"/>
           </a:solidFill>
           <a:ln>
             <a:solidFill>
@@ -9291,7 +9291,7 @@
             <a:avLst/>
           </a:prstGeom>
           <a:solidFill>
-            <a:srgbClr val="359961"/>
+            <a:srgbClr val="245CA5"/>
           </a:solidFill>
           <a:ln>
             <a:solidFill>
@@ -9336,7 +9336,7 @@
             <a:avLst/>
           </a:prstGeom>
           <a:solidFill>
-            <a:srgbClr val="7159C1"/>
+            <a:srgbClr val="245CA5"/>
           </a:solidFill>
           <a:ln>
             <a:solidFill>
@@ -9381,7 +9381,7 @@
             <a:avLst/>
           </a:prstGeom>
           <a:solidFill>
-            <a:srgbClr val="F4A142"/>
+            <a:srgbClr val="245CA5"/>
           </a:solidFill>
           <a:ln>
             <a:solidFill>
@@ -9426,7 +9426,7 @@
             <a:avLst/>
           </a:prstGeom>
           <a:solidFill>
-            <a:srgbClr val="D63F36"/>
+            <a:srgbClr val="245CA5"/>
           </a:solidFill>
           <a:ln>
             <a:solidFill>

</xml_diff>